<commit_message>
Separated boxplots and joined by "category"
</commit_message>
<xml_diff>
--- a/06_ppts/exploratory_analysis_figures_v3-CFB-CG.pptx
+++ b/06_ppts/exploratory_analysis_figures_v3-CFB-CG.pptx
@@ -25,8 +25,8 @@
     <p:sldId id="411" r:id="rId16"/>
     <p:sldId id="412" r:id="rId17"/>
     <p:sldId id="413" r:id="rId18"/>
-    <p:sldId id="414" r:id="rId19"/>
-    <p:sldId id="415" r:id="rId20"/>
+    <p:sldId id="417" r:id="rId19"/>
+    <p:sldId id="418" r:id="rId20"/>
   </p:sldIdLst>
   <p:sldSz cx="12192000" cy="6858000"/>
   <p:notesSz cx="6858000" cy="9144000"/>
@@ -140,53 +140,6 @@
 </p188:authorLst>
 </file>
 
-<file path=ppt/comments/modernComment_14F_36DED8AD.xml><?xml version="1.0" encoding="utf-8"?>
-<p188:cmLst xmlns:a="http://schemas.openxmlformats.org/drawingml/2006/main" xmlns:r="http://schemas.openxmlformats.org/officeDocument/2006/relationships" xmlns:p188="http://schemas.microsoft.com/office/powerpoint/2018/8/main">
-  <p188:cm id="{E72AF825-BE95-3241-AEA5-C9EEB621F435}" authorId="{9B18557D-7187-C966-2E91-CE8B6CF86FC3}" created="2025-05-02T12:23:10.993">
-    <pc:sldMkLst xmlns:pc="http://schemas.microsoft.com/office/powerpoint/2013/main/command">
-      <pc:docMk/>
-      <pc:sldMk cId="920574125" sldId="335"/>
-    </pc:sldMkLst>
-    <p188:replyLst>
-      <p188:reply id="{E26608CF-4E9D-4396-9053-190CB4A16447}" authorId="{DB4BCF0B-13A8-F3D9-5213-32840108FAB3}" created="2025-05-27T13:51:56.997">
-        <p188:txBody>
-          <a:bodyPr/>
-          <a:lstStyle/>
-          <a:p>
-            <a:r>
-              <a:rPr lang="es-ES"/>
-              <a:t>Paloma agrees! Maybe we could remove the sites list at the right, and include in a smaller map the distribution area of Pinus sylvestris, Pinus pinea and Abies alba?</a:t>
-            </a:r>
-          </a:p>
-        </p188:txBody>
-      </p188:reply>
-      <p188:reply id="{B860C380-96D0-6C42-937C-9DC0777E96D0}" authorId="{9B18557D-7187-C966-2E91-CE8B6CF86FC3}" created="2025-05-29T06:02:12.303">
-        <p188:txBody>
-          <a:bodyPr/>
-          <a:lstStyle/>
-          <a:p>
-            <a:r>
-              <a:rPr lang="en-US"/>
-              <a:t>I fully agree. Great idea with the distribution. Looking forward to the final figure. this will be beautiful</a:t>
-            </a:r>
-          </a:p>
-        </p188:txBody>
-      </p188:reply>
-    </p188:replyLst>
-    <p188:txBody>
-      <a:bodyPr/>
-      <a:lstStyle/>
-      <a:p>
-        <a:r>
-          <a:rPr lang="en-US"/>
-          <a:t>your first figure could be a map like this one I believe</a:t>
-        </a:r>
-      </a:p>
-    </p188:txBody>
-  </p188:cm>
-</p188:cmLst>
-</file>
-
 <file path=ppt/comments/modernComment_195_4CD3AFA7.xml><?xml version="1.0" encoding="utf-8"?>
 <p188:cmLst xmlns:a="http://schemas.openxmlformats.org/drawingml/2006/main" xmlns:r="http://schemas.openxmlformats.org/officeDocument/2006/relationships" xmlns:p188="http://schemas.microsoft.com/office/powerpoint/2018/8/main">
   <p188:cm id="{A04E7475-72AC-EF41-8DCE-78170E424C1C}" authorId="{9B18557D-7187-C966-2E91-CE8B6CF86FC3}" status="resolved" created="2025-05-29T06:12:45.195" complete="100000">
@@ -220,48 +173,6 @@
         <a:r>
           <a:rPr lang="en-US"/>
           <a:t>why not merge Obj 1 and Obj2 by saying that you investigate the intrinsik risk factors (size, competition...) and the observable responses (mentionned here)?</a:t>
-        </a:r>
-      </a:p>
-    </p188:txBody>
-  </p188:cm>
-  <p188:cm id="{9E6DA31E-3171-E849-9D13-216E00158302}" authorId="{9B18557D-7187-C966-2E91-CE8B6CF86FC3}" status="resolved" created="2025-05-29T06:14:26.530" complete="100000">
-    <ac:txMkLst xmlns:ac="http://schemas.microsoft.com/office/drawing/2013/main/command">
-      <pc:docMk xmlns:pc="http://schemas.microsoft.com/office/powerpoint/2013/main/command"/>
-      <pc:sldMk xmlns:pc="http://schemas.microsoft.com/office/powerpoint/2013/main/command" cId="1288941479" sldId="405"/>
-      <ac:spMk id="8" creationId="{5D2A598E-3271-64EB-5DA8-A70DDDCC8E1C}"/>
-      <ac:txMk cp="0" len="10">
-        <ac:context len="434" hash="1566757412"/>
-      </ac:txMk>
-    </ac:txMkLst>
-    <p188:pos x="2182893" y="481381"/>
-    <p188:txBody>
-      <a:bodyPr/>
-      <a:lstStyle/>
-      <a:p>
-        <a:r>
-          <a:rPr lang="en-US"/>
-          <a:t>but you dont measure senescence per se so you can't say that it is measured, same for transpiration. You need in the intro to say that these are indicators of transpiration and in the objectiive description you formulate it the otherway around : d13C (i.e., indicator of WUE)</a:t>
-        </a:r>
-      </a:p>
-    </p188:txBody>
-  </p188:cm>
-  <p188:cm id="{955AC656-0168-DB42-B262-221F64286C42}" authorId="{9B18557D-7187-C966-2E91-CE8B6CF86FC3}" status="resolved" created="2025-05-29T06:15:10.224" complete="100000">
-    <ac:txMkLst xmlns:ac="http://schemas.microsoft.com/office/drawing/2013/main/command">
-      <pc:docMk xmlns:pc="http://schemas.microsoft.com/office/powerpoint/2013/main/command"/>
-      <pc:sldMk xmlns:pc="http://schemas.microsoft.com/office/powerpoint/2013/main/command" cId="1288941479" sldId="405"/>
-      <ac:spMk id="8" creationId="{5D2A598E-3271-64EB-5DA8-A70DDDCC8E1C}"/>
-      <ac:txMk cp="244" len="7">
-        <ac:context len="434" hash="1566757412"/>
-      </ac:txMk>
-    </ac:txMkLst>
-    <p188:pos x="3731277" y="1822501"/>
-    <p188:txBody>
-      <a:bodyPr/>
-      <a:lstStyle/>
-      <a:p>
-        <a:r>
-          <a:rPr lang="en-US"/>
-          <a:t>d13C is rather an indicator of WUE than transpiration</a:t>
         </a:r>
       </a:p>
     </p188:txBody>
@@ -385,85 +296,6 @@
         <a:r>
           <a:rPr lang="en-US"/>
           <a:t>I though you said you can only do this in Pinus synvesltris? Then this hypotheses should rather be formulated like H1</a:t>
-        </a:r>
-      </a:p>
-    </p188:txBody>
-  </p188:cm>
-</p188:cmLst>
-</file>
-
-<file path=ppt/comments/modernComment_19D_E6C7FCE7.xml><?xml version="1.0" encoding="utf-8"?>
-<p188:cmLst xmlns:a="http://schemas.openxmlformats.org/drawingml/2006/main" xmlns:r="http://schemas.openxmlformats.org/officeDocument/2006/relationships" xmlns:p188="http://schemas.microsoft.com/office/powerpoint/2018/8/main">
-  <p188:cm id="{5FE692DE-1540-1749-8480-24406C1CE541}" authorId="{9B18557D-7187-C966-2E91-CE8B6CF86FC3}" created="2025-05-29T06:16:45.284">
-    <ac:deMkLst xmlns:ac="http://schemas.microsoft.com/office/drawing/2013/main/command">
-      <pc:docMk xmlns:pc="http://schemas.microsoft.com/office/powerpoint/2013/main/command"/>
-      <pc:sldMk xmlns:pc="http://schemas.microsoft.com/office/powerpoint/2013/main/command" cId="3871866087" sldId="413"/>
-      <ac:picMk id="6" creationId="{4A839B70-2AA1-A2D9-351F-FDAB6E029D6B}"/>
-    </ac:deMkLst>
-    <p188:txBody>
-      <a:bodyPr/>
-      <a:lstStyle/>
-      <a:p>
-        <a:r>
-          <a:rPr lang="en-US"/>
-          <a:t>cool figures! To show the overall effect you could consider having an insert in each figure that shows the mean of all declining vs. healthy trees across all species</a:t>
-        </a:r>
-      </a:p>
-    </p188:txBody>
-  </p188:cm>
-</p188:cmLst>
-</file>
-
-<file path=ppt/comments/modernComment_19E_E57EE501.xml><?xml version="1.0" encoding="utf-8"?>
-<p188:cmLst xmlns:a="http://schemas.openxmlformats.org/drawingml/2006/main" xmlns:r="http://schemas.openxmlformats.org/officeDocument/2006/relationships" xmlns:p188="http://schemas.microsoft.com/office/powerpoint/2018/8/main">
-  <p188:cm id="{B247A5EF-AB37-7F43-8EAF-889A767EE01B}" authorId="{9B18557D-7187-C966-2E91-CE8B6CF86FC3}" created="2025-05-29T06:19:32.086">
-    <ac:deMkLst xmlns:ac="http://schemas.microsoft.com/office/drawing/2013/main/command">
-      <pc:docMk xmlns:pc="http://schemas.microsoft.com/office/powerpoint/2013/main/command"/>
-      <pc:sldMk xmlns:pc="http://schemas.microsoft.com/office/powerpoint/2013/main/command" cId="3850298625" sldId="414"/>
-      <ac:picMk id="6" creationId="{A9F74993-0A4C-E813-363F-E0876843D936}"/>
-    </ac:deMkLst>
-    <p188:replyLst>
-      <p188:reply id="{BE2095AE-1EFF-D04B-B0E1-F3A138E8E7A3}" authorId="{9B18557D-7187-C966-2E91-CE8B6CF86FC3}" created="2025-05-29T06:20:48.533">
-        <p188:txBody>
-          <a:bodyPr/>
-          <a:lstStyle/>
-          <a:p>
-            <a:r>
-              <a:rPr lang="en-US"/>
-              <a:t>Also I would merge in 1 figure all the response vs. all the intrsinsik factors as you separated them in the objectives</a:t>
-            </a:r>
-          </a:p>
-        </p188:txBody>
-      </p188:reply>
-    </p188:replyLst>
-    <p188:txBody>
-      <a:bodyPr/>
-      <a:lstStyle/>
-      <a:p>
-        <a:r>
-          <a:rPr lang="en-US"/>
-          <a:t>here I would also suggest the same insert as before</a:t>
-        </a:r>
-      </a:p>
-    </p188:txBody>
-  </p188:cm>
-</p188:cmLst>
-</file>
-
-<file path=ppt/comments/modernComment_19F_7A1565F.xml><?xml version="1.0" encoding="utf-8"?>
-<p188:cmLst xmlns:a="http://schemas.openxmlformats.org/drawingml/2006/main" xmlns:r="http://schemas.openxmlformats.org/officeDocument/2006/relationships" xmlns:p188="http://schemas.microsoft.com/office/powerpoint/2018/8/main">
-  <p188:cm id="{FB4D4660-1684-B947-A52A-CBB020A8ADC9}" authorId="{9B18557D-7187-C966-2E91-CE8B6CF86FC3}" created="2025-05-29T06:21:38.773">
-    <pc:sldMkLst xmlns:pc="http://schemas.microsoft.com/office/powerpoint/2013/main/command">
-      <pc:docMk/>
-      <pc:sldMk cId="128013919" sldId="415"/>
-    </pc:sldMkLst>
-    <p188:txBody>
-      <a:bodyPr/>
-      <a:lstStyle/>
-      <a:p>
-        <a:r>
-          <a:rPr lang="en-US"/>
-          <a:t>I don't remember reading about resistance in the objectives and hypotheses. Make sure to add them as well</a:t>
         </a:r>
       </a:p>
     </p188:txBody>
@@ -553,7 +385,7 @@
           <a:p>
             <a:fld id="{B02983DD-E218-4F5B-97E6-73372FCDFB94}" type="datetimeFigureOut">
               <a:rPr lang="es-ES" smtClean="0"/>
-              <a:t>02/06/2025</a:t>
+              <a:t>10/06/2025</a:t>
             </a:fld>
             <a:endParaRPr lang="es-ES"/>
           </a:p>
@@ -1072,6 +904,222 @@
 </p:notes>
 </file>
 
+<file path=ppt/notesSlides/notesSlide4.xml><?xml version="1.0" encoding="utf-8"?>
+<p:notes xmlns:a="http://schemas.openxmlformats.org/drawingml/2006/main" xmlns:r="http://schemas.openxmlformats.org/officeDocument/2006/relationships" xmlns:p="http://schemas.openxmlformats.org/presentationml/2006/main">
+  <p:cSld>
+    <p:spTree>
+      <p:nvGrpSpPr>
+        <p:cNvPr id="1" name="">
+          <a:extLst>
+            <a:ext uri="{FF2B5EF4-FFF2-40B4-BE49-F238E27FC236}">
+              <a16:creationId xmlns:a16="http://schemas.microsoft.com/office/drawing/2014/main" id="{BA12C936-5A85-D26D-A1A2-3995F25E443D}"/>
+            </a:ext>
+          </a:extLst>
+        </p:cNvPr>
+        <p:cNvGrpSpPr/>
+        <p:nvPr/>
+      </p:nvGrpSpPr>
+      <p:grpSpPr>
+        <a:xfrm>
+          <a:off x="0" y="0"/>
+          <a:ext cx="0" cy="0"/>
+          <a:chOff x="0" y="0"/>
+          <a:chExt cx="0" cy="0"/>
+        </a:xfrm>
+      </p:grpSpPr>
+      <p:sp>
+        <p:nvSpPr>
+          <p:cNvPr id="2" name="Marcador de imagen de diapositiva 1">
+            <a:extLst>
+              <a:ext uri="{FF2B5EF4-FFF2-40B4-BE49-F238E27FC236}">
+                <a16:creationId xmlns:a16="http://schemas.microsoft.com/office/drawing/2014/main" id="{5DF41241-C527-0269-5349-925DD9211FAD}"/>
+              </a:ext>
+            </a:extLst>
+          </p:cNvPr>
+          <p:cNvSpPr>
+            <a:spLocks noGrp="1" noRot="1" noChangeAspect="1"/>
+          </p:cNvSpPr>
+          <p:nvPr>
+            <p:ph type="sldImg"/>
+          </p:nvPr>
+        </p:nvSpPr>
+        <p:spPr/>
+      </p:sp>
+      <p:sp>
+        <p:nvSpPr>
+          <p:cNvPr id="3" name="Marcador de notas 2">
+            <a:extLst>
+              <a:ext uri="{FF2B5EF4-FFF2-40B4-BE49-F238E27FC236}">
+                <a16:creationId xmlns:a16="http://schemas.microsoft.com/office/drawing/2014/main" id="{9F304C16-9142-9471-FF44-7379A61918F9}"/>
+              </a:ext>
+            </a:extLst>
+          </p:cNvPr>
+          <p:cNvSpPr>
+            <a:spLocks noGrp="1"/>
+          </p:cNvSpPr>
+          <p:nvPr>
+            <p:ph type="body" idx="1"/>
+          </p:nvPr>
+        </p:nvSpPr>
+        <p:spPr/>
+        <p:txBody>
+          <a:bodyPr/>
+          <a:lstStyle/>
+          <a:p>
+            <a:endParaRPr lang="es-ES" dirty="0"/>
+          </a:p>
+        </p:txBody>
+      </p:sp>
+      <p:sp>
+        <p:nvSpPr>
+          <p:cNvPr id="4" name="Marcador de número de diapositiva 3">
+            <a:extLst>
+              <a:ext uri="{FF2B5EF4-FFF2-40B4-BE49-F238E27FC236}">
+                <a16:creationId xmlns:a16="http://schemas.microsoft.com/office/drawing/2014/main" id="{49249B6E-84D0-BAF7-0235-37077C7C20A9}"/>
+              </a:ext>
+            </a:extLst>
+          </p:cNvPr>
+          <p:cNvSpPr>
+            <a:spLocks noGrp="1"/>
+          </p:cNvSpPr>
+          <p:nvPr>
+            <p:ph type="sldNum" sz="quarter" idx="5"/>
+          </p:nvPr>
+        </p:nvSpPr>
+        <p:spPr/>
+        <p:txBody>
+          <a:bodyPr/>
+          <a:lstStyle/>
+          <a:p>
+            <a:fld id="{95285FFF-AA8A-422F-901E-D94C39C8B224}" type="slidenum">
+              <a:rPr lang="es-ES" smtClean="0"/>
+              <a:t>18</a:t>
+            </a:fld>
+            <a:endParaRPr lang="es-ES"/>
+          </a:p>
+        </p:txBody>
+      </p:sp>
+    </p:spTree>
+    <p:extLst>
+      <p:ext uri="{BB962C8B-B14F-4D97-AF65-F5344CB8AC3E}">
+        <p14:creationId xmlns:p14="http://schemas.microsoft.com/office/powerpoint/2010/main" val="3854016901"/>
+      </p:ext>
+    </p:extLst>
+  </p:cSld>
+  <p:clrMapOvr>
+    <a:masterClrMapping/>
+  </p:clrMapOvr>
+</p:notes>
+</file>
+
+<file path=ppt/notesSlides/notesSlide5.xml><?xml version="1.0" encoding="utf-8"?>
+<p:notes xmlns:a="http://schemas.openxmlformats.org/drawingml/2006/main" xmlns:r="http://schemas.openxmlformats.org/officeDocument/2006/relationships" xmlns:p="http://schemas.openxmlformats.org/presentationml/2006/main">
+  <p:cSld>
+    <p:spTree>
+      <p:nvGrpSpPr>
+        <p:cNvPr id="1" name="">
+          <a:extLst>
+            <a:ext uri="{FF2B5EF4-FFF2-40B4-BE49-F238E27FC236}">
+              <a16:creationId xmlns:a16="http://schemas.microsoft.com/office/drawing/2014/main" id="{3440A726-8B60-9081-AB22-2ACFF82A3213}"/>
+            </a:ext>
+          </a:extLst>
+        </p:cNvPr>
+        <p:cNvGrpSpPr/>
+        <p:nvPr/>
+      </p:nvGrpSpPr>
+      <p:grpSpPr>
+        <a:xfrm>
+          <a:off x="0" y="0"/>
+          <a:ext cx="0" cy="0"/>
+          <a:chOff x="0" y="0"/>
+          <a:chExt cx="0" cy="0"/>
+        </a:xfrm>
+      </p:grpSpPr>
+      <p:sp>
+        <p:nvSpPr>
+          <p:cNvPr id="2" name="Marcador de imagen de diapositiva 1">
+            <a:extLst>
+              <a:ext uri="{FF2B5EF4-FFF2-40B4-BE49-F238E27FC236}">
+                <a16:creationId xmlns:a16="http://schemas.microsoft.com/office/drawing/2014/main" id="{750546EF-CD9D-6AF5-42AA-6256E4E21272}"/>
+              </a:ext>
+            </a:extLst>
+          </p:cNvPr>
+          <p:cNvSpPr>
+            <a:spLocks noGrp="1" noRot="1" noChangeAspect="1"/>
+          </p:cNvSpPr>
+          <p:nvPr>
+            <p:ph type="sldImg"/>
+          </p:nvPr>
+        </p:nvSpPr>
+        <p:spPr/>
+      </p:sp>
+      <p:sp>
+        <p:nvSpPr>
+          <p:cNvPr id="3" name="Marcador de notas 2">
+            <a:extLst>
+              <a:ext uri="{FF2B5EF4-FFF2-40B4-BE49-F238E27FC236}">
+                <a16:creationId xmlns:a16="http://schemas.microsoft.com/office/drawing/2014/main" id="{678122E8-E439-6B82-DA47-AC465F3A7253}"/>
+              </a:ext>
+            </a:extLst>
+          </p:cNvPr>
+          <p:cNvSpPr>
+            <a:spLocks noGrp="1"/>
+          </p:cNvSpPr>
+          <p:nvPr>
+            <p:ph type="body" idx="1"/>
+          </p:nvPr>
+        </p:nvSpPr>
+        <p:spPr/>
+        <p:txBody>
+          <a:bodyPr/>
+          <a:lstStyle/>
+          <a:p>
+            <a:endParaRPr lang="es-ES" dirty="0"/>
+          </a:p>
+        </p:txBody>
+      </p:sp>
+      <p:sp>
+        <p:nvSpPr>
+          <p:cNvPr id="4" name="Marcador de número de diapositiva 3">
+            <a:extLst>
+              <a:ext uri="{FF2B5EF4-FFF2-40B4-BE49-F238E27FC236}">
+                <a16:creationId xmlns:a16="http://schemas.microsoft.com/office/drawing/2014/main" id="{9915EA7E-2854-2B8E-0B30-689552412DDE}"/>
+              </a:ext>
+            </a:extLst>
+          </p:cNvPr>
+          <p:cNvSpPr>
+            <a:spLocks noGrp="1"/>
+          </p:cNvSpPr>
+          <p:nvPr>
+            <p:ph type="sldNum" sz="quarter" idx="5"/>
+          </p:nvPr>
+        </p:nvSpPr>
+        <p:spPr/>
+        <p:txBody>
+          <a:bodyPr/>
+          <a:lstStyle/>
+          <a:p>
+            <a:fld id="{95285FFF-AA8A-422F-901E-D94C39C8B224}" type="slidenum">
+              <a:rPr lang="es-ES" smtClean="0"/>
+              <a:t>19</a:t>
+            </a:fld>
+            <a:endParaRPr lang="es-ES"/>
+          </a:p>
+        </p:txBody>
+      </p:sp>
+    </p:spTree>
+    <p:extLst>
+      <p:ext uri="{BB962C8B-B14F-4D97-AF65-F5344CB8AC3E}">
+        <p14:creationId xmlns:p14="http://schemas.microsoft.com/office/powerpoint/2010/main" val="2778219967"/>
+      </p:ext>
+    </p:extLst>
+  </p:cSld>
+  <p:clrMapOvr>
+    <a:masterClrMapping/>
+  </p:clrMapOvr>
+</p:notes>
+</file>
+
 <file path=ppt/slideLayouts/slideLayout1.xml><?xml version="1.0" encoding="utf-8"?>
 <p:sldLayout xmlns:a="http://schemas.openxmlformats.org/drawingml/2006/main" xmlns:r="http://schemas.openxmlformats.org/officeDocument/2006/relationships" xmlns:p="http://schemas.openxmlformats.org/presentationml/2006/main" type="title" preserve="1">
   <p:cSld name="Diapositiva de título">
@@ -1219,7 +1267,7 @@
           <a:p>
             <a:fld id="{05302A3C-7F5D-464A-B794-A5CF9734955A}" type="datetimeFigureOut">
               <a:rPr lang="es-ES" smtClean="0"/>
-              <a:t>02/06/2025</a:t>
+              <a:t>10/06/2025</a:t>
             </a:fld>
             <a:endParaRPr lang="es-ES"/>
           </a:p>
@@ -1417,7 +1465,7 @@
           <a:p>
             <a:fld id="{05302A3C-7F5D-464A-B794-A5CF9734955A}" type="datetimeFigureOut">
               <a:rPr lang="es-ES" smtClean="0"/>
-              <a:t>02/06/2025</a:t>
+              <a:t>10/06/2025</a:t>
             </a:fld>
             <a:endParaRPr lang="es-ES"/>
           </a:p>
@@ -1625,7 +1673,7 @@
           <a:p>
             <a:fld id="{05302A3C-7F5D-464A-B794-A5CF9734955A}" type="datetimeFigureOut">
               <a:rPr lang="es-ES" smtClean="0"/>
-              <a:t>02/06/2025</a:t>
+              <a:t>10/06/2025</a:t>
             </a:fld>
             <a:endParaRPr lang="es-ES"/>
           </a:p>
@@ -1823,7 +1871,7 @@
           <a:p>
             <a:fld id="{05302A3C-7F5D-464A-B794-A5CF9734955A}" type="datetimeFigureOut">
               <a:rPr lang="es-ES" smtClean="0"/>
-              <a:t>02/06/2025</a:t>
+              <a:t>10/06/2025</a:t>
             </a:fld>
             <a:endParaRPr lang="es-ES"/>
           </a:p>
@@ -2098,7 +2146,7 @@
           <a:p>
             <a:fld id="{05302A3C-7F5D-464A-B794-A5CF9734955A}" type="datetimeFigureOut">
               <a:rPr lang="es-ES" smtClean="0"/>
-              <a:t>02/06/2025</a:t>
+              <a:t>10/06/2025</a:t>
             </a:fld>
             <a:endParaRPr lang="es-ES"/>
           </a:p>
@@ -2363,7 +2411,7 @@
           <a:p>
             <a:fld id="{05302A3C-7F5D-464A-B794-A5CF9734955A}" type="datetimeFigureOut">
               <a:rPr lang="es-ES" smtClean="0"/>
-              <a:t>02/06/2025</a:t>
+              <a:t>10/06/2025</a:t>
             </a:fld>
             <a:endParaRPr lang="es-ES"/>
           </a:p>
@@ -2775,7 +2823,7 @@
           <a:p>
             <a:fld id="{05302A3C-7F5D-464A-B794-A5CF9734955A}" type="datetimeFigureOut">
               <a:rPr lang="es-ES" smtClean="0"/>
-              <a:t>02/06/2025</a:t>
+              <a:t>10/06/2025</a:t>
             </a:fld>
             <a:endParaRPr lang="es-ES"/>
           </a:p>
@@ -2916,7 +2964,7 @@
           <a:p>
             <a:fld id="{05302A3C-7F5D-464A-B794-A5CF9734955A}" type="datetimeFigureOut">
               <a:rPr lang="es-ES" smtClean="0"/>
-              <a:t>02/06/2025</a:t>
+              <a:t>10/06/2025</a:t>
             </a:fld>
             <a:endParaRPr lang="es-ES"/>
           </a:p>
@@ -3029,7 +3077,7 @@
           <a:p>
             <a:fld id="{05302A3C-7F5D-464A-B794-A5CF9734955A}" type="datetimeFigureOut">
               <a:rPr lang="es-ES" smtClean="0"/>
-              <a:t>02/06/2025</a:t>
+              <a:t>10/06/2025</a:t>
             </a:fld>
             <a:endParaRPr lang="es-ES"/>
           </a:p>
@@ -3340,7 +3388,7 @@
           <a:p>
             <a:fld id="{05302A3C-7F5D-464A-B794-A5CF9734955A}" type="datetimeFigureOut">
               <a:rPr lang="es-ES" smtClean="0"/>
-              <a:t>02/06/2025</a:t>
+              <a:t>10/06/2025</a:t>
             </a:fld>
             <a:endParaRPr lang="es-ES"/>
           </a:p>
@@ -3628,7 +3676,7 @@
           <a:p>
             <a:fld id="{05302A3C-7F5D-464A-B794-A5CF9734955A}" type="datetimeFigureOut">
               <a:rPr lang="es-ES" smtClean="0"/>
-              <a:t>02/06/2025</a:t>
+              <a:t>10/06/2025</a:t>
             </a:fld>
             <a:endParaRPr lang="es-ES"/>
           </a:p>
@@ -3869,7 +3917,7 @@
           <a:p>
             <a:fld id="{05302A3C-7F5D-464A-B794-A5CF9734955A}" type="datetimeFigureOut">
               <a:rPr lang="es-ES" smtClean="0"/>
-              <a:t>02/06/2025</a:t>
+              <a:t>10/06/2025</a:t>
             </a:fld>
             <a:endParaRPr lang="es-ES"/>
           </a:p>
@@ -15968,41 +16016,6 @@
           </a:p>
         </p:txBody>
       </p:sp>
-      <p:pic>
-        <p:nvPicPr>
-          <p:cNvPr id="6" name="Imagen 5">
-            <a:extLst>
-              <a:ext uri="{FF2B5EF4-FFF2-40B4-BE49-F238E27FC236}">
-                <a16:creationId xmlns:a16="http://schemas.microsoft.com/office/drawing/2014/main" id="{4A839B70-2AA1-A2D9-351F-FDAB6E029D6B}"/>
-              </a:ext>
-            </a:extLst>
-          </p:cNvPr>
-          <p:cNvPicPr>
-            <a:picLocks noChangeAspect="1"/>
-          </p:cNvPicPr>
-          <p:nvPr/>
-        </p:nvPicPr>
-        <p:blipFill>
-          <a:blip r:embed="rId4">
-            <a:extLst>
-              <a:ext uri="{28A0092B-C50C-407E-A947-70E740481C1C}">
-                <a14:useLocalDpi xmlns:a14="http://schemas.microsoft.com/office/drawing/2010/main" val="0"/>
-              </a:ext>
-            </a:extLst>
-          </a:blip>
-          <a:srcRect b="75615"/>
-          <a:stretch/>
-        </p:blipFill>
-        <p:spPr>
-          <a:xfrm>
-            <a:off x="1285054" y="1070861"/>
-            <a:ext cx="9621891" cy="2607059"/>
-          </a:xfrm>
-          <a:prstGeom prst="rect">
-            <a:avLst/>
-          </a:prstGeom>
-        </p:spPr>
-      </p:pic>
       <p:sp>
         <p:nvSpPr>
           <p:cNvPr id="7" name="CuadroTexto 10">
@@ -16017,8 +16030,8 @@
         </p:nvSpPr>
         <p:spPr>
           <a:xfrm>
-            <a:off x="1483360" y="3677920"/>
-            <a:ext cx="2956560" cy="2308324"/>
+            <a:off x="1739812" y="3596455"/>
+            <a:ext cx="6111420" cy="1200329"/>
           </a:xfrm>
           <a:prstGeom prst="rect">
             <a:avLst/>
@@ -16152,6 +16165,69 @@
                 <a:latin typeface="Helvetica" panose="020B0604020202020204" pitchFamily="34" charset="0"/>
                 <a:cs typeface="Helvetica" panose="020B0604020202020204" pitchFamily="34" charset="0"/>
               </a:rPr>
+              <a:t> and </a:t>
+            </a:r>
+            <a:r>
+              <a:rPr lang="es-ES" b="1" dirty="0" err="1">
+                <a:latin typeface="Helvetica" panose="020B0604020202020204" pitchFamily="34" charset="0"/>
+                <a:cs typeface="Helvetica" panose="020B0604020202020204" pitchFamily="34" charset="0"/>
+              </a:rPr>
+              <a:t>d.b.h</a:t>
+            </a:r>
+            <a:r>
+              <a:rPr lang="es-ES" b="1" dirty="0">
+                <a:latin typeface="Helvetica" panose="020B0604020202020204" pitchFamily="34" charset="0"/>
+                <a:cs typeface="Helvetica" panose="020B0604020202020204" pitchFamily="34" charset="0"/>
+              </a:rPr>
+              <a:t>. </a:t>
+            </a:r>
+            <a:r>
+              <a:rPr lang="es-ES" dirty="0">
+                <a:latin typeface="Helvetica" panose="020B0604020202020204" pitchFamily="34" charset="0"/>
+                <a:cs typeface="Helvetica" panose="020B0604020202020204" pitchFamily="34" charset="0"/>
+              </a:rPr>
+              <a:t>are </a:t>
+            </a:r>
+            <a:r>
+              <a:rPr lang="es-ES" dirty="0" err="1">
+                <a:latin typeface="Helvetica" panose="020B0604020202020204" pitchFamily="34" charset="0"/>
+                <a:cs typeface="Helvetica" panose="020B0604020202020204" pitchFamily="34" charset="0"/>
+              </a:rPr>
+              <a:t>higher</a:t>
+            </a:r>
+            <a:r>
+              <a:rPr lang="es-ES" dirty="0">
+                <a:latin typeface="Helvetica" panose="020B0604020202020204" pitchFamily="34" charset="0"/>
+                <a:cs typeface="Helvetica" panose="020B0604020202020204" pitchFamily="34" charset="0"/>
+              </a:rPr>
+              <a:t> in non-</a:t>
+            </a:r>
+            <a:r>
+              <a:rPr lang="es-ES" dirty="0" err="1">
+                <a:latin typeface="Helvetica" panose="020B0604020202020204" pitchFamily="34" charset="0"/>
+                <a:cs typeface="Helvetica" panose="020B0604020202020204" pitchFamily="34" charset="0"/>
+              </a:rPr>
+              <a:t>declining</a:t>
+            </a:r>
+            <a:r>
+              <a:rPr lang="es-ES" dirty="0">
+                <a:latin typeface="Helvetica" panose="020B0604020202020204" pitchFamily="34" charset="0"/>
+                <a:cs typeface="Helvetica" panose="020B0604020202020204" pitchFamily="34" charset="0"/>
+              </a:rPr>
+              <a:t> sites in </a:t>
+            </a:r>
+            <a:r>
+              <a:rPr lang="es-ES" dirty="0" err="1">
+                <a:latin typeface="Helvetica" panose="020B0604020202020204" pitchFamily="34" charset="0"/>
+                <a:cs typeface="Helvetica" panose="020B0604020202020204" pitchFamily="34" charset="0"/>
+              </a:rPr>
+              <a:t>all</a:t>
+            </a:r>
+            <a:r>
+              <a:rPr lang="es-ES" dirty="0">
+                <a:latin typeface="Helvetica" panose="020B0604020202020204" pitchFamily="34" charset="0"/>
+                <a:cs typeface="Helvetica" panose="020B0604020202020204" pitchFamily="34" charset="0"/>
+              </a:rPr>
               <a:t> </a:t>
             </a:r>
             <a:r>
@@ -16159,83 +16235,37 @@
                 <a:latin typeface="Helvetica" panose="020B0604020202020204" pitchFamily="34" charset="0"/>
                 <a:cs typeface="Helvetica" panose="020B0604020202020204" pitchFamily="34" charset="0"/>
               </a:rPr>
-              <a:t>is</a:t>
+              <a:t>species</a:t>
             </a:r>
             <a:r>
               <a:rPr lang="es-ES" dirty="0">
                 <a:latin typeface="Helvetica" panose="020B0604020202020204" pitchFamily="34" charset="0"/>
                 <a:cs typeface="Helvetica" panose="020B0604020202020204" pitchFamily="34" charset="0"/>
               </a:rPr>
+              <a:t>.</a:t>
+            </a:r>
+          </a:p>
+          <a:p>
+            <a:pPr lvl="1" algn="ctr"/>
+            <a:r>
+              <a:rPr lang="es-ES" b="1" dirty="0" err="1">
+                <a:solidFill>
+                  <a:srgbClr val="FF0000"/>
+                </a:solidFill>
+                <a:latin typeface="Helvetica" panose="020B0604020202020204" pitchFamily="34" charset="0"/>
+                <a:cs typeface="Helvetica" panose="020B0604020202020204" pitchFamily="34" charset="0"/>
+              </a:rPr>
+              <a:t>Bigger</a:t>
+            </a:r>
+            <a:r>
+              <a:rPr lang="es-ES" b="1" dirty="0">
+                <a:solidFill>
+                  <a:srgbClr val="FF0000"/>
+                </a:solidFill>
+                <a:latin typeface="Helvetica" panose="020B0604020202020204" pitchFamily="34" charset="0"/>
+                <a:cs typeface="Helvetica" panose="020B0604020202020204" pitchFamily="34" charset="0"/>
+              </a:rPr>
               <a:t> </a:t>
-            </a:r>
-            <a:r>
-              <a:rPr lang="es-ES" dirty="0" err="1">
-                <a:latin typeface="Helvetica" panose="020B0604020202020204" pitchFamily="34" charset="0"/>
-                <a:cs typeface="Helvetica" panose="020B0604020202020204" pitchFamily="34" charset="0"/>
-              </a:rPr>
-              <a:t>higher</a:t>
-            </a:r>
-            <a:r>
-              <a:rPr lang="es-ES" dirty="0">
-                <a:latin typeface="Helvetica" panose="020B0604020202020204" pitchFamily="34" charset="0"/>
-                <a:cs typeface="Helvetica" panose="020B0604020202020204" pitchFamily="34" charset="0"/>
-              </a:rPr>
-              <a:t> in non-</a:t>
-            </a:r>
-            <a:r>
-              <a:rPr lang="es-ES" dirty="0" err="1">
-                <a:latin typeface="Helvetica" panose="020B0604020202020204" pitchFamily="34" charset="0"/>
-                <a:cs typeface="Helvetica" panose="020B0604020202020204" pitchFamily="34" charset="0"/>
-              </a:rPr>
-              <a:t>declining</a:t>
-            </a:r>
-            <a:r>
-              <a:rPr lang="es-ES" dirty="0">
-                <a:latin typeface="Helvetica" panose="020B0604020202020204" pitchFamily="34" charset="0"/>
-                <a:cs typeface="Helvetica" panose="020B0604020202020204" pitchFamily="34" charset="0"/>
-              </a:rPr>
-              <a:t> sites in </a:t>
-            </a:r>
-            <a:r>
-              <a:rPr lang="es-ES" dirty="0" err="1">
-                <a:latin typeface="Helvetica" panose="020B0604020202020204" pitchFamily="34" charset="0"/>
-                <a:cs typeface="Helvetica" panose="020B0604020202020204" pitchFamily="34" charset="0"/>
-              </a:rPr>
-              <a:t>all</a:t>
-            </a:r>
-            <a:r>
-              <a:rPr lang="es-ES" dirty="0">
-                <a:latin typeface="Helvetica" panose="020B0604020202020204" pitchFamily="34" charset="0"/>
-                <a:cs typeface="Helvetica" panose="020B0604020202020204" pitchFamily="34" charset="0"/>
-              </a:rPr>
-              <a:t> </a:t>
-            </a:r>
-            <a:r>
-              <a:rPr lang="es-ES" dirty="0" err="1">
-                <a:latin typeface="Helvetica" panose="020B0604020202020204" pitchFamily="34" charset="0"/>
-                <a:cs typeface="Helvetica" panose="020B0604020202020204" pitchFamily="34" charset="0"/>
-              </a:rPr>
-              <a:t>species</a:t>
-            </a:r>
-            <a:r>
-              <a:rPr lang="es-ES" dirty="0">
-                <a:latin typeface="Helvetica" panose="020B0604020202020204" pitchFamily="34" charset="0"/>
-                <a:cs typeface="Helvetica" panose="020B0604020202020204" pitchFamily="34" charset="0"/>
-              </a:rPr>
-              <a:t>.</a:t>
-            </a:r>
-          </a:p>
-          <a:p>
-            <a:pPr lvl="1" algn="ctr"/>
-            <a:r>
-              <a:rPr lang="es-ES" b="1" dirty="0">
-                <a:solidFill>
-                  <a:srgbClr val="FF0000"/>
-                </a:solidFill>
-                <a:latin typeface="Helvetica" panose="020B0604020202020204" pitchFamily="34" charset="0"/>
-                <a:cs typeface="Helvetica" panose="020B0604020202020204" pitchFamily="34" charset="0"/>
-              </a:rPr>
-              <a:t>Taller </a:t>
             </a:r>
             <a:r>
               <a:rPr lang="es-ES" b="1" dirty="0" err="1">
@@ -16420,272 +16450,6 @@
               <a:latin typeface="Helvetica" panose="020B0604020202020204" pitchFamily="34" charset="0"/>
               <a:cs typeface="Helvetica" panose="020B0604020202020204" pitchFamily="34" charset="0"/>
             </a:endParaRPr>
-          </a:p>
-        </p:txBody>
-      </p:sp>
-      <p:sp>
-        <p:nvSpPr>
-          <p:cNvPr id="9" name="CuadroTexto 10">
-            <a:extLst>
-              <a:ext uri="{FF2B5EF4-FFF2-40B4-BE49-F238E27FC236}">
-                <a16:creationId xmlns:a16="http://schemas.microsoft.com/office/drawing/2014/main" id="{68926A5D-6BF7-B942-F35A-54A3F22D891B}"/>
-              </a:ext>
-            </a:extLst>
-          </p:cNvPr>
-          <p:cNvSpPr txBox="1"/>
-          <p:nvPr/>
-        </p:nvSpPr>
-        <p:spPr>
-          <a:xfrm>
-            <a:off x="4795522" y="3677920"/>
-            <a:ext cx="2956560" cy="2031325"/>
-          </a:xfrm>
-          <a:prstGeom prst="rect">
-            <a:avLst/>
-          </a:prstGeom>
-          <a:noFill/>
-        </p:spPr>
-        <p:txBody>
-          <a:bodyPr wrap="square" rtlCol="0">
-            <a:spAutoFit/>
-          </a:bodyPr>
-          <a:lstStyle>
-            <a:defPPr>
-              <a:defRPr lang="es-ES"/>
-            </a:defPPr>
-            <a:lvl1pPr marL="0" algn="l" defTabSz="914400" rtl="0" eaLnBrk="1" latinLnBrk="0" hangingPunct="1">
-              <a:defRPr sz="1800" kern="1200">
-                <a:solidFill>
-                  <a:schemeClr val="tx1"/>
-                </a:solidFill>
-                <a:latin typeface="+mn-lt"/>
-                <a:ea typeface="+mn-ea"/>
-                <a:cs typeface="+mn-cs"/>
-              </a:defRPr>
-            </a:lvl1pPr>
-            <a:lvl2pPr marL="457200" algn="l" defTabSz="914400" rtl="0" eaLnBrk="1" latinLnBrk="0" hangingPunct="1">
-              <a:defRPr sz="1800" kern="1200">
-                <a:solidFill>
-                  <a:schemeClr val="tx1"/>
-                </a:solidFill>
-                <a:latin typeface="+mn-lt"/>
-                <a:ea typeface="+mn-ea"/>
-                <a:cs typeface="+mn-cs"/>
-              </a:defRPr>
-            </a:lvl2pPr>
-            <a:lvl3pPr marL="914400" algn="l" defTabSz="914400" rtl="0" eaLnBrk="1" latinLnBrk="0" hangingPunct="1">
-              <a:defRPr sz="1800" kern="1200">
-                <a:solidFill>
-                  <a:schemeClr val="tx1"/>
-                </a:solidFill>
-                <a:latin typeface="+mn-lt"/>
-                <a:ea typeface="+mn-ea"/>
-                <a:cs typeface="+mn-cs"/>
-              </a:defRPr>
-            </a:lvl3pPr>
-            <a:lvl4pPr marL="1371600" algn="l" defTabSz="914400" rtl="0" eaLnBrk="1" latinLnBrk="0" hangingPunct="1">
-              <a:defRPr sz="1800" kern="1200">
-                <a:solidFill>
-                  <a:schemeClr val="tx1"/>
-                </a:solidFill>
-                <a:latin typeface="+mn-lt"/>
-                <a:ea typeface="+mn-ea"/>
-                <a:cs typeface="+mn-cs"/>
-              </a:defRPr>
-            </a:lvl4pPr>
-            <a:lvl5pPr marL="1828800" algn="l" defTabSz="914400" rtl="0" eaLnBrk="1" latinLnBrk="0" hangingPunct="1">
-              <a:defRPr sz="1800" kern="1200">
-                <a:solidFill>
-                  <a:schemeClr val="tx1"/>
-                </a:solidFill>
-                <a:latin typeface="+mn-lt"/>
-                <a:ea typeface="+mn-ea"/>
-                <a:cs typeface="+mn-cs"/>
-              </a:defRPr>
-            </a:lvl5pPr>
-            <a:lvl6pPr marL="2286000" algn="l" defTabSz="914400" rtl="0" eaLnBrk="1" latinLnBrk="0" hangingPunct="1">
-              <a:defRPr sz="1800" kern="1200">
-                <a:solidFill>
-                  <a:schemeClr val="tx1"/>
-                </a:solidFill>
-                <a:latin typeface="+mn-lt"/>
-                <a:ea typeface="+mn-ea"/>
-                <a:cs typeface="+mn-cs"/>
-              </a:defRPr>
-            </a:lvl6pPr>
-            <a:lvl7pPr marL="2743200" algn="l" defTabSz="914400" rtl="0" eaLnBrk="1" latinLnBrk="0" hangingPunct="1">
-              <a:defRPr sz="1800" kern="1200">
-                <a:solidFill>
-                  <a:schemeClr val="tx1"/>
-                </a:solidFill>
-                <a:latin typeface="+mn-lt"/>
-                <a:ea typeface="+mn-ea"/>
-                <a:cs typeface="+mn-cs"/>
-              </a:defRPr>
-            </a:lvl7pPr>
-            <a:lvl8pPr marL="3200400" algn="l" defTabSz="914400" rtl="0" eaLnBrk="1" latinLnBrk="0" hangingPunct="1">
-              <a:defRPr sz="1800" kern="1200">
-                <a:solidFill>
-                  <a:schemeClr val="tx1"/>
-                </a:solidFill>
-                <a:latin typeface="+mn-lt"/>
-                <a:ea typeface="+mn-ea"/>
-                <a:cs typeface="+mn-cs"/>
-              </a:defRPr>
-            </a:lvl8pPr>
-            <a:lvl9pPr marL="3657600" algn="l" defTabSz="914400" rtl="0" eaLnBrk="1" latinLnBrk="0" hangingPunct="1">
-              <a:defRPr sz="1800" kern="1200">
-                <a:solidFill>
-                  <a:schemeClr val="tx1"/>
-                </a:solidFill>
-                <a:latin typeface="+mn-lt"/>
-                <a:ea typeface="+mn-ea"/>
-                <a:cs typeface="+mn-cs"/>
-              </a:defRPr>
-            </a:lvl9pPr>
-          </a:lstStyle>
-          <a:p>
-            <a:pPr lvl="1" algn="ctr"/>
-            <a:r>
-              <a:rPr lang="es-ES" b="1" dirty="0" err="1">
-                <a:latin typeface="Helvetica" panose="020B0604020202020204" pitchFamily="34" charset="0"/>
-                <a:cs typeface="Helvetica" panose="020B0604020202020204" pitchFamily="34" charset="0"/>
-              </a:rPr>
-              <a:t>Competition</a:t>
-            </a:r>
-            <a:r>
-              <a:rPr lang="es-ES" dirty="0">
-                <a:latin typeface="Helvetica" panose="020B0604020202020204" pitchFamily="34" charset="0"/>
-                <a:cs typeface="Helvetica" panose="020B0604020202020204" pitchFamily="34" charset="0"/>
-              </a:rPr>
-              <a:t> </a:t>
-            </a:r>
-            <a:r>
-              <a:rPr lang="es-ES" dirty="0" err="1">
-                <a:latin typeface="Helvetica" panose="020B0604020202020204" pitchFamily="34" charset="0"/>
-                <a:cs typeface="Helvetica" panose="020B0604020202020204" pitchFamily="34" charset="0"/>
-              </a:rPr>
-              <a:t>is</a:t>
-            </a:r>
-            <a:r>
-              <a:rPr lang="es-ES" dirty="0">
-                <a:latin typeface="Helvetica" panose="020B0604020202020204" pitchFamily="34" charset="0"/>
-                <a:cs typeface="Helvetica" panose="020B0604020202020204" pitchFamily="34" charset="0"/>
-              </a:rPr>
-              <a:t> more intense in </a:t>
-            </a:r>
-            <a:r>
-              <a:rPr lang="es-ES" dirty="0" err="1">
-                <a:latin typeface="Helvetica" panose="020B0604020202020204" pitchFamily="34" charset="0"/>
-                <a:cs typeface="Helvetica" panose="020B0604020202020204" pitchFamily="34" charset="0"/>
-              </a:rPr>
-              <a:t>declining</a:t>
-            </a:r>
-            <a:r>
-              <a:rPr lang="es-ES" dirty="0">
-                <a:latin typeface="Helvetica" panose="020B0604020202020204" pitchFamily="34" charset="0"/>
-                <a:cs typeface="Helvetica" panose="020B0604020202020204" pitchFamily="34" charset="0"/>
-              </a:rPr>
-              <a:t> sites. </a:t>
-            </a:r>
-            <a:r>
-              <a:rPr lang="es-ES" b="1" dirty="0" err="1">
-                <a:latin typeface="Helvetica" panose="020B0604020202020204" pitchFamily="34" charset="0"/>
-                <a:cs typeface="Helvetica" panose="020B0604020202020204" pitchFamily="34" charset="0"/>
-              </a:rPr>
-              <a:t>Denser</a:t>
-            </a:r>
-            <a:r>
-              <a:rPr lang="es-ES" b="1" dirty="0">
-                <a:latin typeface="Helvetica" panose="020B0604020202020204" pitchFamily="34" charset="0"/>
-                <a:cs typeface="Helvetica" panose="020B0604020202020204" pitchFamily="34" charset="0"/>
-              </a:rPr>
-              <a:t> stands </a:t>
-            </a:r>
-            <a:r>
-              <a:rPr lang="es-ES" dirty="0">
-                <a:latin typeface="Helvetica" panose="020B0604020202020204" pitchFamily="34" charset="0"/>
-                <a:cs typeface="Helvetica" panose="020B0604020202020204" pitchFamily="34" charset="0"/>
-              </a:rPr>
-              <a:t>are </a:t>
-            </a:r>
-            <a:r>
-              <a:rPr lang="es-ES" b="1" dirty="0">
-                <a:latin typeface="Helvetica" panose="020B0604020202020204" pitchFamily="34" charset="0"/>
-                <a:cs typeface="Helvetica" panose="020B0604020202020204" pitchFamily="34" charset="0"/>
-              </a:rPr>
-              <a:t>more vulnerable </a:t>
-            </a:r>
-            <a:r>
-              <a:rPr lang="es-ES" dirty="0" err="1">
-                <a:latin typeface="Helvetica" panose="020B0604020202020204" pitchFamily="34" charset="0"/>
-                <a:cs typeface="Helvetica" panose="020B0604020202020204" pitchFamily="34" charset="0"/>
-              </a:rPr>
-              <a:t>due</a:t>
-            </a:r>
-            <a:r>
-              <a:rPr lang="es-ES" dirty="0">
-                <a:latin typeface="Helvetica" panose="020B0604020202020204" pitchFamily="34" charset="0"/>
-                <a:cs typeface="Helvetica" panose="020B0604020202020204" pitchFamily="34" charset="0"/>
-              </a:rPr>
-              <a:t> </a:t>
-            </a:r>
-            <a:r>
-              <a:rPr lang="es-ES" dirty="0" err="1">
-                <a:latin typeface="Helvetica" panose="020B0604020202020204" pitchFamily="34" charset="0"/>
-                <a:cs typeface="Helvetica" panose="020B0604020202020204" pitchFamily="34" charset="0"/>
-              </a:rPr>
-              <a:t>limitting</a:t>
-            </a:r>
-            <a:r>
-              <a:rPr lang="es-ES" dirty="0">
-                <a:latin typeface="Helvetica" panose="020B0604020202020204" pitchFamily="34" charset="0"/>
-                <a:cs typeface="Helvetica" panose="020B0604020202020204" pitchFamily="34" charset="0"/>
-              </a:rPr>
-              <a:t> </a:t>
-            </a:r>
-            <a:r>
-              <a:rPr lang="es-ES" dirty="0" err="1">
-                <a:latin typeface="Helvetica" panose="020B0604020202020204" pitchFamily="34" charset="0"/>
-                <a:cs typeface="Helvetica" panose="020B0604020202020204" pitchFamily="34" charset="0"/>
-              </a:rPr>
-              <a:t>water</a:t>
-            </a:r>
-            <a:r>
-              <a:rPr lang="es-ES" dirty="0">
-                <a:latin typeface="Helvetica" panose="020B0604020202020204" pitchFamily="34" charset="0"/>
-                <a:cs typeface="Helvetica" panose="020B0604020202020204" pitchFamily="34" charset="0"/>
-              </a:rPr>
-              <a:t> and </a:t>
-            </a:r>
-            <a:r>
-              <a:rPr lang="es-ES" dirty="0" err="1">
-                <a:latin typeface="Helvetica" panose="020B0604020202020204" pitchFamily="34" charset="0"/>
-                <a:cs typeface="Helvetica" panose="020B0604020202020204" pitchFamily="34" charset="0"/>
-              </a:rPr>
-              <a:t>nutrients</a:t>
-            </a:r>
-            <a:r>
-              <a:rPr lang="es-ES" dirty="0">
-                <a:latin typeface="Helvetica" panose="020B0604020202020204" pitchFamily="34" charset="0"/>
-                <a:cs typeface="Helvetica" panose="020B0604020202020204" pitchFamily="34" charset="0"/>
-              </a:rPr>
-              <a:t> </a:t>
-            </a:r>
-            <a:r>
-              <a:rPr lang="es-ES" dirty="0" err="1">
-                <a:latin typeface="Helvetica" panose="020B0604020202020204" pitchFamily="34" charset="0"/>
-                <a:cs typeface="Helvetica" panose="020B0604020202020204" pitchFamily="34" charset="0"/>
-              </a:rPr>
-              <a:t>availability</a:t>
-            </a:r>
-            <a:r>
-              <a:rPr lang="es-ES" dirty="0">
-                <a:latin typeface="Helvetica" panose="020B0604020202020204" pitchFamily="34" charset="0"/>
-                <a:cs typeface="Helvetica" panose="020B0604020202020204" pitchFamily="34" charset="0"/>
-              </a:rPr>
-              <a:t> per individual</a:t>
-            </a:r>
           </a:p>
         </p:txBody>
       </p:sp>
@@ -17081,7 +16845,7 @@
         </p:nvSpPr>
         <p:spPr>
           <a:xfrm>
-            <a:off x="129540" y="6100313"/>
+            <a:off x="1963422" y="4837516"/>
             <a:ext cx="5664199" cy="369332"/>
           </a:xfrm>
           <a:prstGeom prst="rect">
@@ -17297,6 +17061,43 @@
           </a:p>
         </p:txBody>
       </p:sp>
+      <p:pic>
+        <p:nvPicPr>
+          <p:cNvPr id="11" name="Imagen 10">
+            <a:extLst>
+              <a:ext uri="{FF2B5EF4-FFF2-40B4-BE49-F238E27FC236}">
+                <a16:creationId xmlns:a16="http://schemas.microsoft.com/office/drawing/2014/main" id="{BA3090E5-3344-7682-8401-8E6E1FBDFAD7}"/>
+              </a:ext>
+            </a:extLst>
+          </p:cNvPr>
+          <p:cNvPicPr>
+            <a:picLocks noChangeAspect="1"/>
+          </p:cNvPicPr>
+          <p:nvPr/>
+        </p:nvPicPr>
+        <p:blipFill>
+          <a:blip r:embed="rId3">
+            <a:extLst>
+              <a:ext uri="{28A0092B-C50C-407E-A947-70E740481C1C}">
+                <a14:useLocalDpi xmlns:a14="http://schemas.microsoft.com/office/drawing/2010/main" val="0"/>
+              </a:ext>
+            </a:extLst>
+          </a:blip>
+          <a:srcRect r="21514"/>
+          <a:stretch>
+            <a:fillRect/>
+          </a:stretch>
+        </p:blipFill>
+        <p:spPr>
+          <a:xfrm>
+            <a:off x="1489310" y="1125916"/>
+            <a:ext cx="9568983" cy="2437935"/>
+          </a:xfrm>
+          <a:prstGeom prst="rect">
+            <a:avLst/>
+          </a:prstGeom>
+        </p:spPr>
+      </p:pic>
     </p:spTree>
     <p:extLst>
       <p:ext uri="{BB962C8B-B14F-4D97-AF65-F5344CB8AC3E}">
@@ -17307,11 +17108,6 @@
   <p:clrMapOvr>
     <a:masterClrMapping/>
   </p:clrMapOvr>
-  <p:extLst>
-    <p:ext uri="{6950BFC3-D8DA-4A85-94F7-54DA5524770B}">
-      <p188:commentRel xmlns:p188="http://schemas.microsoft.com/office/powerpoint/2018/8/main" r:id="rId3"/>
-    </p:ext>
-  </p:extLst>
 </p:sld>
 </file>
 
@@ -17323,7 +17119,7 @@
         <p:cNvPr id="1" name="">
           <a:extLst>
             <a:ext uri="{FF2B5EF4-FFF2-40B4-BE49-F238E27FC236}">
-              <a16:creationId xmlns:a16="http://schemas.microsoft.com/office/drawing/2014/main" id="{F94D8D41-657E-4FC9-863A-C46F9A7BA03A}"/>
+              <a16:creationId xmlns:a16="http://schemas.microsoft.com/office/drawing/2014/main" id="{4B7BB3F3-3AA3-1A33-1327-48FE2BC9AE3B}"/>
             </a:ext>
           </a:extLst>
         </p:cNvPr>
@@ -17343,7 +17139,7 @@
           <p:cNvPr id="3" name="Rectangle 1">
             <a:extLst>
               <a:ext uri="{FF2B5EF4-FFF2-40B4-BE49-F238E27FC236}">
-                <a16:creationId xmlns:a16="http://schemas.microsoft.com/office/drawing/2014/main" id="{706FCF1C-553F-1FAF-CC23-00699FA08473}"/>
+                <a16:creationId xmlns:a16="http://schemas.microsoft.com/office/drawing/2014/main" id="{F9D7B8CA-CD6C-C18E-3E03-319F19470422}"/>
               </a:ext>
             </a:extLst>
           </p:cNvPr>
@@ -17605,7 +17401,7 @@
           <p:cNvPr id="2" name="Título 1">
             <a:extLst>
               <a:ext uri="{FF2B5EF4-FFF2-40B4-BE49-F238E27FC236}">
-                <a16:creationId xmlns:a16="http://schemas.microsoft.com/office/drawing/2014/main" id="{CE9D40A1-2403-322F-D2A4-4B2657D8B9E6}"/>
+                <a16:creationId xmlns:a16="http://schemas.microsoft.com/office/drawing/2014/main" id="{DD3F8DC2-F439-732C-6ABC-DF331931459C}"/>
               </a:ext>
             </a:extLst>
           </p:cNvPr>
@@ -17686,7 +17482,7 @@
           <p:cNvPr id="8" name="Título 1">
             <a:extLst>
               <a:ext uri="{FF2B5EF4-FFF2-40B4-BE49-F238E27FC236}">
-                <a16:creationId xmlns:a16="http://schemas.microsoft.com/office/drawing/2014/main" id="{D7B4279A-D5B6-73C3-7955-EFED977C3629}"/>
+                <a16:creationId xmlns:a16="http://schemas.microsoft.com/office/drawing/2014/main" id="{49FFA1FA-24B2-07BA-7DCC-6DA1633359EB}"/>
               </a:ext>
             </a:extLst>
           </p:cNvPr>
@@ -17760,10 +17556,10 @@
       </p:sp>
       <p:pic>
         <p:nvPicPr>
-          <p:cNvPr id="6" name="Imagen 5">
+          <p:cNvPr id="5" name="Imagen 4">
             <a:extLst>
               <a:ext uri="{FF2B5EF4-FFF2-40B4-BE49-F238E27FC236}">
-                <a16:creationId xmlns:a16="http://schemas.microsoft.com/office/drawing/2014/main" id="{A9F74993-0A4C-E813-363F-E0876843D936}"/>
+                <a16:creationId xmlns:a16="http://schemas.microsoft.com/office/drawing/2014/main" id="{D7E0C2BF-7E7C-0CAB-43B1-B4D031CD3036}"/>
               </a:ext>
             </a:extLst>
           </p:cNvPr>
@@ -17780,13 +17576,15 @@
               </a:ext>
             </a:extLst>
           </a:blip>
-          <a:srcRect t="24665" r="32788" b="50950"/>
-          <a:stretch/>
+          <a:srcRect r="28540"/>
+          <a:stretch>
+            <a:fillRect/>
+          </a:stretch>
         </p:blipFill>
         <p:spPr>
           <a:xfrm>
-            <a:off x="1285055" y="1070861"/>
-            <a:ext cx="6467028" cy="2607059"/>
+            <a:off x="1536612" y="1058155"/>
+            <a:ext cx="8712376" cy="3047516"/>
           </a:xfrm>
           <a:prstGeom prst="rect">
             <a:avLst/>
@@ -17795,10 +17593,10 @@
       </p:pic>
       <p:sp>
         <p:nvSpPr>
-          <p:cNvPr id="7" name="CuadroTexto 10">
+          <p:cNvPr id="6" name="CuadroTexto 10">
             <a:extLst>
               <a:ext uri="{FF2B5EF4-FFF2-40B4-BE49-F238E27FC236}">
-                <a16:creationId xmlns:a16="http://schemas.microsoft.com/office/drawing/2014/main" id="{EB3398C9-D8A7-FCC2-EBA7-93E4556645A1}"/>
+                <a16:creationId xmlns:a16="http://schemas.microsoft.com/office/drawing/2014/main" id="{D83437F7-F8D1-4EBF-37B6-07B5C8A7D181}"/>
               </a:ext>
             </a:extLst>
           </p:cNvPr>
@@ -17807,7 +17605,7 @@
         </p:nvSpPr>
         <p:spPr>
           <a:xfrm>
-            <a:off x="1483360" y="3677920"/>
+            <a:off x="5288915" y="4105671"/>
             <a:ext cx="2956560" cy="1754326"/>
           </a:xfrm>
           <a:prstGeom prst="rect">
@@ -18177,7 +17975,7 @@
           <p:cNvPr id="9" name="CuadroTexto 10">
             <a:extLst>
               <a:ext uri="{FF2B5EF4-FFF2-40B4-BE49-F238E27FC236}">
-                <a16:creationId xmlns:a16="http://schemas.microsoft.com/office/drawing/2014/main" id="{99523C24-29E5-5604-C068-291A939F8009}"/>
+                <a16:creationId xmlns:a16="http://schemas.microsoft.com/office/drawing/2014/main" id="{C82EAB7D-F378-7BA4-9A88-AC54DB8D51F1}"/>
               </a:ext>
             </a:extLst>
           </p:cNvPr>
@@ -18186,7 +17984,426 @@
         </p:nvSpPr>
         <p:spPr>
           <a:xfrm>
-            <a:off x="4795522" y="3677920"/>
+            <a:off x="4026703" y="5903083"/>
+            <a:ext cx="5664199" cy="369332"/>
+          </a:xfrm>
+          <a:prstGeom prst="rect">
+            <a:avLst/>
+          </a:prstGeom>
+          <a:noFill/>
+        </p:spPr>
+        <p:txBody>
+          <a:bodyPr wrap="square" rtlCol="0">
+            <a:spAutoFit/>
+          </a:bodyPr>
+          <a:lstStyle>
+            <a:defPPr>
+              <a:defRPr lang="es-ES"/>
+            </a:defPPr>
+            <a:lvl1pPr marL="0" algn="l" defTabSz="914400" rtl="0" eaLnBrk="1" latinLnBrk="0" hangingPunct="1">
+              <a:defRPr sz="1800" kern="1200">
+                <a:solidFill>
+                  <a:schemeClr val="tx1"/>
+                </a:solidFill>
+                <a:latin typeface="+mn-lt"/>
+                <a:ea typeface="+mn-ea"/>
+                <a:cs typeface="+mn-cs"/>
+              </a:defRPr>
+            </a:lvl1pPr>
+            <a:lvl2pPr marL="457200" algn="l" defTabSz="914400" rtl="0" eaLnBrk="1" latinLnBrk="0" hangingPunct="1">
+              <a:defRPr sz="1800" kern="1200">
+                <a:solidFill>
+                  <a:schemeClr val="tx1"/>
+                </a:solidFill>
+                <a:latin typeface="+mn-lt"/>
+                <a:ea typeface="+mn-ea"/>
+                <a:cs typeface="+mn-cs"/>
+              </a:defRPr>
+            </a:lvl2pPr>
+            <a:lvl3pPr marL="914400" algn="l" defTabSz="914400" rtl="0" eaLnBrk="1" latinLnBrk="0" hangingPunct="1">
+              <a:defRPr sz="1800" kern="1200">
+                <a:solidFill>
+                  <a:schemeClr val="tx1"/>
+                </a:solidFill>
+                <a:latin typeface="+mn-lt"/>
+                <a:ea typeface="+mn-ea"/>
+                <a:cs typeface="+mn-cs"/>
+              </a:defRPr>
+            </a:lvl3pPr>
+            <a:lvl4pPr marL="1371600" algn="l" defTabSz="914400" rtl="0" eaLnBrk="1" latinLnBrk="0" hangingPunct="1">
+              <a:defRPr sz="1800" kern="1200">
+                <a:solidFill>
+                  <a:schemeClr val="tx1"/>
+                </a:solidFill>
+                <a:latin typeface="+mn-lt"/>
+                <a:ea typeface="+mn-ea"/>
+                <a:cs typeface="+mn-cs"/>
+              </a:defRPr>
+            </a:lvl4pPr>
+            <a:lvl5pPr marL="1828800" algn="l" defTabSz="914400" rtl="0" eaLnBrk="1" latinLnBrk="0" hangingPunct="1">
+              <a:defRPr sz="1800" kern="1200">
+                <a:solidFill>
+                  <a:schemeClr val="tx1"/>
+                </a:solidFill>
+                <a:latin typeface="+mn-lt"/>
+                <a:ea typeface="+mn-ea"/>
+                <a:cs typeface="+mn-cs"/>
+              </a:defRPr>
+            </a:lvl5pPr>
+            <a:lvl6pPr marL="2286000" algn="l" defTabSz="914400" rtl="0" eaLnBrk="1" latinLnBrk="0" hangingPunct="1">
+              <a:defRPr sz="1800" kern="1200">
+                <a:solidFill>
+                  <a:schemeClr val="tx1"/>
+                </a:solidFill>
+                <a:latin typeface="+mn-lt"/>
+                <a:ea typeface="+mn-ea"/>
+                <a:cs typeface="+mn-cs"/>
+              </a:defRPr>
+            </a:lvl6pPr>
+            <a:lvl7pPr marL="2743200" algn="l" defTabSz="914400" rtl="0" eaLnBrk="1" latinLnBrk="0" hangingPunct="1">
+              <a:defRPr sz="1800" kern="1200">
+                <a:solidFill>
+                  <a:schemeClr val="tx1"/>
+                </a:solidFill>
+                <a:latin typeface="+mn-lt"/>
+                <a:ea typeface="+mn-ea"/>
+                <a:cs typeface="+mn-cs"/>
+              </a:defRPr>
+            </a:lvl7pPr>
+            <a:lvl8pPr marL="3200400" algn="l" defTabSz="914400" rtl="0" eaLnBrk="1" latinLnBrk="0" hangingPunct="1">
+              <a:defRPr sz="1800" kern="1200">
+                <a:solidFill>
+                  <a:schemeClr val="tx1"/>
+                </a:solidFill>
+                <a:latin typeface="+mn-lt"/>
+                <a:ea typeface="+mn-ea"/>
+                <a:cs typeface="+mn-cs"/>
+              </a:defRPr>
+            </a:lvl8pPr>
+            <a:lvl9pPr marL="3657600" algn="l" defTabSz="914400" rtl="0" eaLnBrk="1" latinLnBrk="0" hangingPunct="1">
+              <a:defRPr sz="1800" kern="1200">
+                <a:solidFill>
+                  <a:schemeClr val="tx1"/>
+                </a:solidFill>
+                <a:latin typeface="+mn-lt"/>
+                <a:ea typeface="+mn-ea"/>
+                <a:cs typeface="+mn-cs"/>
+              </a:defRPr>
+            </a:lvl9pPr>
+          </a:lstStyle>
+          <a:p>
+            <a:pPr lvl="1" algn="ctr"/>
+            <a:r>
+              <a:rPr lang="es-ES" b="1" dirty="0" err="1">
+                <a:solidFill>
+                  <a:srgbClr val="FF0000"/>
+                </a:solidFill>
+                <a:latin typeface="Helvetica" panose="020B0604020202020204" pitchFamily="34" charset="0"/>
+                <a:cs typeface="Helvetica" panose="020B0604020202020204" pitchFamily="34" charset="0"/>
+              </a:rPr>
+              <a:t>Contrary</a:t>
+            </a:r>
+            <a:r>
+              <a:rPr lang="es-ES" b="1" dirty="0">
+                <a:solidFill>
+                  <a:srgbClr val="FF0000"/>
+                </a:solidFill>
+                <a:latin typeface="Helvetica" panose="020B0604020202020204" pitchFamily="34" charset="0"/>
+                <a:cs typeface="Helvetica" panose="020B0604020202020204" pitchFamily="34" charset="0"/>
+              </a:rPr>
+              <a:t> </a:t>
+            </a:r>
+            <a:r>
+              <a:rPr lang="es-ES" b="1" dirty="0" err="1">
+                <a:solidFill>
+                  <a:srgbClr val="FF0000"/>
+                </a:solidFill>
+                <a:latin typeface="Helvetica" panose="020B0604020202020204" pitchFamily="34" charset="0"/>
+                <a:cs typeface="Helvetica" panose="020B0604020202020204" pitchFamily="34" charset="0"/>
+              </a:rPr>
+              <a:t>to</a:t>
+            </a:r>
+            <a:r>
+              <a:rPr lang="es-ES" b="1" dirty="0">
+                <a:solidFill>
+                  <a:srgbClr val="FF0000"/>
+                </a:solidFill>
+                <a:latin typeface="Helvetica" panose="020B0604020202020204" pitchFamily="34" charset="0"/>
+                <a:cs typeface="Helvetica" panose="020B0604020202020204" pitchFamily="34" charset="0"/>
+              </a:rPr>
+              <a:t> </a:t>
+            </a:r>
+            <a:r>
+              <a:rPr lang="es-ES" b="1" dirty="0" err="1">
+                <a:solidFill>
+                  <a:srgbClr val="FF0000"/>
+                </a:solidFill>
+                <a:latin typeface="Helvetica" panose="020B0604020202020204" pitchFamily="34" charset="0"/>
+                <a:cs typeface="Helvetica" panose="020B0604020202020204" pitchFamily="34" charset="0"/>
+              </a:rPr>
+              <a:t>what</a:t>
+            </a:r>
+            <a:r>
+              <a:rPr lang="es-ES" b="1" dirty="0">
+                <a:solidFill>
+                  <a:srgbClr val="FF0000"/>
+                </a:solidFill>
+                <a:latin typeface="Helvetica" panose="020B0604020202020204" pitchFamily="34" charset="0"/>
+                <a:cs typeface="Helvetica" panose="020B0604020202020204" pitchFamily="34" charset="0"/>
+              </a:rPr>
+              <a:t> </a:t>
+            </a:r>
+            <a:r>
+              <a:rPr lang="es-ES" b="1" dirty="0" err="1">
+                <a:solidFill>
+                  <a:srgbClr val="FF0000"/>
+                </a:solidFill>
+                <a:latin typeface="Helvetica" panose="020B0604020202020204" pitchFamily="34" charset="0"/>
+                <a:cs typeface="Helvetica" panose="020B0604020202020204" pitchFamily="34" charset="0"/>
+              </a:rPr>
+              <a:t>we</a:t>
+            </a:r>
+            <a:r>
+              <a:rPr lang="es-ES" b="1" dirty="0">
+                <a:solidFill>
+                  <a:srgbClr val="FF0000"/>
+                </a:solidFill>
+                <a:latin typeface="Helvetica" panose="020B0604020202020204" pitchFamily="34" charset="0"/>
+                <a:cs typeface="Helvetica" panose="020B0604020202020204" pitchFamily="34" charset="0"/>
+              </a:rPr>
+              <a:t> </a:t>
+            </a:r>
+            <a:r>
+              <a:rPr lang="es-ES" b="1" dirty="0" err="1">
+                <a:solidFill>
+                  <a:srgbClr val="FF0000"/>
+                </a:solidFill>
+                <a:latin typeface="Helvetica" panose="020B0604020202020204" pitchFamily="34" charset="0"/>
+                <a:cs typeface="Helvetica" panose="020B0604020202020204" pitchFamily="34" charset="0"/>
+              </a:rPr>
+              <a:t>expected</a:t>
+            </a:r>
+            <a:r>
+              <a:rPr lang="es-ES" b="1" dirty="0">
+                <a:solidFill>
+                  <a:srgbClr val="FF0000"/>
+                </a:solidFill>
+                <a:latin typeface="Helvetica" panose="020B0604020202020204" pitchFamily="34" charset="0"/>
+                <a:cs typeface="Helvetica" panose="020B0604020202020204" pitchFamily="34" charset="0"/>
+              </a:rPr>
+              <a:t>!</a:t>
+            </a:r>
+            <a:endParaRPr lang="es-ES" dirty="0">
+              <a:latin typeface="Helvetica" panose="020B0604020202020204" pitchFamily="34" charset="0"/>
+              <a:cs typeface="Helvetica" panose="020B0604020202020204" pitchFamily="34" charset="0"/>
+            </a:endParaRPr>
+          </a:p>
+        </p:txBody>
+      </p:sp>
+      <p:sp>
+        <p:nvSpPr>
+          <p:cNvPr id="10" name="CuadroTexto 10">
+            <a:extLst>
+              <a:ext uri="{FF2B5EF4-FFF2-40B4-BE49-F238E27FC236}">
+                <a16:creationId xmlns:a16="http://schemas.microsoft.com/office/drawing/2014/main" id="{4AFD5ADB-7309-9E31-754C-662A52E6DE59}"/>
+              </a:ext>
+            </a:extLst>
+          </p:cNvPr>
+          <p:cNvSpPr txBox="1"/>
+          <p:nvPr/>
+        </p:nvSpPr>
+        <p:spPr>
+          <a:xfrm>
+            <a:off x="8661397" y="4542712"/>
+            <a:ext cx="2621279" cy="923330"/>
+          </a:xfrm>
+          <a:prstGeom prst="rect">
+            <a:avLst/>
+          </a:prstGeom>
+          <a:noFill/>
+        </p:spPr>
+        <p:txBody>
+          <a:bodyPr wrap="square" rtlCol="0">
+            <a:spAutoFit/>
+          </a:bodyPr>
+          <a:lstStyle>
+            <a:defPPr>
+              <a:defRPr lang="es-ES"/>
+            </a:defPPr>
+            <a:lvl1pPr marL="0" algn="l" defTabSz="914400" rtl="0" eaLnBrk="1" latinLnBrk="0" hangingPunct="1">
+              <a:defRPr sz="1800" kern="1200">
+                <a:solidFill>
+                  <a:schemeClr val="tx1"/>
+                </a:solidFill>
+                <a:latin typeface="+mn-lt"/>
+                <a:ea typeface="+mn-ea"/>
+                <a:cs typeface="+mn-cs"/>
+              </a:defRPr>
+            </a:lvl1pPr>
+            <a:lvl2pPr marL="457200" algn="l" defTabSz="914400" rtl="0" eaLnBrk="1" latinLnBrk="0" hangingPunct="1">
+              <a:defRPr sz="1800" kern="1200">
+                <a:solidFill>
+                  <a:schemeClr val="tx1"/>
+                </a:solidFill>
+                <a:latin typeface="+mn-lt"/>
+                <a:ea typeface="+mn-ea"/>
+                <a:cs typeface="+mn-cs"/>
+              </a:defRPr>
+            </a:lvl2pPr>
+            <a:lvl3pPr marL="914400" algn="l" defTabSz="914400" rtl="0" eaLnBrk="1" latinLnBrk="0" hangingPunct="1">
+              <a:defRPr sz="1800" kern="1200">
+                <a:solidFill>
+                  <a:schemeClr val="tx1"/>
+                </a:solidFill>
+                <a:latin typeface="+mn-lt"/>
+                <a:ea typeface="+mn-ea"/>
+                <a:cs typeface="+mn-cs"/>
+              </a:defRPr>
+            </a:lvl3pPr>
+            <a:lvl4pPr marL="1371600" algn="l" defTabSz="914400" rtl="0" eaLnBrk="1" latinLnBrk="0" hangingPunct="1">
+              <a:defRPr sz="1800" kern="1200">
+                <a:solidFill>
+                  <a:schemeClr val="tx1"/>
+                </a:solidFill>
+                <a:latin typeface="+mn-lt"/>
+                <a:ea typeface="+mn-ea"/>
+                <a:cs typeface="+mn-cs"/>
+              </a:defRPr>
+            </a:lvl4pPr>
+            <a:lvl5pPr marL="1828800" algn="l" defTabSz="914400" rtl="0" eaLnBrk="1" latinLnBrk="0" hangingPunct="1">
+              <a:defRPr sz="1800" kern="1200">
+                <a:solidFill>
+                  <a:schemeClr val="tx1"/>
+                </a:solidFill>
+                <a:latin typeface="+mn-lt"/>
+                <a:ea typeface="+mn-ea"/>
+                <a:cs typeface="+mn-cs"/>
+              </a:defRPr>
+            </a:lvl5pPr>
+            <a:lvl6pPr marL="2286000" algn="l" defTabSz="914400" rtl="0" eaLnBrk="1" latinLnBrk="0" hangingPunct="1">
+              <a:defRPr sz="1800" kern="1200">
+                <a:solidFill>
+                  <a:schemeClr val="tx1"/>
+                </a:solidFill>
+                <a:latin typeface="+mn-lt"/>
+                <a:ea typeface="+mn-ea"/>
+                <a:cs typeface="+mn-cs"/>
+              </a:defRPr>
+            </a:lvl6pPr>
+            <a:lvl7pPr marL="2743200" algn="l" defTabSz="914400" rtl="0" eaLnBrk="1" latinLnBrk="0" hangingPunct="1">
+              <a:defRPr sz="1800" kern="1200">
+                <a:solidFill>
+                  <a:schemeClr val="tx1"/>
+                </a:solidFill>
+                <a:latin typeface="+mn-lt"/>
+                <a:ea typeface="+mn-ea"/>
+                <a:cs typeface="+mn-cs"/>
+              </a:defRPr>
+            </a:lvl7pPr>
+            <a:lvl8pPr marL="3200400" algn="l" defTabSz="914400" rtl="0" eaLnBrk="1" latinLnBrk="0" hangingPunct="1">
+              <a:defRPr sz="1800" kern="1200">
+                <a:solidFill>
+                  <a:schemeClr val="tx1"/>
+                </a:solidFill>
+                <a:latin typeface="+mn-lt"/>
+                <a:ea typeface="+mn-ea"/>
+                <a:cs typeface="+mn-cs"/>
+              </a:defRPr>
+            </a:lvl8pPr>
+            <a:lvl9pPr marL="3657600" algn="l" defTabSz="914400" rtl="0" eaLnBrk="1" latinLnBrk="0" hangingPunct="1">
+              <a:defRPr sz="1800" kern="1200">
+                <a:solidFill>
+                  <a:schemeClr val="tx1"/>
+                </a:solidFill>
+                <a:latin typeface="+mn-lt"/>
+                <a:ea typeface="+mn-ea"/>
+                <a:cs typeface="+mn-cs"/>
+              </a:defRPr>
+            </a:lvl9pPr>
+          </a:lstStyle>
+          <a:p>
+            <a:pPr lvl="1" algn="ctr"/>
+            <a:r>
+              <a:rPr lang="es-ES" b="1" dirty="0">
+                <a:latin typeface="Helvetica" panose="020B0604020202020204" pitchFamily="34" charset="0"/>
+                <a:cs typeface="Helvetica" panose="020B0604020202020204" pitchFamily="34" charset="0"/>
+              </a:rPr>
+              <a:t>SLA </a:t>
+            </a:r>
+            <a:r>
+              <a:rPr lang="es-ES" dirty="0" err="1">
+                <a:latin typeface="Helvetica" panose="020B0604020202020204" pitchFamily="34" charset="0"/>
+                <a:cs typeface="Helvetica" panose="020B0604020202020204" pitchFamily="34" charset="0"/>
+              </a:rPr>
+              <a:t>is</a:t>
+            </a:r>
+            <a:r>
+              <a:rPr lang="es-ES" dirty="0">
+                <a:latin typeface="Helvetica" panose="020B0604020202020204" pitchFamily="34" charset="0"/>
+                <a:cs typeface="Helvetica" panose="020B0604020202020204" pitchFamily="34" charset="0"/>
+              </a:rPr>
+              <a:t> a response </a:t>
+            </a:r>
+            <a:r>
+              <a:rPr lang="es-ES" dirty="0" err="1">
+                <a:latin typeface="Helvetica" panose="020B0604020202020204" pitchFamily="34" charset="0"/>
+                <a:cs typeface="Helvetica" panose="020B0604020202020204" pitchFamily="34" charset="0"/>
+              </a:rPr>
+              <a:t>instead</a:t>
+            </a:r>
+            <a:r>
+              <a:rPr lang="es-ES" dirty="0">
+                <a:latin typeface="Helvetica" panose="020B0604020202020204" pitchFamily="34" charset="0"/>
+                <a:cs typeface="Helvetica" panose="020B0604020202020204" pitchFamily="34" charset="0"/>
+              </a:rPr>
+              <a:t> </a:t>
+            </a:r>
+            <a:r>
+              <a:rPr lang="es-ES" dirty="0" err="1">
+                <a:latin typeface="Helvetica" panose="020B0604020202020204" pitchFamily="34" charset="0"/>
+                <a:cs typeface="Helvetica" panose="020B0604020202020204" pitchFamily="34" charset="0"/>
+              </a:rPr>
+              <a:t>of</a:t>
+            </a:r>
+            <a:r>
+              <a:rPr lang="es-ES" dirty="0">
+                <a:latin typeface="Helvetica" panose="020B0604020202020204" pitchFamily="34" charset="0"/>
+                <a:cs typeface="Helvetica" panose="020B0604020202020204" pitchFamily="34" charset="0"/>
+              </a:rPr>
+              <a:t> a </a:t>
+            </a:r>
+            <a:r>
+              <a:rPr lang="es-ES" dirty="0" err="1">
+                <a:latin typeface="Helvetica" panose="020B0604020202020204" pitchFamily="34" charset="0"/>
+                <a:cs typeface="Helvetica" panose="020B0604020202020204" pitchFamily="34" charset="0"/>
+              </a:rPr>
+              <a:t>vulnerability</a:t>
+            </a:r>
+            <a:r>
+              <a:rPr lang="es-ES" dirty="0">
+                <a:latin typeface="Helvetica" panose="020B0604020202020204" pitchFamily="34" charset="0"/>
+                <a:cs typeface="Helvetica" panose="020B0604020202020204" pitchFamily="34" charset="0"/>
+              </a:rPr>
+              <a:t> factor!</a:t>
+            </a:r>
+          </a:p>
+        </p:txBody>
+      </p:sp>
+      <p:sp>
+        <p:nvSpPr>
+          <p:cNvPr id="13" name="CuadroTexto 10">
+            <a:extLst>
+              <a:ext uri="{FF2B5EF4-FFF2-40B4-BE49-F238E27FC236}">
+                <a16:creationId xmlns:a16="http://schemas.microsoft.com/office/drawing/2014/main" id="{5E222CD1-A427-DC37-54F3-C3C02023523C}"/>
+              </a:ext>
+            </a:extLst>
+          </p:cNvPr>
+          <p:cNvSpPr txBox="1"/>
+          <p:nvPr/>
+        </p:nvSpPr>
+        <p:spPr>
+          <a:xfrm>
+            <a:off x="1807122" y="4105671"/>
             <a:ext cx="2956560" cy="2031325"/>
           </a:xfrm>
           <a:prstGeom prst="rect">
@@ -18300,407 +18517,154 @@
                 <a:latin typeface="Helvetica" panose="020B0604020202020204" pitchFamily="34" charset="0"/>
                 <a:cs typeface="Helvetica" panose="020B0604020202020204" pitchFamily="34" charset="0"/>
               </a:rPr>
-              <a:t>Growth</a:t>
+              <a:t>Competition</a:t>
+            </a:r>
+            <a:r>
+              <a:rPr lang="es-ES" dirty="0">
+                <a:latin typeface="Helvetica" panose="020B0604020202020204" pitchFamily="34" charset="0"/>
+                <a:cs typeface="Helvetica" panose="020B0604020202020204" pitchFamily="34" charset="0"/>
+              </a:rPr>
+              <a:t> </a:t>
+            </a:r>
+            <a:r>
+              <a:rPr lang="es-ES" dirty="0" err="1">
+                <a:latin typeface="Helvetica" panose="020B0604020202020204" pitchFamily="34" charset="0"/>
+                <a:cs typeface="Helvetica" panose="020B0604020202020204" pitchFamily="34" charset="0"/>
+              </a:rPr>
+              <a:t>is</a:t>
+            </a:r>
+            <a:r>
+              <a:rPr lang="es-ES" dirty="0">
+                <a:latin typeface="Helvetica" panose="020B0604020202020204" pitchFamily="34" charset="0"/>
+                <a:cs typeface="Helvetica" panose="020B0604020202020204" pitchFamily="34" charset="0"/>
+              </a:rPr>
+              <a:t> more intense in </a:t>
+            </a:r>
+            <a:r>
+              <a:rPr lang="es-ES" dirty="0" err="1">
+                <a:latin typeface="Helvetica" panose="020B0604020202020204" pitchFamily="34" charset="0"/>
+                <a:cs typeface="Helvetica" panose="020B0604020202020204" pitchFamily="34" charset="0"/>
+              </a:rPr>
+              <a:t>declining</a:t>
+            </a:r>
+            <a:r>
+              <a:rPr lang="es-ES" dirty="0">
+                <a:latin typeface="Helvetica" panose="020B0604020202020204" pitchFamily="34" charset="0"/>
+                <a:cs typeface="Helvetica" panose="020B0604020202020204" pitchFamily="34" charset="0"/>
+              </a:rPr>
+              <a:t> sites. </a:t>
+            </a:r>
+            <a:r>
+              <a:rPr lang="es-ES" b="1" dirty="0" err="1">
+                <a:latin typeface="Helvetica" panose="020B0604020202020204" pitchFamily="34" charset="0"/>
+                <a:cs typeface="Helvetica" panose="020B0604020202020204" pitchFamily="34" charset="0"/>
+              </a:rPr>
+              <a:t>Denser</a:t>
             </a:r>
             <a:r>
               <a:rPr lang="es-ES" b="1" dirty="0">
                 <a:latin typeface="Helvetica" panose="020B0604020202020204" pitchFamily="34" charset="0"/>
                 <a:cs typeface="Helvetica" panose="020B0604020202020204" pitchFamily="34" charset="0"/>
               </a:rPr>
+              <a:t> stands </a:t>
+            </a:r>
+            <a:r>
+              <a:rPr lang="es-ES" dirty="0">
+                <a:latin typeface="Helvetica" panose="020B0604020202020204" pitchFamily="34" charset="0"/>
+                <a:cs typeface="Helvetica" panose="020B0604020202020204" pitchFamily="34" charset="0"/>
+              </a:rPr>
+              <a:t>are </a:t>
+            </a:r>
+            <a:r>
+              <a:rPr lang="es-ES" b="1" dirty="0">
+                <a:latin typeface="Helvetica" panose="020B0604020202020204" pitchFamily="34" charset="0"/>
+                <a:cs typeface="Helvetica" panose="020B0604020202020204" pitchFamily="34" charset="0"/>
+              </a:rPr>
+              <a:t>more vulnerable </a:t>
+            </a:r>
+            <a:r>
+              <a:rPr lang="es-ES" dirty="0" err="1">
+                <a:latin typeface="Helvetica" panose="020B0604020202020204" pitchFamily="34" charset="0"/>
+                <a:cs typeface="Helvetica" panose="020B0604020202020204" pitchFamily="34" charset="0"/>
+              </a:rPr>
+              <a:t>due</a:t>
+            </a:r>
+            <a:r>
+              <a:rPr lang="es-ES" dirty="0">
+                <a:latin typeface="Helvetica" panose="020B0604020202020204" pitchFamily="34" charset="0"/>
+                <a:cs typeface="Helvetica" panose="020B0604020202020204" pitchFamily="34" charset="0"/>
+              </a:rPr>
               <a:t> </a:t>
             </a:r>
             <a:r>
-              <a:rPr lang="es-ES" b="1" dirty="0" err="1">
-                <a:latin typeface="Helvetica" panose="020B0604020202020204" pitchFamily="34" charset="0"/>
-                <a:cs typeface="Helvetica" panose="020B0604020202020204" pitchFamily="34" charset="0"/>
-              </a:rPr>
-              <a:t>rates</a:t>
+              <a:rPr lang="es-ES" dirty="0" err="1">
+                <a:latin typeface="Helvetica" panose="020B0604020202020204" pitchFamily="34" charset="0"/>
+                <a:cs typeface="Helvetica" panose="020B0604020202020204" pitchFamily="34" charset="0"/>
+              </a:rPr>
+              <a:t>limitting</a:t>
             </a:r>
             <a:r>
               <a:rPr lang="es-ES" dirty="0">
                 <a:latin typeface="Helvetica" panose="020B0604020202020204" pitchFamily="34" charset="0"/>
                 <a:cs typeface="Helvetica" panose="020B0604020202020204" pitchFamily="34" charset="0"/>
               </a:rPr>
-              <a:t> are more intense in </a:t>
+              <a:t> </a:t>
             </a:r>
             <a:r>
               <a:rPr lang="es-ES" dirty="0" err="1">
                 <a:latin typeface="Helvetica" panose="020B0604020202020204" pitchFamily="34" charset="0"/>
                 <a:cs typeface="Helvetica" panose="020B0604020202020204" pitchFamily="34" charset="0"/>
               </a:rPr>
-              <a:t>higher</a:t>
+              <a:t>water</a:t>
             </a:r>
             <a:r>
               <a:rPr lang="es-ES" dirty="0">
                 <a:latin typeface="Helvetica" panose="020B0604020202020204" pitchFamily="34" charset="0"/>
                 <a:cs typeface="Helvetica" panose="020B0604020202020204" pitchFamily="34" charset="0"/>
               </a:rPr>
-              <a:t> in </a:t>
+              <a:t> and </a:t>
             </a:r>
             <a:r>
               <a:rPr lang="es-ES" dirty="0" err="1">
                 <a:latin typeface="Helvetica" panose="020B0604020202020204" pitchFamily="34" charset="0"/>
                 <a:cs typeface="Helvetica" panose="020B0604020202020204" pitchFamily="34" charset="0"/>
               </a:rPr>
-              <a:t>declining</a:t>
+              <a:t>nutrients</a:t>
             </a:r>
             <a:r>
               <a:rPr lang="es-ES" dirty="0">
                 <a:latin typeface="Helvetica" panose="020B0604020202020204" pitchFamily="34" charset="0"/>
                 <a:cs typeface="Helvetica" panose="020B0604020202020204" pitchFamily="34" charset="0"/>
               </a:rPr>
-              <a:t> sites. </a:t>
+              <a:t> </a:t>
             </a:r>
             <a:r>
               <a:rPr lang="es-ES" dirty="0" err="1">
                 <a:latin typeface="Helvetica" panose="020B0604020202020204" pitchFamily="34" charset="0"/>
                 <a:cs typeface="Helvetica" panose="020B0604020202020204" pitchFamily="34" charset="0"/>
               </a:rPr>
-              <a:t>Trees</a:t>
+              <a:t>availability</a:t>
             </a:r>
             <a:r>
               <a:rPr lang="es-ES" dirty="0">
                 <a:latin typeface="Helvetica" panose="020B0604020202020204" pitchFamily="34" charset="0"/>
                 <a:cs typeface="Helvetica" panose="020B0604020202020204" pitchFamily="34" charset="0"/>
               </a:rPr>
-              <a:t> </a:t>
-            </a:r>
-            <a:r>
-              <a:rPr lang="es-ES" dirty="0" err="1">
-                <a:latin typeface="Helvetica" panose="020B0604020202020204" pitchFamily="34" charset="0"/>
-                <a:cs typeface="Helvetica" panose="020B0604020202020204" pitchFamily="34" charset="0"/>
-              </a:rPr>
-              <a:t>with</a:t>
-            </a:r>
-            <a:r>
-              <a:rPr lang="es-ES" dirty="0">
-                <a:latin typeface="Helvetica" panose="020B0604020202020204" pitchFamily="34" charset="0"/>
-                <a:cs typeface="Helvetica" panose="020B0604020202020204" pitchFamily="34" charset="0"/>
-              </a:rPr>
-              <a:t> </a:t>
-            </a:r>
-            <a:r>
-              <a:rPr lang="es-ES" b="1" dirty="0" err="1">
-                <a:latin typeface="Helvetica" panose="020B0604020202020204" pitchFamily="34" charset="0"/>
-                <a:cs typeface="Helvetica" panose="020B0604020202020204" pitchFamily="34" charset="0"/>
-              </a:rPr>
-              <a:t>declining</a:t>
-            </a:r>
-            <a:r>
-              <a:rPr lang="es-ES" b="1" dirty="0">
-                <a:latin typeface="Helvetica" panose="020B0604020202020204" pitchFamily="34" charset="0"/>
-                <a:cs typeface="Helvetica" panose="020B0604020202020204" pitchFamily="34" charset="0"/>
-              </a:rPr>
-              <a:t> </a:t>
-            </a:r>
-            <a:r>
-              <a:rPr lang="es-ES" b="1" dirty="0" err="1">
-                <a:latin typeface="Helvetica" panose="020B0604020202020204" pitchFamily="34" charset="0"/>
-                <a:cs typeface="Helvetica" panose="020B0604020202020204" pitchFamily="34" charset="0"/>
-              </a:rPr>
-              <a:t>growth</a:t>
-            </a:r>
-            <a:r>
-              <a:rPr lang="es-ES" b="1" dirty="0">
-                <a:latin typeface="Helvetica" panose="020B0604020202020204" pitchFamily="34" charset="0"/>
-                <a:cs typeface="Helvetica" panose="020B0604020202020204" pitchFamily="34" charset="0"/>
-              </a:rPr>
-              <a:t> </a:t>
-            </a:r>
-            <a:r>
-              <a:rPr lang="es-ES" b="1" dirty="0" err="1">
-                <a:latin typeface="Helvetica" panose="020B0604020202020204" pitchFamily="34" charset="0"/>
-                <a:cs typeface="Helvetica" panose="020B0604020202020204" pitchFamily="34" charset="0"/>
-              </a:rPr>
-              <a:t>rates</a:t>
-            </a:r>
-            <a:r>
-              <a:rPr lang="es-ES" b="1" dirty="0">
-                <a:latin typeface="Helvetica" panose="020B0604020202020204" pitchFamily="34" charset="0"/>
-                <a:cs typeface="Helvetica" panose="020B0604020202020204" pitchFamily="34" charset="0"/>
-              </a:rPr>
-              <a:t> </a:t>
-            </a:r>
-            <a:r>
-              <a:rPr lang="es-ES" dirty="0">
-                <a:latin typeface="Helvetica" panose="020B0604020202020204" pitchFamily="34" charset="0"/>
-                <a:cs typeface="Helvetica" panose="020B0604020202020204" pitchFamily="34" charset="0"/>
-              </a:rPr>
-              <a:t>are more vulnerable </a:t>
-            </a:r>
-            <a:r>
-              <a:rPr lang="es-ES" dirty="0" err="1">
-                <a:latin typeface="Helvetica" panose="020B0604020202020204" pitchFamily="34" charset="0"/>
-                <a:cs typeface="Helvetica" panose="020B0604020202020204" pitchFamily="34" charset="0"/>
-              </a:rPr>
-              <a:t>to</a:t>
-            </a:r>
-            <a:r>
-              <a:rPr lang="es-ES" dirty="0">
-                <a:latin typeface="Helvetica" panose="020B0604020202020204" pitchFamily="34" charset="0"/>
-                <a:cs typeface="Helvetica" panose="020B0604020202020204" pitchFamily="34" charset="0"/>
-              </a:rPr>
-              <a:t> </a:t>
-            </a:r>
-            <a:r>
-              <a:rPr lang="es-ES" dirty="0" err="1">
-                <a:latin typeface="Helvetica" panose="020B0604020202020204" pitchFamily="34" charset="0"/>
-                <a:cs typeface="Helvetica" panose="020B0604020202020204" pitchFamily="34" charset="0"/>
-              </a:rPr>
-              <a:t>drought</a:t>
-            </a:r>
-            <a:endParaRPr lang="es-ES" dirty="0">
-              <a:latin typeface="Helvetica" panose="020B0604020202020204" pitchFamily="34" charset="0"/>
-              <a:cs typeface="Helvetica" panose="020B0604020202020204" pitchFamily="34" charset="0"/>
-            </a:endParaRPr>
-          </a:p>
-        </p:txBody>
-      </p:sp>
-      <p:sp>
-        <p:nvSpPr>
-          <p:cNvPr id="14" name="CuadroTexto 10">
-            <a:extLst>
-              <a:ext uri="{FF2B5EF4-FFF2-40B4-BE49-F238E27FC236}">
-                <a16:creationId xmlns:a16="http://schemas.microsoft.com/office/drawing/2014/main" id="{984E2E61-6987-446E-0F1F-3DDE3400E43F}"/>
-              </a:ext>
-            </a:extLst>
-          </p:cNvPr>
-          <p:cNvSpPr txBox="1"/>
-          <p:nvPr/>
-        </p:nvSpPr>
-        <p:spPr>
-          <a:xfrm>
-            <a:off x="129540" y="6100313"/>
-            <a:ext cx="5664199" cy="369332"/>
-          </a:xfrm>
-          <a:prstGeom prst="rect">
-            <a:avLst/>
-          </a:prstGeom>
-          <a:noFill/>
-        </p:spPr>
-        <p:txBody>
-          <a:bodyPr wrap="square" rtlCol="0">
-            <a:spAutoFit/>
-          </a:bodyPr>
-          <a:lstStyle>
-            <a:defPPr>
-              <a:defRPr lang="es-ES"/>
-            </a:defPPr>
-            <a:lvl1pPr marL="0" algn="l" defTabSz="914400" rtl="0" eaLnBrk="1" latinLnBrk="0" hangingPunct="1">
-              <a:defRPr sz="1800" kern="1200">
-                <a:solidFill>
-                  <a:schemeClr val="tx1"/>
-                </a:solidFill>
-                <a:latin typeface="+mn-lt"/>
-                <a:ea typeface="+mn-ea"/>
-                <a:cs typeface="+mn-cs"/>
-              </a:defRPr>
-            </a:lvl1pPr>
-            <a:lvl2pPr marL="457200" algn="l" defTabSz="914400" rtl="0" eaLnBrk="1" latinLnBrk="0" hangingPunct="1">
-              <a:defRPr sz="1800" kern="1200">
-                <a:solidFill>
-                  <a:schemeClr val="tx1"/>
-                </a:solidFill>
-                <a:latin typeface="+mn-lt"/>
-                <a:ea typeface="+mn-ea"/>
-                <a:cs typeface="+mn-cs"/>
-              </a:defRPr>
-            </a:lvl2pPr>
-            <a:lvl3pPr marL="914400" algn="l" defTabSz="914400" rtl="0" eaLnBrk="1" latinLnBrk="0" hangingPunct="1">
-              <a:defRPr sz="1800" kern="1200">
-                <a:solidFill>
-                  <a:schemeClr val="tx1"/>
-                </a:solidFill>
-                <a:latin typeface="+mn-lt"/>
-                <a:ea typeface="+mn-ea"/>
-                <a:cs typeface="+mn-cs"/>
-              </a:defRPr>
-            </a:lvl3pPr>
-            <a:lvl4pPr marL="1371600" algn="l" defTabSz="914400" rtl="0" eaLnBrk="1" latinLnBrk="0" hangingPunct="1">
-              <a:defRPr sz="1800" kern="1200">
-                <a:solidFill>
-                  <a:schemeClr val="tx1"/>
-                </a:solidFill>
-                <a:latin typeface="+mn-lt"/>
-                <a:ea typeface="+mn-ea"/>
-                <a:cs typeface="+mn-cs"/>
-              </a:defRPr>
-            </a:lvl4pPr>
-            <a:lvl5pPr marL="1828800" algn="l" defTabSz="914400" rtl="0" eaLnBrk="1" latinLnBrk="0" hangingPunct="1">
-              <a:defRPr sz="1800" kern="1200">
-                <a:solidFill>
-                  <a:schemeClr val="tx1"/>
-                </a:solidFill>
-                <a:latin typeface="+mn-lt"/>
-                <a:ea typeface="+mn-ea"/>
-                <a:cs typeface="+mn-cs"/>
-              </a:defRPr>
-            </a:lvl5pPr>
-            <a:lvl6pPr marL="2286000" algn="l" defTabSz="914400" rtl="0" eaLnBrk="1" latinLnBrk="0" hangingPunct="1">
-              <a:defRPr sz="1800" kern="1200">
-                <a:solidFill>
-                  <a:schemeClr val="tx1"/>
-                </a:solidFill>
-                <a:latin typeface="+mn-lt"/>
-                <a:ea typeface="+mn-ea"/>
-                <a:cs typeface="+mn-cs"/>
-              </a:defRPr>
-            </a:lvl6pPr>
-            <a:lvl7pPr marL="2743200" algn="l" defTabSz="914400" rtl="0" eaLnBrk="1" latinLnBrk="0" hangingPunct="1">
-              <a:defRPr sz="1800" kern="1200">
-                <a:solidFill>
-                  <a:schemeClr val="tx1"/>
-                </a:solidFill>
-                <a:latin typeface="+mn-lt"/>
-                <a:ea typeface="+mn-ea"/>
-                <a:cs typeface="+mn-cs"/>
-              </a:defRPr>
-            </a:lvl7pPr>
-            <a:lvl8pPr marL="3200400" algn="l" defTabSz="914400" rtl="0" eaLnBrk="1" latinLnBrk="0" hangingPunct="1">
-              <a:defRPr sz="1800" kern="1200">
-                <a:solidFill>
-                  <a:schemeClr val="tx1"/>
-                </a:solidFill>
-                <a:latin typeface="+mn-lt"/>
-                <a:ea typeface="+mn-ea"/>
-                <a:cs typeface="+mn-cs"/>
-              </a:defRPr>
-            </a:lvl8pPr>
-            <a:lvl9pPr marL="3657600" algn="l" defTabSz="914400" rtl="0" eaLnBrk="1" latinLnBrk="0" hangingPunct="1">
-              <a:defRPr sz="1800" kern="1200">
-                <a:solidFill>
-                  <a:schemeClr val="tx1"/>
-                </a:solidFill>
-                <a:latin typeface="+mn-lt"/>
-                <a:ea typeface="+mn-ea"/>
-                <a:cs typeface="+mn-cs"/>
-              </a:defRPr>
-            </a:lvl9pPr>
-          </a:lstStyle>
-          <a:p>
-            <a:pPr lvl="1" algn="ctr"/>
-            <a:r>
-              <a:rPr lang="es-ES" b="1" dirty="0" err="1">
-                <a:solidFill>
-                  <a:srgbClr val="FF0000"/>
-                </a:solidFill>
-                <a:latin typeface="Helvetica" panose="020B0604020202020204" pitchFamily="34" charset="0"/>
-                <a:cs typeface="Helvetica" panose="020B0604020202020204" pitchFamily="34" charset="0"/>
-              </a:rPr>
-              <a:t>Contrary</a:t>
-            </a:r>
-            <a:r>
-              <a:rPr lang="es-ES" b="1" dirty="0">
-                <a:solidFill>
-                  <a:srgbClr val="FF0000"/>
-                </a:solidFill>
-                <a:latin typeface="Helvetica" panose="020B0604020202020204" pitchFamily="34" charset="0"/>
-                <a:cs typeface="Helvetica" panose="020B0604020202020204" pitchFamily="34" charset="0"/>
-              </a:rPr>
-              <a:t> </a:t>
-            </a:r>
-            <a:r>
-              <a:rPr lang="es-ES" b="1" dirty="0" err="1">
-                <a:solidFill>
-                  <a:srgbClr val="FF0000"/>
-                </a:solidFill>
-                <a:latin typeface="Helvetica" panose="020B0604020202020204" pitchFamily="34" charset="0"/>
-                <a:cs typeface="Helvetica" panose="020B0604020202020204" pitchFamily="34" charset="0"/>
-              </a:rPr>
-              <a:t>to</a:t>
-            </a:r>
-            <a:r>
-              <a:rPr lang="es-ES" b="1" dirty="0">
-                <a:solidFill>
-                  <a:srgbClr val="FF0000"/>
-                </a:solidFill>
-                <a:latin typeface="Helvetica" panose="020B0604020202020204" pitchFamily="34" charset="0"/>
-                <a:cs typeface="Helvetica" panose="020B0604020202020204" pitchFamily="34" charset="0"/>
-              </a:rPr>
-              <a:t> </a:t>
-            </a:r>
-            <a:r>
-              <a:rPr lang="es-ES" b="1" dirty="0" err="1">
-                <a:solidFill>
-                  <a:srgbClr val="FF0000"/>
-                </a:solidFill>
-                <a:latin typeface="Helvetica" panose="020B0604020202020204" pitchFamily="34" charset="0"/>
-                <a:cs typeface="Helvetica" panose="020B0604020202020204" pitchFamily="34" charset="0"/>
-              </a:rPr>
-              <a:t>what</a:t>
-            </a:r>
-            <a:r>
-              <a:rPr lang="es-ES" b="1" dirty="0">
-                <a:solidFill>
-                  <a:srgbClr val="FF0000"/>
-                </a:solidFill>
-                <a:latin typeface="Helvetica" panose="020B0604020202020204" pitchFamily="34" charset="0"/>
-                <a:cs typeface="Helvetica" panose="020B0604020202020204" pitchFamily="34" charset="0"/>
-              </a:rPr>
-              <a:t> </a:t>
-            </a:r>
-            <a:r>
-              <a:rPr lang="es-ES" b="1" dirty="0" err="1">
-                <a:solidFill>
-                  <a:srgbClr val="FF0000"/>
-                </a:solidFill>
-                <a:latin typeface="Helvetica" panose="020B0604020202020204" pitchFamily="34" charset="0"/>
-                <a:cs typeface="Helvetica" panose="020B0604020202020204" pitchFamily="34" charset="0"/>
-              </a:rPr>
-              <a:t>we</a:t>
-            </a:r>
-            <a:r>
-              <a:rPr lang="es-ES" b="1" dirty="0">
-                <a:solidFill>
-                  <a:srgbClr val="FF0000"/>
-                </a:solidFill>
-                <a:latin typeface="Helvetica" panose="020B0604020202020204" pitchFamily="34" charset="0"/>
-                <a:cs typeface="Helvetica" panose="020B0604020202020204" pitchFamily="34" charset="0"/>
-              </a:rPr>
-              <a:t> </a:t>
-            </a:r>
-            <a:r>
-              <a:rPr lang="es-ES" b="1" dirty="0" err="1">
-                <a:solidFill>
-                  <a:srgbClr val="FF0000"/>
-                </a:solidFill>
-                <a:latin typeface="Helvetica" panose="020B0604020202020204" pitchFamily="34" charset="0"/>
-                <a:cs typeface="Helvetica" panose="020B0604020202020204" pitchFamily="34" charset="0"/>
-              </a:rPr>
-              <a:t>expected</a:t>
-            </a:r>
-            <a:r>
-              <a:rPr lang="es-ES" b="1" dirty="0">
-                <a:solidFill>
-                  <a:srgbClr val="FF0000"/>
-                </a:solidFill>
-                <a:latin typeface="Helvetica" panose="020B0604020202020204" pitchFamily="34" charset="0"/>
-                <a:cs typeface="Helvetica" panose="020B0604020202020204" pitchFamily="34" charset="0"/>
-              </a:rPr>
-              <a:t>!</a:t>
-            </a:r>
-            <a:endParaRPr lang="es-ES" dirty="0">
-              <a:latin typeface="Helvetica" panose="020B0604020202020204" pitchFamily="34" charset="0"/>
-              <a:cs typeface="Helvetica" panose="020B0604020202020204" pitchFamily="34" charset="0"/>
-            </a:endParaRPr>
+              <a:t> per individual</a:t>
+            </a:r>
           </a:p>
         </p:txBody>
       </p:sp>
     </p:spTree>
     <p:extLst>
       <p:ext uri="{BB962C8B-B14F-4D97-AF65-F5344CB8AC3E}">
-        <p14:creationId xmlns:p14="http://schemas.microsoft.com/office/powerpoint/2010/main" val="3850298625"/>
+        <p14:creationId xmlns:p14="http://schemas.microsoft.com/office/powerpoint/2010/main" val="4188263335"/>
       </p:ext>
     </p:extLst>
   </p:cSld>
   <p:clrMapOvr>
     <a:masterClrMapping/>
   </p:clrMapOvr>
-  <p:extLst>
-    <p:ext uri="{6950BFC3-D8DA-4A85-94F7-54DA5524770B}">
-      <p188:commentRel xmlns:p188="http://schemas.microsoft.com/office/powerpoint/2018/8/main" r:id="rId2"/>
-    </p:ext>
-  </p:extLst>
 </p:sld>
 </file>
 
@@ -18712,7 +18676,7 @@
         <p:cNvPr id="1" name="">
           <a:extLst>
             <a:ext uri="{FF2B5EF4-FFF2-40B4-BE49-F238E27FC236}">
-              <a16:creationId xmlns:a16="http://schemas.microsoft.com/office/drawing/2014/main" id="{8CCFEB6C-5237-FAD5-FD30-22E62AF9C5E6}"/>
+              <a16:creationId xmlns:a16="http://schemas.microsoft.com/office/drawing/2014/main" id="{E5D7817C-A3F6-4CDF-EA36-D5DB876C36FA}"/>
             </a:ext>
           </a:extLst>
         </p:cNvPr>
@@ -18732,7 +18696,7 @@
           <p:cNvPr id="3" name="Rectangle 1">
             <a:extLst>
               <a:ext uri="{FF2B5EF4-FFF2-40B4-BE49-F238E27FC236}">
-                <a16:creationId xmlns:a16="http://schemas.microsoft.com/office/drawing/2014/main" id="{902E8109-2D9D-23DE-1AD2-033BA9B2E70F}"/>
+                <a16:creationId xmlns:a16="http://schemas.microsoft.com/office/drawing/2014/main" id="{51887738-5FA3-398F-5A45-8D1BE14389E1}"/>
               </a:ext>
             </a:extLst>
           </p:cNvPr>
@@ -18994,7 +18958,7 @@
           <p:cNvPr id="2" name="Título 1">
             <a:extLst>
               <a:ext uri="{FF2B5EF4-FFF2-40B4-BE49-F238E27FC236}">
-                <a16:creationId xmlns:a16="http://schemas.microsoft.com/office/drawing/2014/main" id="{CED90A4F-2E06-ED1D-D1D4-D61669DFD101}"/>
+                <a16:creationId xmlns:a16="http://schemas.microsoft.com/office/drawing/2014/main" id="{CFDAEAB4-983A-5310-50BA-5A0D50CDEDCC}"/>
               </a:ext>
             </a:extLst>
           </p:cNvPr>
@@ -19075,7 +19039,7 @@
           <p:cNvPr id="8" name="Título 1">
             <a:extLst>
               <a:ext uri="{FF2B5EF4-FFF2-40B4-BE49-F238E27FC236}">
-                <a16:creationId xmlns:a16="http://schemas.microsoft.com/office/drawing/2014/main" id="{E4569738-113F-F874-2875-405C8052CA6E}"/>
+                <a16:creationId xmlns:a16="http://schemas.microsoft.com/office/drawing/2014/main" id="{1549C90F-45ED-B3B2-EB45-508D4058995A}"/>
               </a:ext>
             </a:extLst>
           </p:cNvPr>
@@ -19149,10 +19113,10 @@
       </p:sp>
       <p:pic>
         <p:nvPicPr>
-          <p:cNvPr id="6" name="Imagen 5">
+          <p:cNvPr id="13" name="Imagen 12">
             <a:extLst>
               <a:ext uri="{FF2B5EF4-FFF2-40B4-BE49-F238E27FC236}">
-                <a16:creationId xmlns:a16="http://schemas.microsoft.com/office/drawing/2014/main" id="{F438458D-07A2-6454-15EC-DFD810CC89C2}"/>
+                <a16:creationId xmlns:a16="http://schemas.microsoft.com/office/drawing/2014/main" id="{E13DBB13-C45D-3BA8-A0AF-F4460C6C724D}"/>
               </a:ext>
             </a:extLst>
           </p:cNvPr>
@@ -19169,13 +19133,14 @@
               </a:ext>
             </a:extLst>
           </a:blip>
-          <a:srcRect l="67044" t="24665" r="-359" b="50950"/>
-          <a:stretch/>
+          <a:stretch>
+            <a:fillRect/>
+          </a:stretch>
         </p:blipFill>
         <p:spPr>
           <a:xfrm>
-            <a:off x="1234440" y="937508"/>
-            <a:ext cx="3205480" cy="2607059"/>
+            <a:off x="223935" y="1006150"/>
+            <a:ext cx="8957388" cy="4478695"/>
           </a:xfrm>
           <a:prstGeom prst="rect">
             <a:avLst/>
@@ -19184,10 +19149,10 @@
       </p:pic>
       <p:sp>
         <p:nvSpPr>
-          <p:cNvPr id="9" name="CuadroTexto 10">
+          <p:cNvPr id="15" name="CuadroTexto 10">
             <a:extLst>
               <a:ext uri="{FF2B5EF4-FFF2-40B4-BE49-F238E27FC236}">
-                <a16:creationId xmlns:a16="http://schemas.microsoft.com/office/drawing/2014/main" id="{1963F3A8-DB68-F37C-F7AD-65BDFDB074FB}"/>
+                <a16:creationId xmlns:a16="http://schemas.microsoft.com/office/drawing/2014/main" id="{376850FD-E880-7FF4-61E7-9A526E0ED34C}"/>
               </a:ext>
             </a:extLst>
           </p:cNvPr>
@@ -19196,8 +19161,8 @@
         </p:nvSpPr>
         <p:spPr>
           <a:xfrm>
-            <a:off x="7595119" y="4457406"/>
-            <a:ext cx="3872204" cy="923330"/>
+            <a:off x="6224763" y="3375849"/>
+            <a:ext cx="2956560" cy="2031325"/>
           </a:xfrm>
           <a:prstGeom prst="rect">
             <a:avLst/>
@@ -19306,31 +19271,73 @@
           <a:p>
             <a:pPr lvl="1" algn="ctr"/>
             <a:r>
+              <a:rPr lang="es-ES" b="1" dirty="0" err="1">
+                <a:latin typeface="Helvetica" panose="020B0604020202020204" pitchFamily="34" charset="0"/>
+                <a:cs typeface="Helvetica" panose="020B0604020202020204" pitchFamily="34" charset="0"/>
+              </a:rPr>
+              <a:t>Growth</a:t>
+            </a:r>
+            <a:r>
+              <a:rPr lang="es-ES" b="1" dirty="0">
+                <a:latin typeface="Helvetica" panose="020B0604020202020204" pitchFamily="34" charset="0"/>
+                <a:cs typeface="Helvetica" panose="020B0604020202020204" pitchFamily="34" charset="0"/>
+              </a:rPr>
+              <a:t> </a:t>
+            </a:r>
+            <a:r>
+              <a:rPr lang="es-ES" b="1" dirty="0" err="1">
+                <a:latin typeface="Helvetica" panose="020B0604020202020204" pitchFamily="34" charset="0"/>
+                <a:cs typeface="Helvetica" panose="020B0604020202020204" pitchFamily="34" charset="0"/>
+              </a:rPr>
+              <a:t>rates</a:t>
+            </a:r>
+            <a:r>
+              <a:rPr lang="es-ES" dirty="0">
+                <a:latin typeface="Helvetica" panose="020B0604020202020204" pitchFamily="34" charset="0"/>
+                <a:cs typeface="Helvetica" panose="020B0604020202020204" pitchFamily="34" charset="0"/>
+              </a:rPr>
+              <a:t> are more intense in </a:t>
+            </a:r>
+            <a:r>
               <a:rPr lang="es-ES" dirty="0" err="1">
                 <a:latin typeface="Helvetica" panose="020B0604020202020204" pitchFamily="34" charset="0"/>
                 <a:cs typeface="Helvetica" panose="020B0604020202020204" pitchFamily="34" charset="0"/>
               </a:rPr>
-              <a:t>Resistance</a:t>
+              <a:t>higher</a:t>
             </a:r>
             <a:r>
               <a:rPr lang="es-ES" dirty="0">
                 <a:latin typeface="Helvetica" panose="020B0604020202020204" pitchFamily="34" charset="0"/>
                 <a:cs typeface="Helvetica" panose="020B0604020202020204" pitchFamily="34" charset="0"/>
               </a:rPr>
-              <a:t> and </a:t>
+              <a:t> in </a:t>
             </a:r>
             <a:r>
               <a:rPr lang="es-ES" dirty="0" err="1">
                 <a:latin typeface="Helvetica" panose="020B0604020202020204" pitchFamily="34" charset="0"/>
                 <a:cs typeface="Helvetica" panose="020B0604020202020204" pitchFamily="34" charset="0"/>
               </a:rPr>
-              <a:t>Resilience</a:t>
+              <a:t>declining</a:t>
             </a:r>
             <a:r>
               <a:rPr lang="es-ES" dirty="0">
                 <a:latin typeface="Helvetica" panose="020B0604020202020204" pitchFamily="34" charset="0"/>
                 <a:cs typeface="Helvetica" panose="020B0604020202020204" pitchFamily="34" charset="0"/>
               </a:rPr>
+              <a:t> sites. </a:t>
+            </a:r>
+            <a:r>
+              <a:rPr lang="es-ES" dirty="0" err="1">
+                <a:latin typeface="Helvetica" panose="020B0604020202020204" pitchFamily="34" charset="0"/>
+                <a:cs typeface="Helvetica" panose="020B0604020202020204" pitchFamily="34" charset="0"/>
+              </a:rPr>
+              <a:t>Trees</a:t>
+            </a:r>
+            <a:r>
+              <a:rPr lang="es-ES" dirty="0">
+                <a:latin typeface="Helvetica" panose="020B0604020202020204" pitchFamily="34" charset="0"/>
+                <a:cs typeface="Helvetica" panose="020B0604020202020204" pitchFamily="34" charset="0"/>
+              </a:rPr>
               <a:t> </a:t>
             </a:r>
             <a:r>
@@ -19338,21 +19345,70 @@
                 <a:latin typeface="Helvetica" panose="020B0604020202020204" pitchFamily="34" charset="0"/>
                 <a:cs typeface="Helvetica" panose="020B0604020202020204" pitchFamily="34" charset="0"/>
               </a:rPr>
-              <a:t>values</a:t>
+              <a:t>with</a:t>
             </a:r>
             <a:r>
               <a:rPr lang="es-ES" dirty="0">
                 <a:latin typeface="Helvetica" panose="020B0604020202020204" pitchFamily="34" charset="0"/>
                 <a:cs typeface="Helvetica" panose="020B0604020202020204" pitchFamily="34" charset="0"/>
               </a:rPr>
-              <a:t> are </a:t>
+              <a:t> </a:t>
+            </a:r>
+            <a:r>
+              <a:rPr lang="es-ES" b="1" dirty="0" err="1">
+                <a:latin typeface="Helvetica" panose="020B0604020202020204" pitchFamily="34" charset="0"/>
+                <a:cs typeface="Helvetica" panose="020B0604020202020204" pitchFamily="34" charset="0"/>
+              </a:rPr>
+              <a:t>declining</a:t>
+            </a:r>
+            <a:r>
+              <a:rPr lang="es-ES" b="1" dirty="0">
+                <a:latin typeface="Helvetica" panose="020B0604020202020204" pitchFamily="34" charset="0"/>
+                <a:cs typeface="Helvetica" panose="020B0604020202020204" pitchFamily="34" charset="0"/>
+              </a:rPr>
+              <a:t> </a:t>
+            </a:r>
+            <a:r>
+              <a:rPr lang="es-ES" b="1" dirty="0" err="1">
+                <a:latin typeface="Helvetica" panose="020B0604020202020204" pitchFamily="34" charset="0"/>
+                <a:cs typeface="Helvetica" panose="020B0604020202020204" pitchFamily="34" charset="0"/>
+              </a:rPr>
+              <a:t>growth</a:t>
+            </a:r>
+            <a:r>
+              <a:rPr lang="es-ES" b="1" dirty="0">
+                <a:latin typeface="Helvetica" panose="020B0604020202020204" pitchFamily="34" charset="0"/>
+                <a:cs typeface="Helvetica" panose="020B0604020202020204" pitchFamily="34" charset="0"/>
+              </a:rPr>
+              <a:t> </a:t>
+            </a:r>
+            <a:r>
+              <a:rPr lang="es-ES" b="1" dirty="0" err="1">
+                <a:latin typeface="Helvetica" panose="020B0604020202020204" pitchFamily="34" charset="0"/>
+                <a:cs typeface="Helvetica" panose="020B0604020202020204" pitchFamily="34" charset="0"/>
+              </a:rPr>
+              <a:t>rates</a:t>
+            </a:r>
+            <a:r>
+              <a:rPr lang="es-ES" b="1" dirty="0">
+                <a:latin typeface="Helvetica" panose="020B0604020202020204" pitchFamily="34" charset="0"/>
+                <a:cs typeface="Helvetica" panose="020B0604020202020204" pitchFamily="34" charset="0"/>
+              </a:rPr>
+              <a:t> </a:t>
+            </a:r>
+            <a:r>
+              <a:rPr lang="es-ES" dirty="0">
+                <a:latin typeface="Helvetica" panose="020B0604020202020204" pitchFamily="34" charset="0"/>
+                <a:cs typeface="Helvetica" panose="020B0604020202020204" pitchFamily="34" charset="0"/>
+              </a:rPr>
+              <a:t>are more vulnerable </a:t>
             </a:r>
             <a:r>
               <a:rPr lang="es-ES" dirty="0" err="1">
                 <a:latin typeface="Helvetica" panose="020B0604020202020204" pitchFamily="34" charset="0"/>
                 <a:cs typeface="Helvetica" panose="020B0604020202020204" pitchFamily="34" charset="0"/>
               </a:rPr>
-              <a:t>different</a:t>
+              <a:t>to</a:t>
             </a:r>
             <a:r>
               <a:rPr lang="es-ES" dirty="0">
@@ -19366,77 +19422,7 @@
                 <a:latin typeface="Helvetica" panose="020B0604020202020204" pitchFamily="34" charset="0"/>
                 <a:cs typeface="Helvetica" panose="020B0604020202020204" pitchFamily="34" charset="0"/>
               </a:rPr>
-              <a:t>according</a:t>
-            </a:r>
-            <a:r>
-              <a:rPr lang="es-ES" dirty="0">
-                <a:latin typeface="Helvetica" panose="020B0604020202020204" pitchFamily="34" charset="0"/>
-                <a:cs typeface="Helvetica" panose="020B0604020202020204" pitchFamily="34" charset="0"/>
-              </a:rPr>
-              <a:t> </a:t>
-            </a:r>
-            <a:r>
-              <a:rPr lang="es-ES" dirty="0" err="1">
-                <a:latin typeface="Helvetica" panose="020B0604020202020204" pitchFamily="34" charset="0"/>
-                <a:cs typeface="Helvetica" panose="020B0604020202020204" pitchFamily="34" charset="0"/>
-              </a:rPr>
-              <a:t>to</a:t>
-            </a:r>
-            <a:r>
-              <a:rPr lang="es-ES" dirty="0">
-                <a:latin typeface="Helvetica" panose="020B0604020202020204" pitchFamily="34" charset="0"/>
-                <a:cs typeface="Helvetica" panose="020B0604020202020204" pitchFamily="34" charset="0"/>
-              </a:rPr>
-              <a:t> </a:t>
-            </a:r>
-            <a:r>
-              <a:rPr lang="es-ES" dirty="0" err="1">
-                <a:latin typeface="Helvetica" panose="020B0604020202020204" pitchFamily="34" charset="0"/>
-                <a:cs typeface="Helvetica" panose="020B0604020202020204" pitchFamily="34" charset="0"/>
-              </a:rPr>
-              <a:t>the</a:t>
-            </a:r>
-            <a:r>
-              <a:rPr lang="es-ES" dirty="0">
-                <a:latin typeface="Helvetica" panose="020B0604020202020204" pitchFamily="34" charset="0"/>
-                <a:cs typeface="Helvetica" panose="020B0604020202020204" pitchFamily="34" charset="0"/>
-              </a:rPr>
-              <a:t> </a:t>
-            </a:r>
-            <a:r>
-              <a:rPr lang="es-ES" dirty="0" err="1">
-                <a:latin typeface="Helvetica" panose="020B0604020202020204" pitchFamily="34" charset="0"/>
-                <a:cs typeface="Helvetica" panose="020B0604020202020204" pitchFamily="34" charset="0"/>
-              </a:rPr>
-              <a:t>year</a:t>
-            </a:r>
-            <a:r>
-              <a:rPr lang="es-ES" dirty="0">
-                <a:latin typeface="Helvetica" panose="020B0604020202020204" pitchFamily="34" charset="0"/>
-                <a:cs typeface="Helvetica" panose="020B0604020202020204" pitchFamily="34" charset="0"/>
-              </a:rPr>
-              <a:t> and </a:t>
-            </a:r>
-            <a:r>
-              <a:rPr lang="es-ES" dirty="0" err="1">
-                <a:latin typeface="Helvetica" panose="020B0604020202020204" pitchFamily="34" charset="0"/>
-                <a:cs typeface="Helvetica" panose="020B0604020202020204" pitchFamily="34" charset="0"/>
-              </a:rPr>
-              <a:t>the</a:t>
-            </a:r>
-            <a:r>
-              <a:rPr lang="es-ES" dirty="0">
-                <a:latin typeface="Helvetica" panose="020B0604020202020204" pitchFamily="34" charset="0"/>
-                <a:cs typeface="Helvetica" panose="020B0604020202020204" pitchFamily="34" charset="0"/>
-              </a:rPr>
-              <a:t> </a:t>
-            </a:r>
-            <a:r>
-              <a:rPr lang="es-ES" dirty="0" err="1">
-                <a:latin typeface="Helvetica" panose="020B0604020202020204" pitchFamily="34" charset="0"/>
-                <a:cs typeface="Helvetica" panose="020B0604020202020204" pitchFamily="34" charset="0"/>
-              </a:rPr>
-              <a:t>species</a:t>
+              <a:t>drought</a:t>
             </a:r>
             <a:endParaRPr lang="es-ES" dirty="0">
               <a:latin typeface="Helvetica" panose="020B0604020202020204" pitchFamily="34" charset="0"/>
@@ -19445,126 +19431,279 @@
           </a:p>
         </p:txBody>
       </p:sp>
-      <p:pic>
-        <p:nvPicPr>
-          <p:cNvPr id="4" name="Imagen 3">
+      <p:sp>
+        <p:nvSpPr>
+          <p:cNvPr id="16" name="CuadroTexto 10">
             <a:extLst>
               <a:ext uri="{FF2B5EF4-FFF2-40B4-BE49-F238E27FC236}">
-                <a16:creationId xmlns:a16="http://schemas.microsoft.com/office/drawing/2014/main" id="{9F708861-E722-E6AA-1AE5-7444F048B7AA}"/>
+                <a16:creationId xmlns:a16="http://schemas.microsoft.com/office/drawing/2014/main" id="{57FE396C-A654-0C38-F2C3-23BF5822CCB3}"/>
               </a:ext>
             </a:extLst>
           </p:cNvPr>
-          <p:cNvPicPr>
-            <a:picLocks noChangeAspect="1"/>
-          </p:cNvPicPr>
+          <p:cNvSpPr txBox="1"/>
           <p:nvPr/>
-        </p:nvPicPr>
-        <p:blipFill>
-          <a:blip r:embed="rId3">
-            <a:extLst>
-              <a:ext uri="{28A0092B-C50C-407E-A947-70E740481C1C}">
-                <a14:useLocalDpi xmlns:a14="http://schemas.microsoft.com/office/drawing/2010/main" val="0"/>
-              </a:ext>
-            </a:extLst>
-          </a:blip>
-          <a:srcRect l="-475" t="49349" r="33263" b="26266"/>
-          <a:stretch/>
-        </p:blipFill>
+        </p:nvSpPr>
         <p:spPr>
           <a:xfrm>
-            <a:off x="4518568" y="937508"/>
-            <a:ext cx="6467028" cy="2607059"/>
+            <a:off x="8907625" y="1477261"/>
+            <a:ext cx="3060440" cy="1477328"/>
           </a:xfrm>
           <a:prstGeom prst="rect">
             <a:avLst/>
           </a:prstGeom>
+          <a:noFill/>
         </p:spPr>
-      </p:pic>
-      <p:pic>
-        <p:nvPicPr>
-          <p:cNvPr id="10" name="Imagen 9">
-            <a:extLst>
-              <a:ext uri="{FF2B5EF4-FFF2-40B4-BE49-F238E27FC236}">
-                <a16:creationId xmlns:a16="http://schemas.microsoft.com/office/drawing/2014/main" id="{F6DA646B-2886-69BD-73C1-A198418D1044}"/>
-              </a:ext>
-            </a:extLst>
-          </p:cNvPr>
-          <p:cNvPicPr>
-            <a:picLocks noChangeAspect="1"/>
-          </p:cNvPicPr>
-          <p:nvPr/>
-        </p:nvPicPr>
-        <p:blipFill>
-          <a:blip r:embed="rId3">
-            <a:extLst>
-              <a:ext uri="{28A0092B-C50C-407E-A947-70E740481C1C}">
-                <a14:useLocalDpi xmlns:a14="http://schemas.microsoft.com/office/drawing/2010/main" val="0"/>
-              </a:ext>
-            </a:extLst>
-          </a:blip>
-          <a:srcRect l="66685" t="49652" b="25963"/>
-          <a:stretch/>
-        </p:blipFill>
-        <p:spPr>
-          <a:xfrm>
-            <a:off x="1234440" y="3615543"/>
-            <a:ext cx="3205480" cy="2607059"/>
-          </a:xfrm>
-          <a:prstGeom prst="rect">
-            <a:avLst/>
-          </a:prstGeom>
-        </p:spPr>
-      </p:pic>
-      <p:pic>
-        <p:nvPicPr>
-          <p:cNvPr id="11" name="Imagen 10">
-            <a:extLst>
-              <a:ext uri="{FF2B5EF4-FFF2-40B4-BE49-F238E27FC236}">
-                <a16:creationId xmlns:a16="http://schemas.microsoft.com/office/drawing/2014/main" id="{7EAF3FCA-BFB1-EEE7-4D5A-B7ADA2930AC4}"/>
-              </a:ext>
-            </a:extLst>
-          </p:cNvPr>
-          <p:cNvPicPr>
-            <a:picLocks noChangeAspect="1"/>
-          </p:cNvPicPr>
-          <p:nvPr/>
-        </p:nvPicPr>
-        <p:blipFill>
-          <a:blip r:embed="rId3">
-            <a:extLst>
-              <a:ext uri="{28A0092B-C50C-407E-A947-70E740481C1C}">
-                <a14:useLocalDpi xmlns:a14="http://schemas.microsoft.com/office/drawing/2010/main" val="0"/>
-              </a:ext>
-            </a:extLst>
-          </a:blip>
-          <a:srcRect l="291" t="74318" r="66394" b="1297"/>
-          <a:stretch/>
-        </p:blipFill>
-        <p:spPr>
-          <a:xfrm>
-            <a:off x="4546602" y="3615542"/>
-            <a:ext cx="3205480" cy="2607059"/>
-          </a:xfrm>
-          <a:prstGeom prst="rect">
-            <a:avLst/>
-          </a:prstGeom>
-        </p:spPr>
-      </p:pic>
+        <p:txBody>
+          <a:bodyPr wrap="square" rtlCol="0">
+            <a:spAutoFit/>
+          </a:bodyPr>
+          <a:lstStyle>
+            <a:defPPr>
+              <a:defRPr lang="es-ES"/>
+            </a:defPPr>
+            <a:lvl1pPr marL="0" algn="l" defTabSz="914400" rtl="0" eaLnBrk="1" latinLnBrk="0" hangingPunct="1">
+              <a:defRPr sz="1800" kern="1200">
+                <a:solidFill>
+                  <a:schemeClr val="tx1"/>
+                </a:solidFill>
+                <a:latin typeface="+mn-lt"/>
+                <a:ea typeface="+mn-ea"/>
+                <a:cs typeface="+mn-cs"/>
+              </a:defRPr>
+            </a:lvl1pPr>
+            <a:lvl2pPr marL="457200" algn="l" defTabSz="914400" rtl="0" eaLnBrk="1" latinLnBrk="0" hangingPunct="1">
+              <a:defRPr sz="1800" kern="1200">
+                <a:solidFill>
+                  <a:schemeClr val="tx1"/>
+                </a:solidFill>
+                <a:latin typeface="+mn-lt"/>
+                <a:ea typeface="+mn-ea"/>
+                <a:cs typeface="+mn-cs"/>
+              </a:defRPr>
+            </a:lvl2pPr>
+            <a:lvl3pPr marL="914400" algn="l" defTabSz="914400" rtl="0" eaLnBrk="1" latinLnBrk="0" hangingPunct="1">
+              <a:defRPr sz="1800" kern="1200">
+                <a:solidFill>
+                  <a:schemeClr val="tx1"/>
+                </a:solidFill>
+                <a:latin typeface="+mn-lt"/>
+                <a:ea typeface="+mn-ea"/>
+                <a:cs typeface="+mn-cs"/>
+              </a:defRPr>
+            </a:lvl3pPr>
+            <a:lvl4pPr marL="1371600" algn="l" defTabSz="914400" rtl="0" eaLnBrk="1" latinLnBrk="0" hangingPunct="1">
+              <a:defRPr sz="1800" kern="1200">
+                <a:solidFill>
+                  <a:schemeClr val="tx1"/>
+                </a:solidFill>
+                <a:latin typeface="+mn-lt"/>
+                <a:ea typeface="+mn-ea"/>
+                <a:cs typeface="+mn-cs"/>
+              </a:defRPr>
+            </a:lvl4pPr>
+            <a:lvl5pPr marL="1828800" algn="l" defTabSz="914400" rtl="0" eaLnBrk="1" latinLnBrk="0" hangingPunct="1">
+              <a:defRPr sz="1800" kern="1200">
+                <a:solidFill>
+                  <a:schemeClr val="tx1"/>
+                </a:solidFill>
+                <a:latin typeface="+mn-lt"/>
+                <a:ea typeface="+mn-ea"/>
+                <a:cs typeface="+mn-cs"/>
+              </a:defRPr>
+            </a:lvl5pPr>
+            <a:lvl6pPr marL="2286000" algn="l" defTabSz="914400" rtl="0" eaLnBrk="1" latinLnBrk="0" hangingPunct="1">
+              <a:defRPr sz="1800" kern="1200">
+                <a:solidFill>
+                  <a:schemeClr val="tx1"/>
+                </a:solidFill>
+                <a:latin typeface="+mn-lt"/>
+                <a:ea typeface="+mn-ea"/>
+                <a:cs typeface="+mn-cs"/>
+              </a:defRPr>
+            </a:lvl6pPr>
+            <a:lvl7pPr marL="2743200" algn="l" defTabSz="914400" rtl="0" eaLnBrk="1" latinLnBrk="0" hangingPunct="1">
+              <a:defRPr sz="1800" kern="1200">
+                <a:solidFill>
+                  <a:schemeClr val="tx1"/>
+                </a:solidFill>
+                <a:latin typeface="+mn-lt"/>
+                <a:ea typeface="+mn-ea"/>
+                <a:cs typeface="+mn-cs"/>
+              </a:defRPr>
+            </a:lvl7pPr>
+            <a:lvl8pPr marL="3200400" algn="l" defTabSz="914400" rtl="0" eaLnBrk="1" latinLnBrk="0" hangingPunct="1">
+              <a:defRPr sz="1800" kern="1200">
+                <a:solidFill>
+                  <a:schemeClr val="tx1"/>
+                </a:solidFill>
+                <a:latin typeface="+mn-lt"/>
+                <a:ea typeface="+mn-ea"/>
+                <a:cs typeface="+mn-cs"/>
+              </a:defRPr>
+            </a:lvl8pPr>
+            <a:lvl9pPr marL="3657600" algn="l" defTabSz="914400" rtl="0" eaLnBrk="1" latinLnBrk="0" hangingPunct="1">
+              <a:defRPr sz="1800" kern="1200">
+                <a:solidFill>
+                  <a:schemeClr val="tx1"/>
+                </a:solidFill>
+                <a:latin typeface="+mn-lt"/>
+                <a:ea typeface="+mn-ea"/>
+                <a:cs typeface="+mn-cs"/>
+              </a:defRPr>
+            </a:lvl9pPr>
+          </a:lstStyle>
+          <a:p>
+            <a:pPr lvl="1" algn="ctr"/>
+            <a:r>
+              <a:rPr lang="es-ES" dirty="0" err="1">
+                <a:latin typeface="Helvetica" panose="020B0604020202020204" pitchFamily="34" charset="0"/>
+                <a:cs typeface="Helvetica" panose="020B0604020202020204" pitchFamily="34" charset="0"/>
+              </a:rPr>
+              <a:t>Resistance</a:t>
+            </a:r>
+            <a:r>
+              <a:rPr lang="es-ES" dirty="0">
+                <a:latin typeface="Helvetica" panose="020B0604020202020204" pitchFamily="34" charset="0"/>
+                <a:cs typeface="Helvetica" panose="020B0604020202020204" pitchFamily="34" charset="0"/>
+              </a:rPr>
+              <a:t> and </a:t>
+            </a:r>
+            <a:r>
+              <a:rPr lang="es-ES" dirty="0" err="1">
+                <a:latin typeface="Helvetica" panose="020B0604020202020204" pitchFamily="34" charset="0"/>
+                <a:cs typeface="Helvetica" panose="020B0604020202020204" pitchFamily="34" charset="0"/>
+              </a:rPr>
+              <a:t>Resilience</a:t>
+            </a:r>
+            <a:r>
+              <a:rPr lang="es-ES" dirty="0">
+                <a:latin typeface="Helvetica" panose="020B0604020202020204" pitchFamily="34" charset="0"/>
+                <a:cs typeface="Helvetica" panose="020B0604020202020204" pitchFamily="34" charset="0"/>
+              </a:rPr>
+              <a:t> </a:t>
+            </a:r>
+            <a:r>
+              <a:rPr lang="es-ES" dirty="0" err="1">
+                <a:latin typeface="Helvetica" panose="020B0604020202020204" pitchFamily="34" charset="0"/>
+                <a:cs typeface="Helvetica" panose="020B0604020202020204" pitchFamily="34" charset="0"/>
+              </a:rPr>
+              <a:t>values</a:t>
+            </a:r>
+            <a:r>
+              <a:rPr lang="es-ES" dirty="0">
+                <a:latin typeface="Helvetica" panose="020B0604020202020204" pitchFamily="34" charset="0"/>
+                <a:cs typeface="Helvetica" panose="020B0604020202020204" pitchFamily="34" charset="0"/>
+              </a:rPr>
+              <a:t> are </a:t>
+            </a:r>
+            <a:r>
+              <a:rPr lang="es-ES" dirty="0" err="1">
+                <a:latin typeface="Helvetica" panose="020B0604020202020204" pitchFamily="34" charset="0"/>
+                <a:cs typeface="Helvetica" panose="020B0604020202020204" pitchFamily="34" charset="0"/>
+              </a:rPr>
+              <a:t>different</a:t>
+            </a:r>
+            <a:r>
+              <a:rPr lang="es-ES" dirty="0">
+                <a:latin typeface="Helvetica" panose="020B0604020202020204" pitchFamily="34" charset="0"/>
+                <a:cs typeface="Helvetica" panose="020B0604020202020204" pitchFamily="34" charset="0"/>
+              </a:rPr>
+              <a:t> </a:t>
+            </a:r>
+            <a:r>
+              <a:rPr lang="es-ES" dirty="0" err="1">
+                <a:latin typeface="Helvetica" panose="020B0604020202020204" pitchFamily="34" charset="0"/>
+                <a:cs typeface="Helvetica" panose="020B0604020202020204" pitchFamily="34" charset="0"/>
+              </a:rPr>
+              <a:t>according</a:t>
+            </a:r>
+            <a:r>
+              <a:rPr lang="es-ES" dirty="0">
+                <a:latin typeface="Helvetica" panose="020B0604020202020204" pitchFamily="34" charset="0"/>
+                <a:cs typeface="Helvetica" panose="020B0604020202020204" pitchFamily="34" charset="0"/>
+              </a:rPr>
+              <a:t> </a:t>
+            </a:r>
+            <a:r>
+              <a:rPr lang="es-ES" dirty="0" err="1">
+                <a:latin typeface="Helvetica" panose="020B0604020202020204" pitchFamily="34" charset="0"/>
+                <a:cs typeface="Helvetica" panose="020B0604020202020204" pitchFamily="34" charset="0"/>
+              </a:rPr>
+              <a:t>to</a:t>
+            </a:r>
+            <a:r>
+              <a:rPr lang="es-ES" dirty="0">
+                <a:latin typeface="Helvetica" panose="020B0604020202020204" pitchFamily="34" charset="0"/>
+                <a:cs typeface="Helvetica" panose="020B0604020202020204" pitchFamily="34" charset="0"/>
+              </a:rPr>
+              <a:t> </a:t>
+            </a:r>
+            <a:r>
+              <a:rPr lang="es-ES" dirty="0" err="1">
+                <a:latin typeface="Helvetica" panose="020B0604020202020204" pitchFamily="34" charset="0"/>
+                <a:cs typeface="Helvetica" panose="020B0604020202020204" pitchFamily="34" charset="0"/>
+              </a:rPr>
+              <a:t>the</a:t>
+            </a:r>
+            <a:r>
+              <a:rPr lang="es-ES" dirty="0">
+                <a:latin typeface="Helvetica" panose="020B0604020202020204" pitchFamily="34" charset="0"/>
+                <a:cs typeface="Helvetica" panose="020B0604020202020204" pitchFamily="34" charset="0"/>
+              </a:rPr>
+              <a:t> </a:t>
+            </a:r>
+            <a:r>
+              <a:rPr lang="es-ES" dirty="0" err="1">
+                <a:latin typeface="Helvetica" panose="020B0604020202020204" pitchFamily="34" charset="0"/>
+                <a:cs typeface="Helvetica" panose="020B0604020202020204" pitchFamily="34" charset="0"/>
+              </a:rPr>
+              <a:t>year</a:t>
+            </a:r>
+            <a:r>
+              <a:rPr lang="es-ES" dirty="0">
+                <a:latin typeface="Helvetica" panose="020B0604020202020204" pitchFamily="34" charset="0"/>
+                <a:cs typeface="Helvetica" panose="020B0604020202020204" pitchFamily="34" charset="0"/>
+              </a:rPr>
+              <a:t> and </a:t>
+            </a:r>
+            <a:r>
+              <a:rPr lang="es-ES" dirty="0" err="1">
+                <a:latin typeface="Helvetica" panose="020B0604020202020204" pitchFamily="34" charset="0"/>
+                <a:cs typeface="Helvetica" panose="020B0604020202020204" pitchFamily="34" charset="0"/>
+              </a:rPr>
+              <a:t>the</a:t>
+            </a:r>
+            <a:r>
+              <a:rPr lang="es-ES" dirty="0">
+                <a:latin typeface="Helvetica" panose="020B0604020202020204" pitchFamily="34" charset="0"/>
+                <a:cs typeface="Helvetica" panose="020B0604020202020204" pitchFamily="34" charset="0"/>
+              </a:rPr>
+              <a:t> </a:t>
+            </a:r>
+            <a:r>
+              <a:rPr lang="es-ES" dirty="0" err="1">
+                <a:latin typeface="Helvetica" panose="020B0604020202020204" pitchFamily="34" charset="0"/>
+                <a:cs typeface="Helvetica" panose="020B0604020202020204" pitchFamily="34" charset="0"/>
+              </a:rPr>
+              <a:t>species</a:t>
+            </a:r>
+            <a:endParaRPr lang="es-ES" dirty="0">
+              <a:latin typeface="Helvetica" panose="020B0604020202020204" pitchFamily="34" charset="0"/>
+              <a:cs typeface="Helvetica" panose="020B0604020202020204" pitchFamily="34" charset="0"/>
+            </a:endParaRPr>
+          </a:p>
+        </p:txBody>
+      </p:sp>
     </p:spTree>
     <p:extLst>
       <p:ext uri="{BB962C8B-B14F-4D97-AF65-F5344CB8AC3E}">
-        <p14:creationId xmlns:p14="http://schemas.microsoft.com/office/powerpoint/2010/main" val="128013919"/>
+        <p14:creationId xmlns:p14="http://schemas.microsoft.com/office/powerpoint/2010/main" val="660418765"/>
       </p:ext>
     </p:extLst>
   </p:cSld>
   <p:clrMapOvr>
     <a:masterClrMapping/>
   </p:clrMapOvr>
-  <p:extLst>
-    <p:ext uri="{6950BFC3-D8DA-4A85-94F7-54DA5524770B}">
-      <p188:commentRel xmlns:p188="http://schemas.microsoft.com/office/powerpoint/2018/8/main" r:id="rId2"/>
-    </p:ext>
-  </p:extLst>
 </p:sld>
 </file>
 
@@ -30767,10 +30906,10 @@
       </p:sp>
       <p:pic>
         <p:nvPicPr>
-          <p:cNvPr id="7" name="Imagen 6">
+          <p:cNvPr id="9" name="Imagen 8">
             <a:extLst>
               <a:ext uri="{FF2B5EF4-FFF2-40B4-BE49-F238E27FC236}">
-                <a16:creationId xmlns:a16="http://schemas.microsoft.com/office/drawing/2014/main" id="{3DCD98AE-E281-28B7-DDC6-9F8E6C5095C9}"/>
+                <a16:creationId xmlns:a16="http://schemas.microsoft.com/office/drawing/2014/main" id="{309A2C19-2DBA-1AE2-F8CF-9C15B2272987}"/>
               </a:ext>
             </a:extLst>
           </p:cNvPr>
@@ -30780,61 +30919,383 @@
           <p:nvPr/>
         </p:nvPicPr>
         <p:blipFill>
-          <a:blip r:embed="rId3">
+          <a:blip r:embed="rId2">
             <a:extLst>
               <a:ext uri="{28A0092B-C50C-407E-A947-70E740481C1C}">
                 <a14:useLocalDpi xmlns:a14="http://schemas.microsoft.com/office/drawing/2010/main" val="0"/>
               </a:ext>
             </a:extLst>
           </a:blip>
-          <a:srcRect t="5255"/>
-          <a:stretch/>
+          <a:srcRect t="7334" b="4493"/>
+          <a:stretch>
+            <a:fillRect/>
+          </a:stretch>
         </p:blipFill>
         <p:spPr>
           <a:xfrm>
-            <a:off x="3615224" y="920186"/>
-            <a:ext cx="8573689" cy="5846706"/>
+            <a:off x="3949147" y="811105"/>
+            <a:ext cx="6858000" cy="6046895"/>
           </a:xfrm>
           <a:prstGeom prst="rect">
             <a:avLst/>
           </a:prstGeom>
         </p:spPr>
       </p:pic>
-      <p:pic>
-        <p:nvPicPr>
-          <p:cNvPr id="8" name="Imagen 7">
+      <p:sp>
+        <p:nvSpPr>
+          <p:cNvPr id="10" name="Marcador de contenido 2">
             <a:extLst>
               <a:ext uri="{FF2B5EF4-FFF2-40B4-BE49-F238E27FC236}">
-                <a16:creationId xmlns:a16="http://schemas.microsoft.com/office/drawing/2014/main" id="{3E22E17E-5337-C684-089F-3EFE5D99CF6B}"/>
+                <a16:creationId xmlns:a16="http://schemas.microsoft.com/office/drawing/2014/main" id="{890B8ACB-5314-6A10-2AB3-9ECB817D1B6C}"/>
               </a:ext>
             </a:extLst>
           </p:cNvPr>
-          <p:cNvPicPr>
-            <a:picLocks noChangeAspect="1"/>
-          </p:cNvPicPr>
+          <p:cNvSpPr txBox="1">
+            <a:spLocks/>
+          </p:cNvSpPr>
           <p:nvPr/>
-        </p:nvPicPr>
-        <p:blipFill>
-          <a:blip r:embed="rId4">
-            <a:extLst>
-              <a:ext uri="{28A0092B-C50C-407E-A947-70E740481C1C}">
-                <a14:useLocalDpi xmlns:a14="http://schemas.microsoft.com/office/drawing/2010/main" val="0"/>
-              </a:ext>
-            </a:extLst>
-          </a:blip>
-          <a:srcRect t="9545" b="7334"/>
-          <a:stretch/>
-        </p:blipFill>
+        </p:nvSpPr>
         <p:spPr>
           <a:xfrm>
-            <a:off x="658548" y="1045028"/>
-            <a:ext cx="2833823" cy="2355479"/>
+            <a:off x="127518" y="990543"/>
+            <a:ext cx="3669229" cy="1355092"/>
           </a:xfrm>
           <a:prstGeom prst="rect">
             <a:avLst/>
           </a:prstGeom>
         </p:spPr>
-      </p:pic>
+        <p:txBody>
+          <a:bodyPr vert="horz" lIns="91440" tIns="45720" rIns="91440" bIns="45720" rtlCol="0" anchor="t">
+            <a:normAutofit/>
+          </a:bodyPr>
+          <a:lstStyle>
+            <a:lvl1pPr marL="228600" indent="-228600" algn="l" defTabSz="914400" rtl="0" eaLnBrk="1" latinLnBrk="0" hangingPunct="1">
+              <a:lnSpc>
+                <a:spcPct val="90000"/>
+              </a:lnSpc>
+              <a:spcBef>
+                <a:spcPts val="1000"/>
+              </a:spcBef>
+              <a:buFont typeface="Arial" panose="020B0604020202020204" pitchFamily="34" charset="0"/>
+              <a:buChar char="•"/>
+              <a:defRPr sz="2800" kern="1200">
+                <a:solidFill>
+                  <a:schemeClr val="tx1"/>
+                </a:solidFill>
+                <a:latin typeface="+mn-lt"/>
+                <a:ea typeface="+mn-ea"/>
+                <a:cs typeface="+mn-cs"/>
+              </a:defRPr>
+            </a:lvl1pPr>
+            <a:lvl2pPr marL="685800" indent="-228600" algn="l" defTabSz="914400" rtl="0" eaLnBrk="1" latinLnBrk="0" hangingPunct="1">
+              <a:lnSpc>
+                <a:spcPct val="90000"/>
+              </a:lnSpc>
+              <a:spcBef>
+                <a:spcPts val="500"/>
+              </a:spcBef>
+              <a:buFont typeface="Arial" panose="020B0604020202020204" pitchFamily="34" charset="0"/>
+              <a:buChar char="•"/>
+              <a:defRPr sz="2400" kern="1200">
+                <a:solidFill>
+                  <a:schemeClr val="tx1"/>
+                </a:solidFill>
+                <a:latin typeface="+mn-lt"/>
+                <a:ea typeface="+mn-ea"/>
+                <a:cs typeface="+mn-cs"/>
+              </a:defRPr>
+            </a:lvl2pPr>
+            <a:lvl3pPr marL="1143000" indent="-228600" algn="l" defTabSz="914400" rtl="0" eaLnBrk="1" latinLnBrk="0" hangingPunct="1">
+              <a:lnSpc>
+                <a:spcPct val="90000"/>
+              </a:lnSpc>
+              <a:spcBef>
+                <a:spcPts val="500"/>
+              </a:spcBef>
+              <a:buFont typeface="Arial" panose="020B0604020202020204" pitchFamily="34" charset="0"/>
+              <a:buChar char="•"/>
+              <a:defRPr sz="2000" kern="1200">
+                <a:solidFill>
+                  <a:schemeClr val="tx1"/>
+                </a:solidFill>
+                <a:latin typeface="+mn-lt"/>
+                <a:ea typeface="+mn-ea"/>
+                <a:cs typeface="+mn-cs"/>
+              </a:defRPr>
+            </a:lvl3pPr>
+            <a:lvl4pPr marL="1600200" indent="-228600" algn="l" defTabSz="914400" rtl="0" eaLnBrk="1" latinLnBrk="0" hangingPunct="1">
+              <a:lnSpc>
+                <a:spcPct val="90000"/>
+              </a:lnSpc>
+              <a:spcBef>
+                <a:spcPts val="500"/>
+              </a:spcBef>
+              <a:buFont typeface="Arial" panose="020B0604020202020204" pitchFamily="34" charset="0"/>
+              <a:buChar char="•"/>
+              <a:defRPr sz="1800" kern="1200">
+                <a:solidFill>
+                  <a:schemeClr val="tx1"/>
+                </a:solidFill>
+                <a:latin typeface="+mn-lt"/>
+                <a:ea typeface="+mn-ea"/>
+                <a:cs typeface="+mn-cs"/>
+              </a:defRPr>
+            </a:lvl4pPr>
+            <a:lvl5pPr marL="2057400" indent="-228600" algn="l" defTabSz="914400" rtl="0" eaLnBrk="1" latinLnBrk="0" hangingPunct="1">
+              <a:lnSpc>
+                <a:spcPct val="90000"/>
+              </a:lnSpc>
+              <a:spcBef>
+                <a:spcPts val="500"/>
+              </a:spcBef>
+              <a:buFont typeface="Arial" panose="020B0604020202020204" pitchFamily="34" charset="0"/>
+              <a:buChar char="•"/>
+              <a:defRPr sz="1800" kern="1200">
+                <a:solidFill>
+                  <a:schemeClr val="tx1"/>
+                </a:solidFill>
+                <a:latin typeface="+mn-lt"/>
+                <a:ea typeface="+mn-ea"/>
+                <a:cs typeface="+mn-cs"/>
+              </a:defRPr>
+            </a:lvl5pPr>
+            <a:lvl6pPr marL="2514600" indent="-228600" algn="l" defTabSz="914400" rtl="0" eaLnBrk="1" latinLnBrk="0" hangingPunct="1">
+              <a:lnSpc>
+                <a:spcPct val="90000"/>
+              </a:lnSpc>
+              <a:spcBef>
+                <a:spcPts val="500"/>
+              </a:spcBef>
+              <a:buFont typeface="Arial" panose="020B0604020202020204" pitchFamily="34" charset="0"/>
+              <a:buChar char="•"/>
+              <a:defRPr sz="1800" kern="1200">
+                <a:solidFill>
+                  <a:schemeClr val="tx1"/>
+                </a:solidFill>
+                <a:latin typeface="+mn-lt"/>
+                <a:ea typeface="+mn-ea"/>
+                <a:cs typeface="+mn-cs"/>
+              </a:defRPr>
+            </a:lvl6pPr>
+            <a:lvl7pPr marL="2971800" indent="-228600" algn="l" defTabSz="914400" rtl="0" eaLnBrk="1" latinLnBrk="0" hangingPunct="1">
+              <a:lnSpc>
+                <a:spcPct val="90000"/>
+              </a:lnSpc>
+              <a:spcBef>
+                <a:spcPts val="500"/>
+              </a:spcBef>
+              <a:buFont typeface="Arial" panose="020B0604020202020204" pitchFamily="34" charset="0"/>
+              <a:buChar char="•"/>
+              <a:defRPr sz="1800" kern="1200">
+                <a:solidFill>
+                  <a:schemeClr val="tx1"/>
+                </a:solidFill>
+                <a:latin typeface="+mn-lt"/>
+                <a:ea typeface="+mn-ea"/>
+                <a:cs typeface="+mn-cs"/>
+              </a:defRPr>
+            </a:lvl7pPr>
+            <a:lvl8pPr marL="3429000" indent="-228600" algn="l" defTabSz="914400" rtl="0" eaLnBrk="1" latinLnBrk="0" hangingPunct="1">
+              <a:lnSpc>
+                <a:spcPct val="90000"/>
+              </a:lnSpc>
+              <a:spcBef>
+                <a:spcPts val="500"/>
+              </a:spcBef>
+              <a:buFont typeface="Arial" panose="020B0604020202020204" pitchFamily="34" charset="0"/>
+              <a:buChar char="•"/>
+              <a:defRPr sz="1800" kern="1200">
+                <a:solidFill>
+                  <a:schemeClr val="tx1"/>
+                </a:solidFill>
+                <a:latin typeface="+mn-lt"/>
+                <a:ea typeface="+mn-ea"/>
+                <a:cs typeface="+mn-cs"/>
+              </a:defRPr>
+            </a:lvl8pPr>
+            <a:lvl9pPr marL="3886200" indent="-228600" algn="l" defTabSz="914400" rtl="0" eaLnBrk="1" latinLnBrk="0" hangingPunct="1">
+              <a:lnSpc>
+                <a:spcPct val="90000"/>
+              </a:lnSpc>
+              <a:spcBef>
+                <a:spcPts val="500"/>
+              </a:spcBef>
+              <a:buFont typeface="Arial" panose="020B0604020202020204" pitchFamily="34" charset="0"/>
+              <a:buChar char="•"/>
+              <a:defRPr sz="1800" kern="1200">
+                <a:solidFill>
+                  <a:schemeClr val="tx1"/>
+                </a:solidFill>
+                <a:latin typeface="+mn-lt"/>
+                <a:ea typeface="+mn-ea"/>
+                <a:cs typeface="+mn-cs"/>
+              </a:defRPr>
+            </a:lvl9pPr>
+          </a:lstStyle>
+          <a:p>
+            <a:pPr marL="457200" lvl="1" indent="0" algn="just">
+              <a:buClr>
+                <a:srgbClr val="218317"/>
+              </a:buClr>
+              <a:buNone/>
+            </a:pPr>
+            <a:r>
+              <a:rPr lang="es-ES" sz="2000" dirty="0">
+                <a:latin typeface="Helvetica" panose="020B0604020202020204" pitchFamily="34" charset="0"/>
+                <a:cs typeface="Helvetica" panose="020B0604020202020204" pitchFamily="34" charset="0"/>
+              </a:rPr>
+              <a:t>Fig. 1.: </a:t>
+            </a:r>
+            <a:r>
+              <a:rPr lang="es-ES" sz="2000" dirty="0" err="1">
+                <a:latin typeface="Helvetica" panose="020B0604020202020204" pitchFamily="34" charset="0"/>
+                <a:cs typeface="Helvetica" panose="020B0604020202020204" pitchFamily="34" charset="0"/>
+              </a:rPr>
+              <a:t>Study</a:t>
+            </a:r>
+            <a:r>
+              <a:rPr lang="es-ES" sz="2000" dirty="0">
+                <a:latin typeface="Helvetica" panose="020B0604020202020204" pitchFamily="34" charset="0"/>
+                <a:cs typeface="Helvetica" panose="020B0604020202020204" pitchFamily="34" charset="0"/>
+              </a:rPr>
+              <a:t> sites in Iberia. </a:t>
+            </a:r>
+            <a:r>
+              <a:rPr lang="es-ES" sz="2000" dirty="0" err="1">
+                <a:latin typeface="Helvetica" panose="020B0604020202020204" pitchFamily="34" charset="0"/>
+                <a:cs typeface="Helvetica" panose="020B0604020202020204" pitchFamily="34" charset="0"/>
+              </a:rPr>
+              <a:t>Coloured</a:t>
+            </a:r>
+            <a:r>
+              <a:rPr lang="es-ES" sz="2000" dirty="0">
+                <a:latin typeface="Helvetica" panose="020B0604020202020204" pitchFamily="34" charset="0"/>
+                <a:cs typeface="Helvetica" panose="020B0604020202020204" pitchFamily="34" charset="0"/>
+              </a:rPr>
+              <a:t> </a:t>
+            </a:r>
+            <a:r>
+              <a:rPr lang="es-ES" sz="2000" dirty="0" err="1">
+                <a:latin typeface="Helvetica" panose="020B0604020202020204" pitchFamily="34" charset="0"/>
+                <a:cs typeface="Helvetica" panose="020B0604020202020204" pitchFamily="34" charset="0"/>
+              </a:rPr>
+              <a:t>areas</a:t>
+            </a:r>
+            <a:r>
+              <a:rPr lang="es-ES" sz="2000" dirty="0">
+                <a:latin typeface="Helvetica" panose="020B0604020202020204" pitchFamily="34" charset="0"/>
+                <a:cs typeface="Helvetica" panose="020B0604020202020204" pitchFamily="34" charset="0"/>
+              </a:rPr>
+              <a:t> </a:t>
+            </a:r>
+            <a:r>
+              <a:rPr lang="es-ES" sz="2000" dirty="0" err="1">
+                <a:latin typeface="Helvetica" panose="020B0604020202020204" pitchFamily="34" charset="0"/>
+                <a:cs typeface="Helvetica" panose="020B0604020202020204" pitchFamily="34" charset="0"/>
+              </a:rPr>
+              <a:t>represent</a:t>
+            </a:r>
+            <a:r>
+              <a:rPr lang="es-ES" sz="2000" dirty="0">
+                <a:latin typeface="Helvetica" panose="020B0604020202020204" pitchFamily="34" charset="0"/>
+                <a:cs typeface="Helvetica" panose="020B0604020202020204" pitchFamily="34" charset="0"/>
+              </a:rPr>
+              <a:t> </a:t>
+            </a:r>
+            <a:r>
+              <a:rPr lang="es-ES" sz="2000" dirty="0" err="1">
+                <a:latin typeface="Helvetica" panose="020B0604020202020204" pitchFamily="34" charset="0"/>
+                <a:cs typeface="Helvetica" panose="020B0604020202020204" pitchFamily="34" charset="0"/>
+              </a:rPr>
+              <a:t>the</a:t>
+            </a:r>
+            <a:r>
+              <a:rPr lang="es-ES" sz="2000" dirty="0">
+                <a:latin typeface="Helvetica" panose="020B0604020202020204" pitchFamily="34" charset="0"/>
+                <a:cs typeface="Helvetica" panose="020B0604020202020204" pitchFamily="34" charset="0"/>
+              </a:rPr>
+              <a:t> </a:t>
+            </a:r>
+            <a:r>
+              <a:rPr lang="es-ES" sz="2000" dirty="0" err="1">
+                <a:latin typeface="Helvetica" panose="020B0604020202020204" pitchFamily="34" charset="0"/>
+                <a:cs typeface="Helvetica" panose="020B0604020202020204" pitchFamily="34" charset="0"/>
+              </a:rPr>
+              <a:t>distribution</a:t>
+            </a:r>
+            <a:r>
+              <a:rPr lang="es-ES" sz="2000" dirty="0">
+                <a:latin typeface="Helvetica" panose="020B0604020202020204" pitchFamily="34" charset="0"/>
+                <a:cs typeface="Helvetica" panose="020B0604020202020204" pitchFamily="34" charset="0"/>
+              </a:rPr>
+              <a:t> </a:t>
+            </a:r>
+            <a:r>
+              <a:rPr lang="es-ES" sz="2000" dirty="0" err="1">
+                <a:latin typeface="Helvetica" panose="020B0604020202020204" pitchFamily="34" charset="0"/>
+                <a:cs typeface="Helvetica" panose="020B0604020202020204" pitchFamily="34" charset="0"/>
+              </a:rPr>
+              <a:t>area</a:t>
+            </a:r>
+            <a:r>
+              <a:rPr lang="es-ES" sz="2000" dirty="0">
+                <a:latin typeface="Helvetica" panose="020B0604020202020204" pitchFamily="34" charset="0"/>
+                <a:cs typeface="Helvetica" panose="020B0604020202020204" pitchFamily="34" charset="0"/>
+              </a:rPr>
+              <a:t> </a:t>
+            </a:r>
+            <a:r>
+              <a:rPr lang="es-ES" sz="2000" dirty="0" err="1">
+                <a:latin typeface="Helvetica" panose="020B0604020202020204" pitchFamily="34" charset="0"/>
+                <a:cs typeface="Helvetica" panose="020B0604020202020204" pitchFamily="34" charset="0"/>
+              </a:rPr>
+              <a:t>of</a:t>
+            </a:r>
+            <a:r>
+              <a:rPr lang="es-ES" sz="2000" dirty="0">
+                <a:latin typeface="Helvetica" panose="020B0604020202020204" pitchFamily="34" charset="0"/>
+                <a:cs typeface="Helvetica" panose="020B0604020202020204" pitchFamily="34" charset="0"/>
+              </a:rPr>
+              <a:t> </a:t>
+            </a:r>
+            <a:r>
+              <a:rPr lang="es-ES" sz="2000" dirty="0" err="1">
+                <a:latin typeface="Helvetica" panose="020B0604020202020204" pitchFamily="34" charset="0"/>
+                <a:cs typeface="Helvetica" panose="020B0604020202020204" pitchFamily="34" charset="0"/>
+              </a:rPr>
+              <a:t>each</a:t>
+            </a:r>
+            <a:r>
+              <a:rPr lang="es-ES" sz="2000" dirty="0">
+                <a:latin typeface="Helvetica" panose="020B0604020202020204" pitchFamily="34" charset="0"/>
+                <a:cs typeface="Helvetica" panose="020B0604020202020204" pitchFamily="34" charset="0"/>
+              </a:rPr>
+              <a:t> </a:t>
+            </a:r>
+            <a:r>
+              <a:rPr lang="es-ES" sz="2000" dirty="0" err="1">
+                <a:latin typeface="Helvetica" panose="020B0604020202020204" pitchFamily="34" charset="0"/>
+                <a:cs typeface="Helvetica" panose="020B0604020202020204" pitchFamily="34" charset="0"/>
+              </a:rPr>
+              <a:t>species</a:t>
+            </a:r>
+            <a:r>
+              <a:rPr lang="es-ES" sz="2000" dirty="0">
+                <a:latin typeface="Helvetica" panose="020B0604020202020204" pitchFamily="34" charset="0"/>
+                <a:cs typeface="Helvetica" panose="020B0604020202020204" pitchFamily="34" charset="0"/>
+              </a:rPr>
+              <a:t>.</a:t>
+            </a:r>
+          </a:p>
+          <a:p>
+            <a:pPr algn="just"/>
+            <a:endParaRPr lang="es-ES" sz="2400" dirty="0">
+              <a:latin typeface="Helvetica" panose="020B0604020202020204" pitchFamily="34" charset="0"/>
+              <a:cs typeface="Helvetica" panose="020B0604020202020204" pitchFamily="34" charset="0"/>
+            </a:endParaRPr>
+          </a:p>
+        </p:txBody>
+      </p:sp>
     </p:spTree>
     <p:extLst>
       <p:ext uri="{BB962C8B-B14F-4D97-AF65-F5344CB8AC3E}">
@@ -30845,11 +31306,6 @@
   <p:clrMapOvr>
     <a:masterClrMapping/>
   </p:clrMapOvr>
-  <p:extLst>
-    <p:ext uri="{6950BFC3-D8DA-4A85-94F7-54DA5524770B}">
-      <p188:commentRel xmlns:p188="http://schemas.microsoft.com/office/powerpoint/2018/8/main" r:id="rId2"/>
-    </p:ext>
-  </p:extLst>
 </p:sld>
 </file>
 
@@ -32861,7 +33317,7 @@
         </p:nvSpPr>
         <p:spPr>
           <a:xfrm>
-            <a:off x="623545" y="2760950"/>
+            <a:off x="623545" y="2521266"/>
             <a:ext cx="10925077" cy="1146828"/>
           </a:xfrm>
           <a:prstGeom prst="rect">
@@ -33144,6 +33600,20 @@
                 <a:cs typeface="Helvetica"/>
               </a:rPr>
               <a:t>growth</a:t>
+            </a:r>
+            <a:r>
+              <a:rPr lang="es-ES" sz="2400" i="1" dirty="0">
+                <a:latin typeface="Helvetica"/>
+                <a:cs typeface="Helvetica"/>
+              </a:rPr>
+              <a:t> and </a:t>
+            </a:r>
+            <a:r>
+              <a:rPr lang="es-ES" sz="2400" i="1" dirty="0" err="1">
+                <a:latin typeface="Helvetica"/>
+                <a:cs typeface="Helvetica"/>
+              </a:rPr>
+              <a:t>resilience</a:t>
             </a:r>
             <a:r>
               <a:rPr lang="es-ES" sz="2400" i="1" dirty="0">
@@ -33460,8 +33930,8 @@
         </p:nvSpPr>
         <p:spPr>
           <a:xfrm>
-            <a:off x="643378" y="3907778"/>
-            <a:ext cx="10925077" cy="2561279"/>
+            <a:off x="643378" y="3359019"/>
+            <a:ext cx="11206500" cy="3293707"/>
           </a:xfrm>
           <a:prstGeom prst="rect">
             <a:avLst/>
@@ -33469,7 +33939,7 @@
         </p:spPr>
         <p:txBody>
           <a:bodyPr vert="horz" lIns="91440" tIns="45720" rIns="91440" bIns="45720" rtlCol="0" anchor="t">
-            <a:normAutofit lnSpcReduction="10000"/>
+            <a:normAutofit/>
           </a:bodyPr>
           <a:lstStyle>
             <a:lvl1pPr marL="228600" indent="-228600" algn="l" defTabSz="914400" rtl="0" eaLnBrk="1" latinLnBrk="0" hangingPunct="1">
@@ -33987,30 +34457,76 @@
                 <a:latin typeface="Helvetica"/>
                 <a:cs typeface="Helvetica"/>
               </a:rPr>
+              <a:t>, and </a:t>
+            </a:r>
+            <a:r>
+              <a:rPr lang="es-ES" sz="2400" b="1" dirty="0" err="1">
+                <a:latin typeface="Helvetica"/>
+                <a:cs typeface="Helvetica"/>
+              </a:rPr>
+              <a:t>resilience</a:t>
+            </a:r>
+            <a:r>
+              <a:rPr lang="es-ES" sz="2400" b="1" dirty="0">
+                <a:latin typeface="Helvetica"/>
+                <a:cs typeface="Helvetica"/>
+              </a:rPr>
+              <a:t> </a:t>
+            </a:r>
+            <a:r>
+              <a:rPr lang="es-ES" sz="2400" dirty="0">
+                <a:latin typeface="Helvetica"/>
+                <a:cs typeface="Helvetica"/>
+              </a:rPr>
+              <a:t> </a:t>
+            </a:r>
+            <a:r>
+              <a:rPr lang="es-ES" sz="2400" dirty="0">
+                <a:latin typeface="Helvetica"/>
+                <a:cs typeface="Helvetica"/>
+                <a:sym typeface="Wingdings" panose="05000000000000000000" pitchFamily="2" charset="2"/>
+              </a:rPr>
+              <a:t> </a:t>
+            </a:r>
+            <a:r>
+              <a:rPr lang="es-ES" sz="2400" b="1" dirty="0">
+                <a:latin typeface="Helvetica"/>
+                <a:cs typeface="Helvetica"/>
+                <a:sym typeface="Wingdings" panose="05000000000000000000" pitchFamily="2" charset="2"/>
+              </a:rPr>
+              <a:t>↓ BAI, </a:t>
+            </a:r>
+            <a:r>
+              <a:rPr lang="es-ES" sz="2400" b="1" dirty="0" err="1">
+                <a:latin typeface="Helvetica"/>
+                <a:cs typeface="Helvetica"/>
+                <a:sym typeface="Wingdings" panose="05000000000000000000" pitchFamily="2" charset="2"/>
+              </a:rPr>
+              <a:t>Rt</a:t>
+            </a:r>
+            <a:r>
+              <a:rPr lang="es-ES" sz="2400" b="1" dirty="0">
+                <a:latin typeface="Helvetica"/>
+                <a:cs typeface="Helvetica"/>
+                <a:sym typeface="Wingdings" panose="05000000000000000000" pitchFamily="2" charset="2"/>
+              </a:rPr>
+              <a:t> &amp; </a:t>
+            </a:r>
+            <a:r>
+              <a:rPr lang="es-ES" sz="2400" b="1" dirty="0" err="1">
+                <a:latin typeface="Helvetica"/>
+                <a:cs typeface="Helvetica"/>
+                <a:sym typeface="Wingdings" panose="05000000000000000000" pitchFamily="2" charset="2"/>
+              </a:rPr>
+              <a:t>Rs</a:t>
+            </a:r>
+            <a:r>
+              <a:rPr lang="es-ES" sz="2400" b="1" dirty="0">
+                <a:latin typeface="Helvetica"/>
+                <a:cs typeface="Helvetica"/>
+                <a:sym typeface="Wingdings" panose="05000000000000000000" pitchFamily="2" charset="2"/>
+              </a:rPr>
               <a:t> in </a:t>
-            </a:r>
-            <a:r>
-              <a:rPr lang="es-ES" sz="2400" dirty="0">
-                <a:latin typeface="Helvetica"/>
-                <a:cs typeface="Helvetica"/>
-              </a:rPr>
-              <a:t> </a:t>
-            </a:r>
-            <a:r>
-              <a:rPr lang="es-ES" sz="2400" dirty="0">
-                <a:latin typeface="Helvetica"/>
-                <a:cs typeface="Helvetica"/>
-                <a:sym typeface="Wingdings" panose="05000000000000000000" pitchFamily="2" charset="2"/>
-              </a:rPr>
-              <a:t> </a:t>
-            </a:r>
-            <a:r>
-              <a:rPr lang="es-ES" sz="2400" b="1" dirty="0">
-                <a:latin typeface="Helvetica"/>
-                <a:cs typeface="Helvetica"/>
-                <a:sym typeface="Wingdings" panose="05000000000000000000" pitchFamily="2" charset="2"/>
-              </a:rPr>
-              <a:t>↓ BAI in </a:t>
             </a:r>
             <a:r>
               <a:rPr lang="es-ES" sz="2400" b="1" dirty="0" err="1">
@@ -34143,7 +34659,23 @@
                 <a:cs typeface="Helvetica"/>
                 <a:sym typeface="Wingdings" panose="05000000000000000000" pitchFamily="2" charset="2"/>
               </a:rPr>
-              <a:t> los  </a:t>
+              <a:t> </a:t>
+            </a:r>
+            <a:r>
+              <a:rPr lang="es-ES" sz="2400" dirty="0" err="1">
+                <a:latin typeface="Helvetica"/>
+                <a:cs typeface="Helvetica"/>
+                <a:sym typeface="Wingdings" panose="05000000000000000000" pitchFamily="2" charset="2"/>
+              </a:rPr>
+              <a:t>loss</a:t>
+            </a:r>
+            <a:r>
+              <a:rPr lang="es-ES" sz="2400" dirty="0">
+                <a:latin typeface="Helvetica"/>
+                <a:cs typeface="Helvetica"/>
+                <a:sym typeface="Wingdings" panose="05000000000000000000" pitchFamily="2" charset="2"/>
+              </a:rPr>
+              <a:t>  </a:t>
             </a:r>
             <a:r>
               <a:rPr lang="es-ES" sz="2400" b="1" dirty="0">

</xml_diff>

<commit_message>
Created boxplots for the responses :)
</commit_message>
<xml_diff>
--- a/06_ppts/exploratory_analysis_figures_v3-CFB-CG.pptx
+++ b/06_ppts/exploratory_analysis_figures_v3-CFB-CG.pptx
@@ -5,7 +5,7 @@
     <p:sldMasterId id="2147483648" r:id="rId1"/>
   </p:sldMasterIdLst>
   <p:notesMasterIdLst>
-    <p:notesMasterId r:id="rId21"/>
+    <p:notesMasterId r:id="rId22"/>
   </p:notesMasterIdLst>
   <p:sldIdLst>
     <p:sldId id="257" r:id="rId2"/>
@@ -27,6 +27,7 @@
     <p:sldId id="413" r:id="rId18"/>
     <p:sldId id="417" r:id="rId19"/>
     <p:sldId id="418" r:id="rId20"/>
+    <p:sldId id="419" r:id="rId21"/>
   </p:sldIdLst>
   <p:sldSz cx="12192000" cy="6858000"/>
   <p:notesSz cx="6858000" cy="9144000"/>
@@ -1111,6 +1112,114 @@
     <p:extLst>
       <p:ext uri="{BB962C8B-B14F-4D97-AF65-F5344CB8AC3E}">
         <p14:creationId xmlns:p14="http://schemas.microsoft.com/office/powerpoint/2010/main" val="2778219967"/>
+      </p:ext>
+    </p:extLst>
+  </p:cSld>
+  <p:clrMapOvr>
+    <a:masterClrMapping/>
+  </p:clrMapOvr>
+</p:notes>
+</file>
+
+<file path=ppt/notesSlides/notesSlide6.xml><?xml version="1.0" encoding="utf-8"?>
+<p:notes xmlns:a="http://schemas.openxmlformats.org/drawingml/2006/main" xmlns:r="http://schemas.openxmlformats.org/officeDocument/2006/relationships" xmlns:p="http://schemas.openxmlformats.org/presentationml/2006/main">
+  <p:cSld>
+    <p:spTree>
+      <p:nvGrpSpPr>
+        <p:cNvPr id="1" name="">
+          <a:extLst>
+            <a:ext uri="{FF2B5EF4-FFF2-40B4-BE49-F238E27FC236}">
+              <a16:creationId xmlns:a16="http://schemas.microsoft.com/office/drawing/2014/main" id="{0A728F5F-221D-C4EE-213E-013A839F67BD}"/>
+            </a:ext>
+          </a:extLst>
+        </p:cNvPr>
+        <p:cNvGrpSpPr/>
+        <p:nvPr/>
+      </p:nvGrpSpPr>
+      <p:grpSpPr>
+        <a:xfrm>
+          <a:off x="0" y="0"/>
+          <a:ext cx="0" cy="0"/>
+          <a:chOff x="0" y="0"/>
+          <a:chExt cx="0" cy="0"/>
+        </a:xfrm>
+      </p:grpSpPr>
+      <p:sp>
+        <p:nvSpPr>
+          <p:cNvPr id="2" name="Marcador de imagen de diapositiva 1">
+            <a:extLst>
+              <a:ext uri="{FF2B5EF4-FFF2-40B4-BE49-F238E27FC236}">
+                <a16:creationId xmlns:a16="http://schemas.microsoft.com/office/drawing/2014/main" id="{FF7E85AA-05C4-D6E2-E11F-5A7CB29D8B5D}"/>
+              </a:ext>
+            </a:extLst>
+          </p:cNvPr>
+          <p:cNvSpPr>
+            <a:spLocks noGrp="1" noRot="1" noChangeAspect="1"/>
+          </p:cNvSpPr>
+          <p:nvPr>
+            <p:ph type="sldImg"/>
+          </p:nvPr>
+        </p:nvSpPr>
+        <p:spPr/>
+      </p:sp>
+      <p:sp>
+        <p:nvSpPr>
+          <p:cNvPr id="3" name="Marcador de notas 2">
+            <a:extLst>
+              <a:ext uri="{FF2B5EF4-FFF2-40B4-BE49-F238E27FC236}">
+                <a16:creationId xmlns:a16="http://schemas.microsoft.com/office/drawing/2014/main" id="{A02E503E-6750-5E62-8871-4E5E1C374273}"/>
+              </a:ext>
+            </a:extLst>
+          </p:cNvPr>
+          <p:cNvSpPr>
+            <a:spLocks noGrp="1"/>
+          </p:cNvSpPr>
+          <p:nvPr>
+            <p:ph type="body" idx="1"/>
+          </p:nvPr>
+        </p:nvSpPr>
+        <p:spPr/>
+        <p:txBody>
+          <a:bodyPr/>
+          <a:lstStyle/>
+          <a:p>
+            <a:endParaRPr lang="es-ES" dirty="0"/>
+          </a:p>
+        </p:txBody>
+      </p:sp>
+      <p:sp>
+        <p:nvSpPr>
+          <p:cNvPr id="4" name="Marcador de número de diapositiva 3">
+            <a:extLst>
+              <a:ext uri="{FF2B5EF4-FFF2-40B4-BE49-F238E27FC236}">
+                <a16:creationId xmlns:a16="http://schemas.microsoft.com/office/drawing/2014/main" id="{1C7252C7-98D8-DC13-5C33-3632D72200AD}"/>
+              </a:ext>
+            </a:extLst>
+          </p:cNvPr>
+          <p:cNvSpPr>
+            <a:spLocks noGrp="1"/>
+          </p:cNvSpPr>
+          <p:nvPr>
+            <p:ph type="sldNum" sz="quarter" idx="5"/>
+          </p:nvPr>
+        </p:nvSpPr>
+        <p:spPr/>
+        <p:txBody>
+          <a:bodyPr/>
+          <a:lstStyle/>
+          <a:p>
+            <a:fld id="{95285FFF-AA8A-422F-901E-D94C39C8B224}" type="slidenum">
+              <a:rPr lang="es-ES" smtClean="0"/>
+              <a:t>20</a:t>
+            </a:fld>
+            <a:endParaRPr lang="es-ES"/>
+          </a:p>
+        </p:txBody>
+      </p:sp>
+    </p:spTree>
+    <p:extLst>
+      <p:ext uri="{BB962C8B-B14F-4D97-AF65-F5344CB8AC3E}">
+        <p14:creationId xmlns:p14="http://schemas.microsoft.com/office/powerpoint/2010/main" val="3916906487"/>
       </p:ext>
     </p:extLst>
   </p:cSld>
@@ -24100,6 +24209,1045 @@
     <p:extLst>
       <p:ext uri="{BB962C8B-B14F-4D97-AF65-F5344CB8AC3E}">
         <p14:creationId xmlns:p14="http://schemas.microsoft.com/office/powerpoint/2010/main" val="1866045094"/>
+      </p:ext>
+    </p:extLst>
+  </p:cSld>
+  <p:clrMapOvr>
+    <a:masterClrMapping/>
+  </p:clrMapOvr>
+</p:sld>
+</file>
+
+<file path=ppt/slides/slide20.xml><?xml version="1.0" encoding="utf-8"?>
+<p:sld xmlns:a="http://schemas.openxmlformats.org/drawingml/2006/main" xmlns:r="http://schemas.openxmlformats.org/officeDocument/2006/relationships" xmlns:p="http://schemas.openxmlformats.org/presentationml/2006/main">
+  <p:cSld>
+    <p:spTree>
+      <p:nvGrpSpPr>
+        <p:cNvPr id="1" name="">
+          <a:extLst>
+            <a:ext uri="{FF2B5EF4-FFF2-40B4-BE49-F238E27FC236}">
+              <a16:creationId xmlns:a16="http://schemas.microsoft.com/office/drawing/2014/main" id="{C2831A88-F51D-EB8A-44AC-6EEA3A808C6A}"/>
+            </a:ext>
+          </a:extLst>
+        </p:cNvPr>
+        <p:cNvGrpSpPr/>
+        <p:nvPr/>
+      </p:nvGrpSpPr>
+      <p:grpSpPr>
+        <a:xfrm>
+          <a:off x="0" y="0"/>
+          <a:ext cx="0" cy="0"/>
+          <a:chOff x="0" y="0"/>
+          <a:chExt cx="0" cy="0"/>
+        </a:xfrm>
+      </p:grpSpPr>
+      <p:sp>
+        <p:nvSpPr>
+          <p:cNvPr id="3" name="Rectangle 1">
+            <a:extLst>
+              <a:ext uri="{FF2B5EF4-FFF2-40B4-BE49-F238E27FC236}">
+                <a16:creationId xmlns:a16="http://schemas.microsoft.com/office/drawing/2014/main" id="{9C077BF2-D4B1-544F-EAF9-E722DCB4F855}"/>
+              </a:ext>
+            </a:extLst>
+          </p:cNvPr>
+          <p:cNvSpPr>
+            <a:spLocks noChangeArrowheads="1"/>
+          </p:cNvSpPr>
+          <p:nvPr/>
+        </p:nvSpPr>
+        <p:spPr bwMode="auto">
+          <a:xfrm>
+            <a:off x="5288915" y="1477262"/>
+            <a:ext cx="9366245" cy="646331"/>
+          </a:xfrm>
+          <a:prstGeom prst="rect">
+            <a:avLst/>
+          </a:prstGeom>
+          <a:noFill/>
+          <a:ln>
+            <a:noFill/>
+          </a:ln>
+          <a:effectLst/>
+          <a:extLst>
+            <a:ext uri="{909E8E84-426E-40DD-AFC4-6F175D3DCCD1}">
+              <a14:hiddenFill xmlns:a14="http://schemas.microsoft.com/office/drawing/2010/main">
+                <a:solidFill>
+                  <a:schemeClr val="accent1"/>
+                </a:solidFill>
+              </a14:hiddenFill>
+            </a:ext>
+            <a:ext uri="{91240B29-F687-4F45-9708-019B960494DF}">
+              <a14:hiddenLine xmlns:a14="http://schemas.microsoft.com/office/drawing/2010/main" w="9525">
+                <a:solidFill>
+                  <a:schemeClr val="tx1"/>
+                </a:solidFill>
+                <a:miter lim="800000"/>
+                <a:headEnd/>
+                <a:tailEnd/>
+              </a14:hiddenLine>
+            </a:ext>
+            <a:ext uri="{AF507438-7753-43E0-B8FC-AC1667EBCBE1}">
+              <a14:hiddenEffects xmlns:a14="http://schemas.microsoft.com/office/drawing/2010/main">
+                <a:effectLst>
+                  <a:outerShdw dist="35921" dir="2700000" algn="ctr" rotWithShape="0">
+                    <a:schemeClr val="bg2"/>
+                  </a:outerShdw>
+                </a:effectLst>
+              </a14:hiddenEffects>
+            </a:ext>
+          </a:extLst>
+        </p:spPr>
+        <p:txBody>
+          <a:bodyPr vert="horz" wrap="square" lIns="91440" tIns="45720" rIns="91440" bIns="45720" numCol="1" anchor="ctr" anchorCtr="0" compatLnSpc="1">
+            <a:prstTxWarp prst="textNoShape">
+              <a:avLst/>
+            </a:prstTxWarp>
+            <a:spAutoFit/>
+          </a:bodyPr>
+          <a:lstStyle>
+            <a:lvl1pPr eaLnBrk="0" fontAlgn="base" hangingPunct="0">
+              <a:spcBef>
+                <a:spcPct val="0"/>
+              </a:spcBef>
+              <a:spcAft>
+                <a:spcPct val="0"/>
+              </a:spcAft>
+              <a:defRPr>
+                <a:solidFill>
+                  <a:schemeClr val="tx1"/>
+                </a:solidFill>
+                <a:latin typeface="Arial" panose="020B0604020202020204" pitchFamily="34" charset="0"/>
+              </a:defRPr>
+            </a:lvl1pPr>
+            <a:lvl2pPr eaLnBrk="0" fontAlgn="base" hangingPunct="0">
+              <a:spcBef>
+                <a:spcPct val="0"/>
+              </a:spcBef>
+              <a:spcAft>
+                <a:spcPct val="0"/>
+              </a:spcAft>
+              <a:defRPr>
+                <a:solidFill>
+                  <a:schemeClr val="tx1"/>
+                </a:solidFill>
+                <a:latin typeface="Arial" panose="020B0604020202020204" pitchFamily="34" charset="0"/>
+              </a:defRPr>
+            </a:lvl2pPr>
+            <a:lvl3pPr eaLnBrk="0" fontAlgn="base" hangingPunct="0">
+              <a:spcBef>
+                <a:spcPct val="0"/>
+              </a:spcBef>
+              <a:spcAft>
+                <a:spcPct val="0"/>
+              </a:spcAft>
+              <a:defRPr>
+                <a:solidFill>
+                  <a:schemeClr val="tx1"/>
+                </a:solidFill>
+                <a:latin typeface="Arial" panose="020B0604020202020204" pitchFamily="34" charset="0"/>
+              </a:defRPr>
+            </a:lvl3pPr>
+            <a:lvl4pPr eaLnBrk="0" fontAlgn="base" hangingPunct="0">
+              <a:spcBef>
+                <a:spcPct val="0"/>
+              </a:spcBef>
+              <a:spcAft>
+                <a:spcPct val="0"/>
+              </a:spcAft>
+              <a:defRPr>
+                <a:solidFill>
+                  <a:schemeClr val="tx1"/>
+                </a:solidFill>
+                <a:latin typeface="Arial" panose="020B0604020202020204" pitchFamily="34" charset="0"/>
+              </a:defRPr>
+            </a:lvl4pPr>
+            <a:lvl5pPr eaLnBrk="0" fontAlgn="base" hangingPunct="0">
+              <a:spcBef>
+                <a:spcPct val="0"/>
+              </a:spcBef>
+              <a:spcAft>
+                <a:spcPct val="0"/>
+              </a:spcAft>
+              <a:defRPr>
+                <a:solidFill>
+                  <a:schemeClr val="tx1"/>
+                </a:solidFill>
+                <a:latin typeface="Arial" panose="020B0604020202020204" pitchFamily="34" charset="0"/>
+              </a:defRPr>
+            </a:lvl5pPr>
+            <a:lvl6pPr eaLnBrk="0" fontAlgn="base" hangingPunct="0">
+              <a:spcBef>
+                <a:spcPct val="0"/>
+              </a:spcBef>
+              <a:spcAft>
+                <a:spcPct val="0"/>
+              </a:spcAft>
+              <a:defRPr>
+                <a:solidFill>
+                  <a:schemeClr val="tx1"/>
+                </a:solidFill>
+                <a:latin typeface="Arial" panose="020B0604020202020204" pitchFamily="34" charset="0"/>
+              </a:defRPr>
+            </a:lvl6pPr>
+            <a:lvl7pPr eaLnBrk="0" fontAlgn="base" hangingPunct="0">
+              <a:spcBef>
+                <a:spcPct val="0"/>
+              </a:spcBef>
+              <a:spcAft>
+                <a:spcPct val="0"/>
+              </a:spcAft>
+              <a:defRPr>
+                <a:solidFill>
+                  <a:schemeClr val="tx1"/>
+                </a:solidFill>
+                <a:latin typeface="Arial" panose="020B0604020202020204" pitchFamily="34" charset="0"/>
+              </a:defRPr>
+            </a:lvl7pPr>
+            <a:lvl8pPr eaLnBrk="0" fontAlgn="base" hangingPunct="0">
+              <a:spcBef>
+                <a:spcPct val="0"/>
+              </a:spcBef>
+              <a:spcAft>
+                <a:spcPct val="0"/>
+              </a:spcAft>
+              <a:defRPr>
+                <a:solidFill>
+                  <a:schemeClr val="tx1"/>
+                </a:solidFill>
+                <a:latin typeface="Arial" panose="020B0604020202020204" pitchFamily="34" charset="0"/>
+              </a:defRPr>
+            </a:lvl8pPr>
+            <a:lvl9pPr eaLnBrk="0" fontAlgn="base" hangingPunct="0">
+              <a:spcBef>
+                <a:spcPct val="0"/>
+              </a:spcBef>
+              <a:spcAft>
+                <a:spcPct val="0"/>
+              </a:spcAft>
+              <a:defRPr>
+                <a:solidFill>
+                  <a:schemeClr val="tx1"/>
+                </a:solidFill>
+                <a:latin typeface="Arial" panose="020B0604020202020204" pitchFamily="34" charset="0"/>
+              </a:defRPr>
+            </a:lvl9pPr>
+          </a:lstStyle>
+          <a:p>
+            <a:pPr marL="0" marR="0" lvl="0" indent="0" algn="l" defTabSz="914400" rtl="0" eaLnBrk="0" fontAlgn="base" latinLnBrk="0" hangingPunct="0">
+              <a:lnSpc>
+                <a:spcPct val="100000"/>
+              </a:lnSpc>
+              <a:spcBef>
+                <a:spcPct val="0"/>
+              </a:spcBef>
+              <a:spcAft>
+                <a:spcPct val="0"/>
+              </a:spcAft>
+              <a:buClrTx/>
+              <a:buSzTx/>
+              <a:buFontTx/>
+              <a:buNone/>
+              <a:tabLst/>
+            </a:pPr>
+            <a:r>
+              <a:rPr kumimoji="0" lang="es-ES" altLang="es-ES" sz="1800" b="0" i="0" u="none" strike="noStrike" cap="none" normalizeH="0" baseline="0">
+                <a:ln>
+                  <a:noFill/>
+                </a:ln>
+                <a:solidFill>
+                  <a:srgbClr val="000000"/>
+                </a:solidFill>
+                <a:effectLst/>
+                <a:latin typeface="Times New Roman" panose="02020603050405020304" pitchFamily="18" charset="0"/>
+                <a:cs typeface="Times New Roman" panose="02020603050405020304" pitchFamily="18" charset="0"/>
+              </a:rPr>
+              <a:t> </a:t>
+            </a:r>
+            <a:endParaRPr kumimoji="0" lang="es-ES" altLang="es-ES" sz="1800" b="0" i="0" u="none" strike="noStrike" cap="none" normalizeH="0" baseline="0">
+              <a:ln>
+                <a:noFill/>
+              </a:ln>
+              <a:solidFill>
+                <a:schemeClr val="tx1"/>
+              </a:solidFill>
+              <a:effectLst/>
+            </a:endParaRPr>
+          </a:p>
+          <a:p>
+            <a:pPr marL="0" marR="0" lvl="0" indent="0" algn="l" defTabSz="914400" rtl="0" eaLnBrk="0" fontAlgn="base" latinLnBrk="0" hangingPunct="0">
+              <a:lnSpc>
+                <a:spcPct val="100000"/>
+              </a:lnSpc>
+              <a:spcBef>
+                <a:spcPct val="0"/>
+              </a:spcBef>
+              <a:spcAft>
+                <a:spcPct val="0"/>
+              </a:spcAft>
+              <a:buClrTx/>
+              <a:buSzTx/>
+              <a:buFontTx/>
+              <a:buNone/>
+              <a:tabLst/>
+            </a:pPr>
+            <a:endParaRPr kumimoji="0" lang="es-ES" altLang="es-ES" sz="1800" b="0" i="0" u="none" strike="noStrike" cap="none" normalizeH="0" baseline="0">
+              <a:ln>
+                <a:noFill/>
+              </a:ln>
+              <a:solidFill>
+                <a:schemeClr val="tx1"/>
+              </a:solidFill>
+              <a:effectLst/>
+              <a:latin typeface="Arial" panose="020B0604020202020204" pitchFamily="34" charset="0"/>
+            </a:endParaRPr>
+          </a:p>
+        </p:txBody>
+      </p:sp>
+      <p:sp>
+        <p:nvSpPr>
+          <p:cNvPr id="2" name="Título 1">
+            <a:extLst>
+              <a:ext uri="{FF2B5EF4-FFF2-40B4-BE49-F238E27FC236}">
+                <a16:creationId xmlns:a16="http://schemas.microsoft.com/office/drawing/2014/main" id="{9F23DB8B-E40E-1440-4F43-D6E7E359BA62}"/>
+              </a:ext>
+            </a:extLst>
+          </p:cNvPr>
+          <p:cNvSpPr>
+            <a:spLocks noGrp="1"/>
+          </p:cNvSpPr>
+          <p:nvPr>
+            <p:ph type="title"/>
+          </p:nvPr>
+        </p:nvSpPr>
+        <p:spPr>
+          <a:xfrm>
+            <a:off x="0" y="0"/>
+            <a:ext cx="9690902" cy="804155"/>
+          </a:xfrm>
+          <a:solidFill>
+            <a:srgbClr val="218317"/>
+          </a:solidFill>
+        </p:spPr>
+        <p:txBody>
+          <a:bodyPr>
+            <a:normAutofit/>
+          </a:bodyPr>
+          <a:lstStyle/>
+          <a:p>
+            <a:r>
+              <a:rPr lang="es-ES" sz="3200" b="1" dirty="0">
+                <a:solidFill>
+                  <a:schemeClr val="bg1"/>
+                </a:solidFill>
+                <a:latin typeface="Helvetica" panose="020B0604020202020204" pitchFamily="34" charset="0"/>
+                <a:cs typeface="Helvetica" panose="020B0604020202020204" pitchFamily="34" charset="0"/>
+              </a:rPr>
+              <a:t>	</a:t>
+            </a:r>
+            <a:r>
+              <a:rPr lang="es-ES" sz="3200" b="1" dirty="0" err="1">
+                <a:solidFill>
+                  <a:schemeClr val="bg1"/>
+                </a:solidFill>
+                <a:latin typeface="Helvetica" panose="020B0604020202020204" pitchFamily="34" charset="0"/>
+                <a:cs typeface="Helvetica" panose="020B0604020202020204" pitchFamily="34" charset="0"/>
+              </a:rPr>
+              <a:t>Preliminary</a:t>
+            </a:r>
+            <a:r>
+              <a:rPr lang="es-ES" sz="3200" b="1" dirty="0">
+                <a:solidFill>
+                  <a:schemeClr val="bg1"/>
+                </a:solidFill>
+                <a:latin typeface="Helvetica" panose="020B0604020202020204" pitchFamily="34" charset="0"/>
+                <a:cs typeface="Helvetica" panose="020B0604020202020204" pitchFamily="34" charset="0"/>
+              </a:rPr>
+              <a:t> </a:t>
+            </a:r>
+            <a:r>
+              <a:rPr lang="es-ES" sz="3200" b="1" dirty="0" err="1">
+                <a:solidFill>
+                  <a:schemeClr val="bg1"/>
+                </a:solidFill>
+                <a:latin typeface="Helvetica" panose="020B0604020202020204" pitchFamily="34" charset="0"/>
+                <a:cs typeface="Helvetica" panose="020B0604020202020204" pitchFamily="34" charset="0"/>
+              </a:rPr>
+              <a:t>results</a:t>
+            </a:r>
+            <a:endParaRPr lang="es-ES" sz="3200" b="1" dirty="0">
+              <a:solidFill>
+                <a:schemeClr val="bg1"/>
+              </a:solidFill>
+              <a:latin typeface="Helvetica" panose="020B0604020202020204" pitchFamily="34" charset="0"/>
+              <a:cs typeface="Helvetica" panose="020B0604020202020204" pitchFamily="34" charset="0"/>
+            </a:endParaRPr>
+          </a:p>
+        </p:txBody>
+      </p:sp>
+      <p:sp>
+        <p:nvSpPr>
+          <p:cNvPr id="8" name="Título 1">
+            <a:extLst>
+              <a:ext uri="{FF2B5EF4-FFF2-40B4-BE49-F238E27FC236}">
+                <a16:creationId xmlns:a16="http://schemas.microsoft.com/office/drawing/2014/main" id="{07F2AF2A-89F0-8480-0028-952448512460}"/>
+              </a:ext>
+            </a:extLst>
+          </p:cNvPr>
+          <p:cNvSpPr txBox="1">
+            <a:spLocks/>
+          </p:cNvSpPr>
+          <p:nvPr/>
+        </p:nvSpPr>
+        <p:spPr>
+          <a:xfrm>
+            <a:off x="9690902" y="-1"/>
+            <a:ext cx="2501098" cy="804157"/>
+          </a:xfrm>
+          <a:prstGeom prst="rect">
+            <a:avLst/>
+          </a:prstGeom>
+          <a:solidFill>
+            <a:srgbClr val="218317"/>
+          </a:solidFill>
+        </p:spPr>
+        <p:txBody>
+          <a:bodyPr vert="horz" lIns="91440" tIns="45720" rIns="91440" bIns="45720" rtlCol="0" anchor="ctr">
+            <a:normAutofit/>
+          </a:bodyPr>
+          <a:lstStyle>
+            <a:lvl1pPr algn="l" defTabSz="914400" rtl="0" eaLnBrk="1" latinLnBrk="0" hangingPunct="1">
+              <a:lnSpc>
+                <a:spcPct val="90000"/>
+              </a:lnSpc>
+              <a:spcBef>
+                <a:spcPct val="0"/>
+              </a:spcBef>
+              <a:buNone/>
+              <a:defRPr sz="4400" kern="1200">
+                <a:solidFill>
+                  <a:schemeClr val="tx1"/>
+                </a:solidFill>
+                <a:latin typeface="+mj-lt"/>
+                <a:ea typeface="+mj-ea"/>
+                <a:cs typeface="+mj-cs"/>
+              </a:defRPr>
+            </a:lvl1pPr>
+          </a:lstStyle>
+          <a:p>
+            <a:pPr algn="r"/>
+            <a:r>
+              <a:rPr lang="es-ES" sz="2800" b="1" dirty="0">
+                <a:solidFill>
+                  <a:schemeClr val="accent6">
+                    <a:lumMod val="60000"/>
+                    <a:lumOff val="40000"/>
+                  </a:schemeClr>
+                </a:solidFill>
+                <a:latin typeface="Helvetica" panose="020B0604020202020204" pitchFamily="34" charset="0"/>
+                <a:cs typeface="Helvetica" panose="020B0604020202020204" pitchFamily="34" charset="0"/>
+              </a:rPr>
+              <a:t>M&amp;M </a:t>
+            </a:r>
+            <a:r>
+              <a:rPr lang="es-ES" sz="2800" b="1" dirty="0">
+                <a:solidFill>
+                  <a:srgbClr val="218317"/>
+                </a:solidFill>
+                <a:latin typeface="Helvetica" panose="020B0604020202020204" pitchFamily="34" charset="0"/>
+                <a:cs typeface="Helvetica" panose="020B0604020202020204" pitchFamily="34" charset="0"/>
+              </a:rPr>
+              <a:t>.</a:t>
+            </a:r>
+          </a:p>
+        </p:txBody>
+      </p:sp>
+      <p:sp>
+        <p:nvSpPr>
+          <p:cNvPr id="15" name="CuadroTexto 10">
+            <a:extLst>
+              <a:ext uri="{FF2B5EF4-FFF2-40B4-BE49-F238E27FC236}">
+                <a16:creationId xmlns:a16="http://schemas.microsoft.com/office/drawing/2014/main" id="{15067287-9DBC-9B34-CE2B-65B29960CD6A}"/>
+              </a:ext>
+            </a:extLst>
+          </p:cNvPr>
+          <p:cNvSpPr txBox="1"/>
+          <p:nvPr/>
+        </p:nvSpPr>
+        <p:spPr>
+          <a:xfrm>
+            <a:off x="1398120" y="4262378"/>
+            <a:ext cx="2956560" cy="2031325"/>
+          </a:xfrm>
+          <a:prstGeom prst="rect">
+            <a:avLst/>
+          </a:prstGeom>
+          <a:noFill/>
+        </p:spPr>
+        <p:txBody>
+          <a:bodyPr wrap="square" rtlCol="0">
+            <a:spAutoFit/>
+          </a:bodyPr>
+          <a:lstStyle>
+            <a:defPPr>
+              <a:defRPr lang="es-ES"/>
+            </a:defPPr>
+            <a:lvl1pPr marL="0" algn="l" defTabSz="914400" rtl="0" eaLnBrk="1" latinLnBrk="0" hangingPunct="1">
+              <a:defRPr sz="1800" kern="1200">
+                <a:solidFill>
+                  <a:schemeClr val="tx1"/>
+                </a:solidFill>
+                <a:latin typeface="+mn-lt"/>
+                <a:ea typeface="+mn-ea"/>
+                <a:cs typeface="+mn-cs"/>
+              </a:defRPr>
+            </a:lvl1pPr>
+            <a:lvl2pPr marL="457200" algn="l" defTabSz="914400" rtl="0" eaLnBrk="1" latinLnBrk="0" hangingPunct="1">
+              <a:defRPr sz="1800" kern="1200">
+                <a:solidFill>
+                  <a:schemeClr val="tx1"/>
+                </a:solidFill>
+                <a:latin typeface="+mn-lt"/>
+                <a:ea typeface="+mn-ea"/>
+                <a:cs typeface="+mn-cs"/>
+              </a:defRPr>
+            </a:lvl2pPr>
+            <a:lvl3pPr marL="914400" algn="l" defTabSz="914400" rtl="0" eaLnBrk="1" latinLnBrk="0" hangingPunct="1">
+              <a:defRPr sz="1800" kern="1200">
+                <a:solidFill>
+                  <a:schemeClr val="tx1"/>
+                </a:solidFill>
+                <a:latin typeface="+mn-lt"/>
+                <a:ea typeface="+mn-ea"/>
+                <a:cs typeface="+mn-cs"/>
+              </a:defRPr>
+            </a:lvl3pPr>
+            <a:lvl4pPr marL="1371600" algn="l" defTabSz="914400" rtl="0" eaLnBrk="1" latinLnBrk="0" hangingPunct="1">
+              <a:defRPr sz="1800" kern="1200">
+                <a:solidFill>
+                  <a:schemeClr val="tx1"/>
+                </a:solidFill>
+                <a:latin typeface="+mn-lt"/>
+                <a:ea typeface="+mn-ea"/>
+                <a:cs typeface="+mn-cs"/>
+              </a:defRPr>
+            </a:lvl4pPr>
+            <a:lvl5pPr marL="1828800" algn="l" defTabSz="914400" rtl="0" eaLnBrk="1" latinLnBrk="0" hangingPunct="1">
+              <a:defRPr sz="1800" kern="1200">
+                <a:solidFill>
+                  <a:schemeClr val="tx1"/>
+                </a:solidFill>
+                <a:latin typeface="+mn-lt"/>
+                <a:ea typeface="+mn-ea"/>
+                <a:cs typeface="+mn-cs"/>
+              </a:defRPr>
+            </a:lvl5pPr>
+            <a:lvl6pPr marL="2286000" algn="l" defTabSz="914400" rtl="0" eaLnBrk="1" latinLnBrk="0" hangingPunct="1">
+              <a:defRPr sz="1800" kern="1200">
+                <a:solidFill>
+                  <a:schemeClr val="tx1"/>
+                </a:solidFill>
+                <a:latin typeface="+mn-lt"/>
+                <a:ea typeface="+mn-ea"/>
+                <a:cs typeface="+mn-cs"/>
+              </a:defRPr>
+            </a:lvl6pPr>
+            <a:lvl7pPr marL="2743200" algn="l" defTabSz="914400" rtl="0" eaLnBrk="1" latinLnBrk="0" hangingPunct="1">
+              <a:defRPr sz="1800" kern="1200">
+                <a:solidFill>
+                  <a:schemeClr val="tx1"/>
+                </a:solidFill>
+                <a:latin typeface="+mn-lt"/>
+                <a:ea typeface="+mn-ea"/>
+                <a:cs typeface="+mn-cs"/>
+              </a:defRPr>
+            </a:lvl7pPr>
+            <a:lvl8pPr marL="3200400" algn="l" defTabSz="914400" rtl="0" eaLnBrk="1" latinLnBrk="0" hangingPunct="1">
+              <a:defRPr sz="1800" kern="1200">
+                <a:solidFill>
+                  <a:schemeClr val="tx1"/>
+                </a:solidFill>
+                <a:latin typeface="+mn-lt"/>
+                <a:ea typeface="+mn-ea"/>
+                <a:cs typeface="+mn-cs"/>
+              </a:defRPr>
+            </a:lvl8pPr>
+            <a:lvl9pPr marL="3657600" algn="l" defTabSz="914400" rtl="0" eaLnBrk="1" latinLnBrk="0" hangingPunct="1">
+              <a:defRPr sz="1800" kern="1200">
+                <a:solidFill>
+                  <a:schemeClr val="tx1"/>
+                </a:solidFill>
+                <a:latin typeface="+mn-lt"/>
+                <a:ea typeface="+mn-ea"/>
+                <a:cs typeface="+mn-cs"/>
+              </a:defRPr>
+            </a:lvl9pPr>
+          </a:lstStyle>
+          <a:p>
+            <a:pPr lvl="1" algn="ctr"/>
+            <a:r>
+              <a:rPr lang="es-ES" b="1" dirty="0" err="1">
+                <a:latin typeface="Helvetica" panose="020B0604020202020204" pitchFamily="34" charset="0"/>
+                <a:cs typeface="Helvetica" panose="020B0604020202020204" pitchFamily="34" charset="0"/>
+              </a:rPr>
+              <a:t>Growth</a:t>
+            </a:r>
+            <a:r>
+              <a:rPr lang="es-ES" b="1" dirty="0">
+                <a:latin typeface="Helvetica" panose="020B0604020202020204" pitchFamily="34" charset="0"/>
+                <a:cs typeface="Helvetica" panose="020B0604020202020204" pitchFamily="34" charset="0"/>
+              </a:rPr>
+              <a:t> </a:t>
+            </a:r>
+            <a:r>
+              <a:rPr lang="es-ES" b="1" dirty="0" err="1">
+                <a:latin typeface="Helvetica" panose="020B0604020202020204" pitchFamily="34" charset="0"/>
+                <a:cs typeface="Helvetica" panose="020B0604020202020204" pitchFamily="34" charset="0"/>
+              </a:rPr>
+              <a:t>rates</a:t>
+            </a:r>
+            <a:r>
+              <a:rPr lang="es-ES" dirty="0">
+                <a:latin typeface="Helvetica" panose="020B0604020202020204" pitchFamily="34" charset="0"/>
+                <a:cs typeface="Helvetica" panose="020B0604020202020204" pitchFamily="34" charset="0"/>
+              </a:rPr>
+              <a:t> are more intense in </a:t>
+            </a:r>
+            <a:r>
+              <a:rPr lang="es-ES" dirty="0" err="1">
+                <a:latin typeface="Helvetica" panose="020B0604020202020204" pitchFamily="34" charset="0"/>
+                <a:cs typeface="Helvetica" panose="020B0604020202020204" pitchFamily="34" charset="0"/>
+              </a:rPr>
+              <a:t>higher</a:t>
+            </a:r>
+            <a:r>
+              <a:rPr lang="es-ES" dirty="0">
+                <a:latin typeface="Helvetica" panose="020B0604020202020204" pitchFamily="34" charset="0"/>
+                <a:cs typeface="Helvetica" panose="020B0604020202020204" pitchFamily="34" charset="0"/>
+              </a:rPr>
+              <a:t> in </a:t>
+            </a:r>
+            <a:r>
+              <a:rPr lang="es-ES" dirty="0" err="1">
+                <a:latin typeface="Helvetica" panose="020B0604020202020204" pitchFamily="34" charset="0"/>
+                <a:cs typeface="Helvetica" panose="020B0604020202020204" pitchFamily="34" charset="0"/>
+              </a:rPr>
+              <a:t>declining</a:t>
+            </a:r>
+            <a:r>
+              <a:rPr lang="es-ES" dirty="0">
+                <a:latin typeface="Helvetica" panose="020B0604020202020204" pitchFamily="34" charset="0"/>
+                <a:cs typeface="Helvetica" panose="020B0604020202020204" pitchFamily="34" charset="0"/>
+              </a:rPr>
+              <a:t> sites. </a:t>
+            </a:r>
+            <a:r>
+              <a:rPr lang="es-ES" dirty="0" err="1">
+                <a:latin typeface="Helvetica" panose="020B0604020202020204" pitchFamily="34" charset="0"/>
+                <a:cs typeface="Helvetica" panose="020B0604020202020204" pitchFamily="34" charset="0"/>
+              </a:rPr>
+              <a:t>Trees</a:t>
+            </a:r>
+            <a:r>
+              <a:rPr lang="es-ES" dirty="0">
+                <a:latin typeface="Helvetica" panose="020B0604020202020204" pitchFamily="34" charset="0"/>
+                <a:cs typeface="Helvetica" panose="020B0604020202020204" pitchFamily="34" charset="0"/>
+              </a:rPr>
+              <a:t> </a:t>
+            </a:r>
+            <a:r>
+              <a:rPr lang="es-ES" dirty="0" err="1">
+                <a:latin typeface="Helvetica" panose="020B0604020202020204" pitchFamily="34" charset="0"/>
+                <a:cs typeface="Helvetica" panose="020B0604020202020204" pitchFamily="34" charset="0"/>
+              </a:rPr>
+              <a:t>with</a:t>
+            </a:r>
+            <a:r>
+              <a:rPr lang="es-ES" dirty="0">
+                <a:latin typeface="Helvetica" panose="020B0604020202020204" pitchFamily="34" charset="0"/>
+                <a:cs typeface="Helvetica" panose="020B0604020202020204" pitchFamily="34" charset="0"/>
+              </a:rPr>
+              <a:t> </a:t>
+            </a:r>
+            <a:r>
+              <a:rPr lang="es-ES" b="1" dirty="0" err="1">
+                <a:latin typeface="Helvetica" panose="020B0604020202020204" pitchFamily="34" charset="0"/>
+                <a:cs typeface="Helvetica" panose="020B0604020202020204" pitchFamily="34" charset="0"/>
+              </a:rPr>
+              <a:t>declining</a:t>
+            </a:r>
+            <a:r>
+              <a:rPr lang="es-ES" b="1" dirty="0">
+                <a:latin typeface="Helvetica" panose="020B0604020202020204" pitchFamily="34" charset="0"/>
+                <a:cs typeface="Helvetica" panose="020B0604020202020204" pitchFamily="34" charset="0"/>
+              </a:rPr>
+              <a:t> </a:t>
+            </a:r>
+            <a:r>
+              <a:rPr lang="es-ES" b="1" dirty="0" err="1">
+                <a:latin typeface="Helvetica" panose="020B0604020202020204" pitchFamily="34" charset="0"/>
+                <a:cs typeface="Helvetica" panose="020B0604020202020204" pitchFamily="34" charset="0"/>
+              </a:rPr>
+              <a:t>growth</a:t>
+            </a:r>
+            <a:r>
+              <a:rPr lang="es-ES" b="1" dirty="0">
+                <a:latin typeface="Helvetica" panose="020B0604020202020204" pitchFamily="34" charset="0"/>
+                <a:cs typeface="Helvetica" panose="020B0604020202020204" pitchFamily="34" charset="0"/>
+              </a:rPr>
+              <a:t> </a:t>
+            </a:r>
+            <a:r>
+              <a:rPr lang="es-ES" b="1" dirty="0" err="1">
+                <a:latin typeface="Helvetica" panose="020B0604020202020204" pitchFamily="34" charset="0"/>
+                <a:cs typeface="Helvetica" panose="020B0604020202020204" pitchFamily="34" charset="0"/>
+              </a:rPr>
+              <a:t>rates</a:t>
+            </a:r>
+            <a:r>
+              <a:rPr lang="es-ES" b="1" dirty="0">
+                <a:latin typeface="Helvetica" panose="020B0604020202020204" pitchFamily="34" charset="0"/>
+                <a:cs typeface="Helvetica" panose="020B0604020202020204" pitchFamily="34" charset="0"/>
+              </a:rPr>
+              <a:t> </a:t>
+            </a:r>
+            <a:r>
+              <a:rPr lang="es-ES" dirty="0">
+                <a:latin typeface="Helvetica" panose="020B0604020202020204" pitchFamily="34" charset="0"/>
+                <a:cs typeface="Helvetica" panose="020B0604020202020204" pitchFamily="34" charset="0"/>
+              </a:rPr>
+              <a:t>are more vulnerable </a:t>
+            </a:r>
+            <a:r>
+              <a:rPr lang="es-ES" dirty="0" err="1">
+                <a:latin typeface="Helvetica" panose="020B0604020202020204" pitchFamily="34" charset="0"/>
+                <a:cs typeface="Helvetica" panose="020B0604020202020204" pitchFamily="34" charset="0"/>
+              </a:rPr>
+              <a:t>to</a:t>
+            </a:r>
+            <a:r>
+              <a:rPr lang="es-ES" dirty="0">
+                <a:latin typeface="Helvetica" panose="020B0604020202020204" pitchFamily="34" charset="0"/>
+                <a:cs typeface="Helvetica" panose="020B0604020202020204" pitchFamily="34" charset="0"/>
+              </a:rPr>
+              <a:t> </a:t>
+            </a:r>
+            <a:r>
+              <a:rPr lang="es-ES" dirty="0" err="1">
+                <a:latin typeface="Helvetica" panose="020B0604020202020204" pitchFamily="34" charset="0"/>
+                <a:cs typeface="Helvetica" panose="020B0604020202020204" pitchFamily="34" charset="0"/>
+              </a:rPr>
+              <a:t>drought</a:t>
+            </a:r>
+            <a:endParaRPr lang="es-ES" dirty="0">
+              <a:latin typeface="Helvetica" panose="020B0604020202020204" pitchFamily="34" charset="0"/>
+              <a:cs typeface="Helvetica" panose="020B0604020202020204" pitchFamily="34" charset="0"/>
+            </a:endParaRPr>
+          </a:p>
+        </p:txBody>
+      </p:sp>
+      <p:sp>
+        <p:nvSpPr>
+          <p:cNvPr id="16" name="CuadroTexto 10">
+            <a:extLst>
+              <a:ext uri="{FF2B5EF4-FFF2-40B4-BE49-F238E27FC236}">
+                <a16:creationId xmlns:a16="http://schemas.microsoft.com/office/drawing/2014/main" id="{DA9B830B-9DDD-1B8A-F4D7-5B00A018A22A}"/>
+              </a:ext>
+            </a:extLst>
+          </p:cNvPr>
+          <p:cNvSpPr txBox="1"/>
+          <p:nvPr/>
+        </p:nvSpPr>
+        <p:spPr>
+          <a:xfrm>
+            <a:off x="8907625" y="1477261"/>
+            <a:ext cx="3060440" cy="1477328"/>
+          </a:xfrm>
+          <a:prstGeom prst="rect">
+            <a:avLst/>
+          </a:prstGeom>
+          <a:noFill/>
+        </p:spPr>
+        <p:txBody>
+          <a:bodyPr wrap="square" rtlCol="0">
+            <a:spAutoFit/>
+          </a:bodyPr>
+          <a:lstStyle>
+            <a:defPPr>
+              <a:defRPr lang="es-ES"/>
+            </a:defPPr>
+            <a:lvl1pPr marL="0" algn="l" defTabSz="914400" rtl="0" eaLnBrk="1" latinLnBrk="0" hangingPunct="1">
+              <a:defRPr sz="1800" kern="1200">
+                <a:solidFill>
+                  <a:schemeClr val="tx1"/>
+                </a:solidFill>
+                <a:latin typeface="+mn-lt"/>
+                <a:ea typeface="+mn-ea"/>
+                <a:cs typeface="+mn-cs"/>
+              </a:defRPr>
+            </a:lvl1pPr>
+            <a:lvl2pPr marL="457200" algn="l" defTabSz="914400" rtl="0" eaLnBrk="1" latinLnBrk="0" hangingPunct="1">
+              <a:defRPr sz="1800" kern="1200">
+                <a:solidFill>
+                  <a:schemeClr val="tx1"/>
+                </a:solidFill>
+                <a:latin typeface="+mn-lt"/>
+                <a:ea typeface="+mn-ea"/>
+                <a:cs typeface="+mn-cs"/>
+              </a:defRPr>
+            </a:lvl2pPr>
+            <a:lvl3pPr marL="914400" algn="l" defTabSz="914400" rtl="0" eaLnBrk="1" latinLnBrk="0" hangingPunct="1">
+              <a:defRPr sz="1800" kern="1200">
+                <a:solidFill>
+                  <a:schemeClr val="tx1"/>
+                </a:solidFill>
+                <a:latin typeface="+mn-lt"/>
+                <a:ea typeface="+mn-ea"/>
+                <a:cs typeface="+mn-cs"/>
+              </a:defRPr>
+            </a:lvl3pPr>
+            <a:lvl4pPr marL="1371600" algn="l" defTabSz="914400" rtl="0" eaLnBrk="1" latinLnBrk="0" hangingPunct="1">
+              <a:defRPr sz="1800" kern="1200">
+                <a:solidFill>
+                  <a:schemeClr val="tx1"/>
+                </a:solidFill>
+                <a:latin typeface="+mn-lt"/>
+                <a:ea typeface="+mn-ea"/>
+                <a:cs typeface="+mn-cs"/>
+              </a:defRPr>
+            </a:lvl4pPr>
+            <a:lvl5pPr marL="1828800" algn="l" defTabSz="914400" rtl="0" eaLnBrk="1" latinLnBrk="0" hangingPunct="1">
+              <a:defRPr sz="1800" kern="1200">
+                <a:solidFill>
+                  <a:schemeClr val="tx1"/>
+                </a:solidFill>
+                <a:latin typeface="+mn-lt"/>
+                <a:ea typeface="+mn-ea"/>
+                <a:cs typeface="+mn-cs"/>
+              </a:defRPr>
+            </a:lvl5pPr>
+            <a:lvl6pPr marL="2286000" algn="l" defTabSz="914400" rtl="0" eaLnBrk="1" latinLnBrk="0" hangingPunct="1">
+              <a:defRPr sz="1800" kern="1200">
+                <a:solidFill>
+                  <a:schemeClr val="tx1"/>
+                </a:solidFill>
+                <a:latin typeface="+mn-lt"/>
+                <a:ea typeface="+mn-ea"/>
+                <a:cs typeface="+mn-cs"/>
+              </a:defRPr>
+            </a:lvl6pPr>
+            <a:lvl7pPr marL="2743200" algn="l" defTabSz="914400" rtl="0" eaLnBrk="1" latinLnBrk="0" hangingPunct="1">
+              <a:defRPr sz="1800" kern="1200">
+                <a:solidFill>
+                  <a:schemeClr val="tx1"/>
+                </a:solidFill>
+                <a:latin typeface="+mn-lt"/>
+                <a:ea typeface="+mn-ea"/>
+                <a:cs typeface="+mn-cs"/>
+              </a:defRPr>
+            </a:lvl7pPr>
+            <a:lvl8pPr marL="3200400" algn="l" defTabSz="914400" rtl="0" eaLnBrk="1" latinLnBrk="0" hangingPunct="1">
+              <a:defRPr sz="1800" kern="1200">
+                <a:solidFill>
+                  <a:schemeClr val="tx1"/>
+                </a:solidFill>
+                <a:latin typeface="+mn-lt"/>
+                <a:ea typeface="+mn-ea"/>
+                <a:cs typeface="+mn-cs"/>
+              </a:defRPr>
+            </a:lvl8pPr>
+            <a:lvl9pPr marL="3657600" algn="l" defTabSz="914400" rtl="0" eaLnBrk="1" latinLnBrk="0" hangingPunct="1">
+              <a:defRPr sz="1800" kern="1200">
+                <a:solidFill>
+                  <a:schemeClr val="tx1"/>
+                </a:solidFill>
+                <a:latin typeface="+mn-lt"/>
+                <a:ea typeface="+mn-ea"/>
+                <a:cs typeface="+mn-cs"/>
+              </a:defRPr>
+            </a:lvl9pPr>
+          </a:lstStyle>
+          <a:p>
+            <a:pPr lvl="1" algn="ctr"/>
+            <a:r>
+              <a:rPr lang="es-ES" dirty="0" err="1">
+                <a:latin typeface="Helvetica" panose="020B0604020202020204" pitchFamily="34" charset="0"/>
+                <a:cs typeface="Helvetica" panose="020B0604020202020204" pitchFamily="34" charset="0"/>
+              </a:rPr>
+              <a:t>Resistance</a:t>
+            </a:r>
+            <a:r>
+              <a:rPr lang="es-ES" dirty="0">
+                <a:latin typeface="Helvetica" panose="020B0604020202020204" pitchFamily="34" charset="0"/>
+                <a:cs typeface="Helvetica" panose="020B0604020202020204" pitchFamily="34" charset="0"/>
+              </a:rPr>
+              <a:t> and </a:t>
+            </a:r>
+            <a:r>
+              <a:rPr lang="es-ES" dirty="0" err="1">
+                <a:latin typeface="Helvetica" panose="020B0604020202020204" pitchFamily="34" charset="0"/>
+                <a:cs typeface="Helvetica" panose="020B0604020202020204" pitchFamily="34" charset="0"/>
+              </a:rPr>
+              <a:t>Resilience</a:t>
+            </a:r>
+            <a:r>
+              <a:rPr lang="es-ES" dirty="0">
+                <a:latin typeface="Helvetica" panose="020B0604020202020204" pitchFamily="34" charset="0"/>
+                <a:cs typeface="Helvetica" panose="020B0604020202020204" pitchFamily="34" charset="0"/>
+              </a:rPr>
+              <a:t> </a:t>
+            </a:r>
+            <a:r>
+              <a:rPr lang="es-ES" dirty="0" err="1">
+                <a:latin typeface="Helvetica" panose="020B0604020202020204" pitchFamily="34" charset="0"/>
+                <a:cs typeface="Helvetica" panose="020B0604020202020204" pitchFamily="34" charset="0"/>
+              </a:rPr>
+              <a:t>values</a:t>
+            </a:r>
+            <a:r>
+              <a:rPr lang="es-ES" dirty="0">
+                <a:latin typeface="Helvetica" panose="020B0604020202020204" pitchFamily="34" charset="0"/>
+                <a:cs typeface="Helvetica" panose="020B0604020202020204" pitchFamily="34" charset="0"/>
+              </a:rPr>
+              <a:t> are </a:t>
+            </a:r>
+            <a:r>
+              <a:rPr lang="es-ES" dirty="0" err="1">
+                <a:latin typeface="Helvetica" panose="020B0604020202020204" pitchFamily="34" charset="0"/>
+                <a:cs typeface="Helvetica" panose="020B0604020202020204" pitchFamily="34" charset="0"/>
+              </a:rPr>
+              <a:t>different</a:t>
+            </a:r>
+            <a:r>
+              <a:rPr lang="es-ES" dirty="0">
+                <a:latin typeface="Helvetica" panose="020B0604020202020204" pitchFamily="34" charset="0"/>
+                <a:cs typeface="Helvetica" panose="020B0604020202020204" pitchFamily="34" charset="0"/>
+              </a:rPr>
+              <a:t> </a:t>
+            </a:r>
+            <a:r>
+              <a:rPr lang="es-ES" dirty="0" err="1">
+                <a:latin typeface="Helvetica" panose="020B0604020202020204" pitchFamily="34" charset="0"/>
+                <a:cs typeface="Helvetica" panose="020B0604020202020204" pitchFamily="34" charset="0"/>
+              </a:rPr>
+              <a:t>according</a:t>
+            </a:r>
+            <a:r>
+              <a:rPr lang="es-ES" dirty="0">
+                <a:latin typeface="Helvetica" panose="020B0604020202020204" pitchFamily="34" charset="0"/>
+                <a:cs typeface="Helvetica" panose="020B0604020202020204" pitchFamily="34" charset="0"/>
+              </a:rPr>
+              <a:t> </a:t>
+            </a:r>
+            <a:r>
+              <a:rPr lang="es-ES" dirty="0" err="1">
+                <a:latin typeface="Helvetica" panose="020B0604020202020204" pitchFamily="34" charset="0"/>
+                <a:cs typeface="Helvetica" panose="020B0604020202020204" pitchFamily="34" charset="0"/>
+              </a:rPr>
+              <a:t>to</a:t>
+            </a:r>
+            <a:r>
+              <a:rPr lang="es-ES" dirty="0">
+                <a:latin typeface="Helvetica" panose="020B0604020202020204" pitchFamily="34" charset="0"/>
+                <a:cs typeface="Helvetica" panose="020B0604020202020204" pitchFamily="34" charset="0"/>
+              </a:rPr>
+              <a:t> </a:t>
+            </a:r>
+            <a:r>
+              <a:rPr lang="es-ES" dirty="0" err="1">
+                <a:latin typeface="Helvetica" panose="020B0604020202020204" pitchFamily="34" charset="0"/>
+                <a:cs typeface="Helvetica" panose="020B0604020202020204" pitchFamily="34" charset="0"/>
+              </a:rPr>
+              <a:t>the</a:t>
+            </a:r>
+            <a:r>
+              <a:rPr lang="es-ES" dirty="0">
+                <a:latin typeface="Helvetica" panose="020B0604020202020204" pitchFamily="34" charset="0"/>
+                <a:cs typeface="Helvetica" panose="020B0604020202020204" pitchFamily="34" charset="0"/>
+              </a:rPr>
+              <a:t> </a:t>
+            </a:r>
+            <a:r>
+              <a:rPr lang="es-ES" dirty="0" err="1">
+                <a:latin typeface="Helvetica" panose="020B0604020202020204" pitchFamily="34" charset="0"/>
+                <a:cs typeface="Helvetica" panose="020B0604020202020204" pitchFamily="34" charset="0"/>
+              </a:rPr>
+              <a:t>year</a:t>
+            </a:r>
+            <a:r>
+              <a:rPr lang="es-ES" dirty="0">
+                <a:latin typeface="Helvetica" panose="020B0604020202020204" pitchFamily="34" charset="0"/>
+                <a:cs typeface="Helvetica" panose="020B0604020202020204" pitchFamily="34" charset="0"/>
+              </a:rPr>
+              <a:t> and </a:t>
+            </a:r>
+            <a:r>
+              <a:rPr lang="es-ES" dirty="0" err="1">
+                <a:latin typeface="Helvetica" panose="020B0604020202020204" pitchFamily="34" charset="0"/>
+                <a:cs typeface="Helvetica" panose="020B0604020202020204" pitchFamily="34" charset="0"/>
+              </a:rPr>
+              <a:t>the</a:t>
+            </a:r>
+            <a:r>
+              <a:rPr lang="es-ES" dirty="0">
+                <a:latin typeface="Helvetica" panose="020B0604020202020204" pitchFamily="34" charset="0"/>
+                <a:cs typeface="Helvetica" panose="020B0604020202020204" pitchFamily="34" charset="0"/>
+              </a:rPr>
+              <a:t> </a:t>
+            </a:r>
+            <a:r>
+              <a:rPr lang="es-ES" dirty="0" err="1">
+                <a:latin typeface="Helvetica" panose="020B0604020202020204" pitchFamily="34" charset="0"/>
+                <a:cs typeface="Helvetica" panose="020B0604020202020204" pitchFamily="34" charset="0"/>
+              </a:rPr>
+              <a:t>species</a:t>
+            </a:r>
+            <a:endParaRPr lang="es-ES" dirty="0">
+              <a:latin typeface="Helvetica" panose="020B0604020202020204" pitchFamily="34" charset="0"/>
+              <a:cs typeface="Helvetica" panose="020B0604020202020204" pitchFamily="34" charset="0"/>
+            </a:endParaRPr>
+          </a:p>
+        </p:txBody>
+      </p:sp>
+      <p:pic>
+        <p:nvPicPr>
+          <p:cNvPr id="5" name="Imagen 4">
+            <a:extLst>
+              <a:ext uri="{FF2B5EF4-FFF2-40B4-BE49-F238E27FC236}">
+                <a16:creationId xmlns:a16="http://schemas.microsoft.com/office/drawing/2014/main" id="{4CA2EDFE-0015-1D6B-CED3-06D71D4518E7}"/>
+              </a:ext>
+            </a:extLst>
+          </p:cNvPr>
+          <p:cNvPicPr>
+            <a:picLocks noChangeAspect="1"/>
+          </p:cNvPicPr>
+          <p:nvPr/>
+        </p:nvPicPr>
+        <p:blipFill>
+          <a:blip r:embed="rId3">
+            <a:extLst>
+              <a:ext uri="{28A0092B-C50C-407E-A947-70E740481C1C}">
+                <a14:useLocalDpi xmlns:a14="http://schemas.microsoft.com/office/drawing/2010/main" val="0"/>
+              </a:ext>
+            </a:extLst>
+          </a:blip>
+          <a:stretch>
+            <a:fillRect/>
+          </a:stretch>
+        </p:blipFill>
+        <p:spPr>
+          <a:xfrm>
+            <a:off x="938241" y="1096912"/>
+            <a:ext cx="4692269" cy="3127848"/>
+          </a:xfrm>
+          <a:prstGeom prst="rect">
+            <a:avLst/>
+          </a:prstGeom>
+        </p:spPr>
+      </p:pic>
+    </p:spTree>
+    <p:extLst>
+      <p:ext uri="{BB962C8B-B14F-4D97-AF65-F5344CB8AC3E}">
+        <p14:creationId xmlns:p14="http://schemas.microsoft.com/office/powerpoint/2010/main" val="1364544141"/>
       </p:ext>
     </p:extLst>
   </p:cSld>

</xml_diff>